<commit_message>
Correct LOA asset attribution to Claude
</commit_message>
<xml_diff>
--- a/outputs/rehearsals/issue-477-loa-final/loa-fictional-Growth-Blueprint-v2.pptx
+++ b/outputs/rehearsals/issue-477-loa-final/loa-fictional-Growth-Blueprint-v2.pptx
@@ -2,33 +2,33 @@
 <file path=ppt/presentation.xml><?xml version="1.0" encoding="utf-8"?>
 <p:presentation xmlns:p="http://schemas.openxmlformats.org/presentationml/2006/main">
   <p:sldMasterIdLst>
-    <p:sldMasterId xmlns:r="http://schemas.openxmlformats.org/officeDocument/2006/relationships" id="2147483648" r:id="Rbf154bdd63894c34"/>
+    <p:sldMasterId xmlns:r="http://schemas.openxmlformats.org/officeDocument/2006/relationships" id="2147483648" r:id="R826812ff84ba49d5"/>
   </p:sldMasterIdLst>
   <p:notesMasterIdLst>
-    <p:notesMasterId xmlns:r="http://schemas.openxmlformats.org/officeDocument/2006/relationships" r:id="Re26d50e037ef425f"/>
+    <p:notesMasterId xmlns:r="http://schemas.openxmlformats.org/officeDocument/2006/relationships" r:id="Ra0fa36917ca54401"/>
   </p:notesMasterIdLst>
   <p:sldIdLst>
-    <p:sldId xmlns:r="http://schemas.openxmlformats.org/officeDocument/2006/relationships" id="256" r:id="Rabe3ca3b98d94bd7"/>
-    <p:sldId xmlns:r="http://schemas.openxmlformats.org/officeDocument/2006/relationships" id="257" r:id="R568e3b111f0a46d3"/>
-    <p:sldId xmlns:r="http://schemas.openxmlformats.org/officeDocument/2006/relationships" id="258" r:id="R8ff726bc6aef4450"/>
-    <p:sldId xmlns:r="http://schemas.openxmlformats.org/officeDocument/2006/relationships" id="259" r:id="R6b98c8c8f7be4bd2"/>
-    <p:sldId xmlns:r="http://schemas.openxmlformats.org/officeDocument/2006/relationships" id="260" r:id="Rab8ef2f6fe5541d4"/>
-    <p:sldId xmlns:r="http://schemas.openxmlformats.org/officeDocument/2006/relationships" id="261" r:id="R8ee82ef9314a40d6"/>
-    <p:sldId xmlns:r="http://schemas.openxmlformats.org/officeDocument/2006/relationships" id="262" r:id="R1fc04db922104a3a"/>
-    <p:sldId xmlns:r="http://schemas.openxmlformats.org/officeDocument/2006/relationships" id="263" r:id="R95bdfbeb7ccc4061"/>
-    <p:sldId xmlns:r="http://schemas.openxmlformats.org/officeDocument/2006/relationships" id="264" r:id="R21a7c06c7dd944be"/>
-    <p:sldId xmlns:r="http://schemas.openxmlformats.org/officeDocument/2006/relationships" id="265" r:id="R59da63c2c6ab4119"/>
-    <p:sldId xmlns:r="http://schemas.openxmlformats.org/officeDocument/2006/relationships" id="266" r:id="R1d106f000bb84622"/>
-    <p:sldId xmlns:r="http://schemas.openxmlformats.org/officeDocument/2006/relationships" id="267" r:id="Rf9b7e75c315743c9"/>
-    <p:sldId xmlns:r="http://schemas.openxmlformats.org/officeDocument/2006/relationships" id="268" r:id="Re53946df6a6749c3"/>
-    <p:sldId xmlns:r="http://schemas.openxmlformats.org/officeDocument/2006/relationships" id="269" r:id="R2d16d34403af448c"/>
-    <p:sldId xmlns:r="http://schemas.openxmlformats.org/officeDocument/2006/relationships" id="270" r:id="R2eb32fc564554ff5"/>
-    <p:sldId xmlns:r="http://schemas.openxmlformats.org/officeDocument/2006/relationships" id="271" r:id="R7728e5877c5445ea"/>
-    <p:sldId xmlns:r="http://schemas.openxmlformats.org/officeDocument/2006/relationships" id="272" r:id="R5c05d0e761fb4c63"/>
-    <p:sldId xmlns:r="http://schemas.openxmlformats.org/officeDocument/2006/relationships" id="273" r:id="R06b2e861b2b54777"/>
-    <p:sldId xmlns:r="http://schemas.openxmlformats.org/officeDocument/2006/relationships" id="274" r:id="R8d5b906aa47a4b6f"/>
-    <p:sldId xmlns:r="http://schemas.openxmlformats.org/officeDocument/2006/relationships" id="275" r:id="Ra20c3ec4fb5545ab"/>
-    <p:sldId xmlns:r="http://schemas.openxmlformats.org/officeDocument/2006/relationships" id="276" r:id="Rd18e145778cd4248"/>
+    <p:sldId xmlns:r="http://schemas.openxmlformats.org/officeDocument/2006/relationships" id="256" r:id="Rc3d4bcbf038b435e"/>
+    <p:sldId xmlns:r="http://schemas.openxmlformats.org/officeDocument/2006/relationships" id="257" r:id="R392792085bac4489"/>
+    <p:sldId xmlns:r="http://schemas.openxmlformats.org/officeDocument/2006/relationships" id="258" r:id="R55af2d80bf704d92"/>
+    <p:sldId xmlns:r="http://schemas.openxmlformats.org/officeDocument/2006/relationships" id="259" r:id="Raec07efe1dc9406d"/>
+    <p:sldId xmlns:r="http://schemas.openxmlformats.org/officeDocument/2006/relationships" id="260" r:id="R0205d6b4924d4539"/>
+    <p:sldId xmlns:r="http://schemas.openxmlformats.org/officeDocument/2006/relationships" id="261" r:id="R8a432060c9144c9c"/>
+    <p:sldId xmlns:r="http://schemas.openxmlformats.org/officeDocument/2006/relationships" id="262" r:id="Rfbe2348408d04174"/>
+    <p:sldId xmlns:r="http://schemas.openxmlformats.org/officeDocument/2006/relationships" id="263" r:id="R8cd8e2ae587e40a4"/>
+    <p:sldId xmlns:r="http://schemas.openxmlformats.org/officeDocument/2006/relationships" id="264" r:id="Rbd98f863b9c64266"/>
+    <p:sldId xmlns:r="http://schemas.openxmlformats.org/officeDocument/2006/relationships" id="265" r:id="R700a2c4bc94d41ce"/>
+    <p:sldId xmlns:r="http://schemas.openxmlformats.org/officeDocument/2006/relationships" id="266" r:id="R62e0b9df6b644db6"/>
+    <p:sldId xmlns:r="http://schemas.openxmlformats.org/officeDocument/2006/relationships" id="267" r:id="R53e44549494d4e06"/>
+    <p:sldId xmlns:r="http://schemas.openxmlformats.org/officeDocument/2006/relationships" id="268" r:id="R4a2fa0b09b744cbe"/>
+    <p:sldId xmlns:r="http://schemas.openxmlformats.org/officeDocument/2006/relationships" id="269" r:id="Rd16e608a3b364059"/>
+    <p:sldId xmlns:r="http://schemas.openxmlformats.org/officeDocument/2006/relationships" id="270" r:id="R23173d04ca7347d0"/>
+    <p:sldId xmlns:r="http://schemas.openxmlformats.org/officeDocument/2006/relationships" id="271" r:id="R785f2819125d4206"/>
+    <p:sldId xmlns:r="http://schemas.openxmlformats.org/officeDocument/2006/relationships" id="272" r:id="Rb832d81436824263"/>
+    <p:sldId xmlns:r="http://schemas.openxmlformats.org/officeDocument/2006/relationships" id="273" r:id="Rcb8da4bdbdc34e4c"/>
+    <p:sldId xmlns:r="http://schemas.openxmlformats.org/officeDocument/2006/relationships" id="274" r:id="Rbc4fbb2e91664f3a"/>
+    <p:sldId xmlns:r="http://schemas.openxmlformats.org/officeDocument/2006/relationships" id="275" r:id="Rc0621833a4c94007"/>
+    <p:sldId xmlns:r="http://schemas.openxmlformats.org/officeDocument/2006/relationships" id="276" r:id="R34424130e68d4b8d"/>
   </p:sldIdLst>
   <p:sldSz cx="12192000" cy="6858000"/>
   <p:notesSz cx="6858000" cy="9144000"/>
@@ -572,7 +572,7 @@
           </a:p>
           <a:p xmlns:a="http://schemas.openxmlformats.org/drawingml/2006/main">
             <a:r>
-              <a:t>C2 [CREATIVE ILLUSTRATION]: Paul's existing LOA coral bottle hero and convenience-store film are reused as internal creative illustrations.</a:t>
+              <a:t>C2 [CREATIVE ILLUSTRATION]: Claude's existing LOA coral bottle hero and convenience-store film are reused as internal creative illustrations.</a:t>
             </a:r>
           </a:p>
           <a:p xmlns:a="http://schemas.openxmlformats.org/drawingml/2006/main">
@@ -657,7 +657,7 @@
           </a:p>
           <a:p xmlns:a="http://schemas.openxmlformats.org/drawingml/2006/main">
             <a:r>
-              <a:t>C2 [CREATIVE ILLUSTRATION]: Paul's existing LOA coral bottle hero and convenience-store film are reused as internal creative illustrations.</a:t>
+              <a:t>C2 [CREATIVE ILLUSTRATION]: Claude's existing LOA coral bottle hero and convenience-store film are reused as internal creative illustrations.</a:t>
             </a:r>
           </a:p>
           <a:p xmlns:a="http://schemas.openxmlformats.org/drawingml/2006/main">
@@ -772,7 +772,7 @@
           </a:p>
           <a:p xmlns:a="http://schemas.openxmlformats.org/drawingml/2006/main">
             <a:r>
-              <a:t>C2 [CREATIVE ILLUSTRATION]: Paul's existing LOA coral bottle hero and convenience-store film are reused as internal creative illustrations.</a:t>
+              <a:t>C2 [CREATIVE ILLUSTRATION]: Claude's existing LOA coral bottle hero and convenience-store film are reused as internal creative illustrations.</a:t>
             </a:r>
           </a:p>
           <a:p xmlns:a="http://schemas.openxmlformats.org/drawingml/2006/main">
@@ -897,7 +897,7 @@
           </a:p>
           <a:p xmlns:a="http://schemas.openxmlformats.org/drawingml/2006/main">
             <a:r>
-              <a:t>C2 [CREATIVE ILLUSTRATION]: Paul's existing LOA coral bottle hero and convenience-store film are reused as internal creative illustrations.</a:t>
+              <a:t>C2 [CREATIVE ILLUSTRATION]: Claude's existing LOA coral bottle hero and convenience-store film are reused as internal creative illustrations.</a:t>
             </a:r>
           </a:p>
           <a:p xmlns:a="http://schemas.openxmlformats.org/drawingml/2006/main">
@@ -997,7 +997,7 @@
           </a:p>
           <a:p xmlns:a="http://schemas.openxmlformats.org/drawingml/2006/main">
             <a:r>
-              <a:t>C2 [CREATIVE ILLUSTRATION]: Paul's existing LOA coral bottle hero and convenience-store film are reused as internal creative illustrations.</a:t>
+              <a:t>C2 [CREATIVE ILLUSTRATION]: Claude's existing LOA coral bottle hero and convenience-store film are reused as internal creative illustrations.</a:t>
             </a:r>
           </a:p>
           <a:p xmlns:a="http://schemas.openxmlformats.org/drawingml/2006/main">
@@ -1087,7 +1087,7 @@
           </a:p>
           <a:p xmlns:a="http://schemas.openxmlformats.org/drawingml/2006/main">
             <a:r>
-              <a:t>C2 [CREATIVE ILLUSTRATION]: Paul's existing LOA coral bottle hero and convenience-store film are reused as internal creative illustrations.</a:t>
+              <a:t>C2 [CREATIVE ILLUSTRATION]: Claude's existing LOA coral bottle hero and convenience-store film are reused as internal creative illustrations.</a:t>
             </a:r>
           </a:p>
           <a:p xmlns:a="http://schemas.openxmlformats.org/drawingml/2006/main">
@@ -1392,7 +1392,7 @@
           </a:p>
           <a:p xmlns:a="http://schemas.openxmlformats.org/drawingml/2006/main">
             <a:r>
-              <a:t>C2 [CREATIVE ILLUSTRATION]: Paul's existing LOA coral bottle hero and convenience-store film are reused as internal creative illustrations.</a:t>
+              <a:t>C2 [CREATIVE ILLUSTRATION]: Claude's existing LOA coral bottle hero and convenience-store film are reused as internal creative illustrations.</a:t>
             </a:r>
           </a:p>
           <a:p xmlns:a="http://schemas.openxmlformats.org/drawingml/2006/main">
@@ -1732,7 +1732,7 @@
           </a:p>
           <a:p xmlns:a="http://schemas.openxmlformats.org/drawingml/2006/main">
             <a:r>
-              <a:t>C2 [CREATIVE ILLUSTRATION]: Paul's existing LOA coral bottle hero and convenience-store film are reused as internal creative illustrations.</a:t>
+              <a:t>C2 [CREATIVE ILLUSTRATION]: Claude's existing LOA coral bottle hero and convenience-store film are reused as internal creative illustrations.</a:t>
             </a:r>
           </a:p>
           <a:p xmlns:a="http://schemas.openxmlformats.org/drawingml/2006/main">
@@ -1877,7 +1877,7 @@
           </a:p>
           <a:p xmlns:a="http://schemas.openxmlformats.org/drawingml/2006/main">
             <a:r>
-              <a:t>C2 [CREATIVE ILLUSTRATION]: Paul's existing LOA coral bottle hero and convenience-store film are reused as internal creative illustrations.</a:t>
+              <a:t>C2 [CREATIVE ILLUSTRATION]: Claude's existing LOA coral bottle hero and convenience-store film are reused as internal creative illustrations.</a:t>
             </a:r>
           </a:p>
           <a:p xmlns:a="http://schemas.openxmlformats.org/drawingml/2006/main">
@@ -2072,7 +2072,7 @@
           </a:p>
           <a:p xmlns:a="http://schemas.openxmlformats.org/drawingml/2006/main">
             <a:r>
-              <a:t>C2 [CREATIVE ILLUSTRATION]: Paul's existing LOA coral bottle hero and convenience-store film are reused as internal creative illustrations.</a:t>
+              <a:t>C2 [CREATIVE ILLUSTRATION]: Claude's existing LOA coral bottle hero and convenience-store film are reused as internal creative illustrations.</a:t>
             </a:r>
           </a:p>
           <a:p xmlns:a="http://schemas.openxmlformats.org/drawingml/2006/main">
@@ -2172,7 +2172,7 @@
           </a:p>
           <a:p xmlns:a="http://schemas.openxmlformats.org/drawingml/2006/main">
             <a:r>
-              <a:t>C2 [CREATIVE ILLUSTRATION]: Paul's existing LOA coral bottle hero and convenience-store film are reused as internal creative illustrations.</a:t>
+              <a:t>C2 [CREATIVE ILLUSTRATION]: Claude's existing LOA coral bottle hero and convenience-store film are reused as internal creative illustrations.</a:t>
             </a:r>
           </a:p>
           <a:p xmlns:a="http://schemas.openxmlformats.org/drawingml/2006/main">
@@ -2599,7 +2599,7 @@
           <p:cNvPr id="3" name="Title">
             <a:extLst xmlns:a="http://schemas.openxmlformats.org/drawingml/2006/main">
               <a:ext uri="{FF2B5EF4-FFF2-40B4-BE49-F238E27FC236}">
-                <a16:creationId xmlns:a16="http://schemas.microsoft.com/office/drawing/2014/main" id="{E7B38064-10DE-4BCA-AFE4-DB0E91B791BE}"/>
+                <a16:creationId xmlns:a16="http://schemas.microsoft.com/office/drawing/2014/main" id="{A2066E7F-8ED7-4919-93BF-9216A9697DE1}"/>
               </a:ext>
             </a:extLst>
           </p:cNvPr>
@@ -2756,7 +2756,7 @@
           <p:cNvPr id="2" name="Subtitle">
             <a:extLst xmlns:a="http://schemas.openxmlformats.org/drawingml/2006/main">
               <a:ext uri="{FF2B5EF4-FFF2-40B4-BE49-F238E27FC236}">
-                <a16:creationId xmlns:a16="http://schemas.microsoft.com/office/drawing/2014/main" id="{458D7A48-C0E3-457E-A357-A38E6C462AA6}"/>
+                <a16:creationId xmlns:a16="http://schemas.microsoft.com/office/drawing/2014/main" id="{D59D14C4-8A60-4567-B17E-A31145E5AB14}"/>
               </a:ext>
             </a:extLst>
           </p:cNvPr>
@@ -2930,7 +2930,7 @@
           <p:cNvPr id="2" name="Section title">
             <a:extLst xmlns:a="http://schemas.openxmlformats.org/drawingml/2006/main">
               <a:ext uri="{FF2B5EF4-FFF2-40B4-BE49-F238E27FC236}">
-                <a16:creationId xmlns:a16="http://schemas.microsoft.com/office/drawing/2014/main" id="{91961518-64CF-48FF-822D-C7FD31E40ED3}"/>
+                <a16:creationId xmlns:a16="http://schemas.microsoft.com/office/drawing/2014/main" id="{695128EF-2B14-4A2A-8D10-2FCF1E0A8CB2}"/>
               </a:ext>
             </a:extLst>
           </p:cNvPr>
@@ -3104,7 +3104,7 @@
           <p:cNvPr id="3" name="Title">
             <a:extLst xmlns:a="http://schemas.openxmlformats.org/drawingml/2006/main">
               <a:ext uri="{FF2B5EF4-FFF2-40B4-BE49-F238E27FC236}">
-                <a16:creationId xmlns:a16="http://schemas.microsoft.com/office/drawing/2014/main" id="{E8250C37-E28F-4F8B-AF6A-5BDAF615824C}"/>
+                <a16:creationId xmlns:a16="http://schemas.microsoft.com/office/drawing/2014/main" id="{2BD99AF5-E8FE-4DAA-B4D8-27F8F4C166DF}"/>
               </a:ext>
             </a:extLst>
           </p:cNvPr>
@@ -3261,7 +3261,7 @@
           <p:cNvPr id="2" name="Body">
             <a:extLst xmlns:a="http://schemas.openxmlformats.org/drawingml/2006/main">
               <a:ext uri="{FF2B5EF4-FFF2-40B4-BE49-F238E27FC236}">
-                <a16:creationId xmlns:a16="http://schemas.microsoft.com/office/drawing/2014/main" id="{0A3B845E-70DB-44F1-8906-B84980E8DBB4}"/>
+                <a16:creationId xmlns:a16="http://schemas.microsoft.com/office/drawing/2014/main" id="{5D189B05-EDDB-438E-A92F-D939C8E878C4}"/>
               </a:ext>
             </a:extLst>
           </p:cNvPr>
@@ -3435,7 +3435,7 @@
           <p:cNvPr id="4" name="Title">
             <a:extLst xmlns:a="http://schemas.openxmlformats.org/drawingml/2006/main">
               <a:ext uri="{FF2B5EF4-FFF2-40B4-BE49-F238E27FC236}">
-                <a16:creationId xmlns:a16="http://schemas.microsoft.com/office/drawing/2014/main" id="{52BB3254-8220-4AD2-B52F-A0890E018275}"/>
+                <a16:creationId xmlns:a16="http://schemas.microsoft.com/office/drawing/2014/main" id="{F3D69B22-117A-4F3B-BEA2-25CBA410ADBB}"/>
               </a:ext>
             </a:extLst>
           </p:cNvPr>
@@ -3592,7 +3592,7 @@
           <p:cNvPr id="2" name="Left column">
             <a:extLst xmlns:a="http://schemas.openxmlformats.org/drawingml/2006/main">
               <a:ext uri="{FF2B5EF4-FFF2-40B4-BE49-F238E27FC236}">
-                <a16:creationId xmlns:a16="http://schemas.microsoft.com/office/drawing/2014/main" id="{8E3277C8-437F-4A04-B2AC-ADB551909A82}"/>
+                <a16:creationId xmlns:a16="http://schemas.microsoft.com/office/drawing/2014/main" id="{673B855A-1B45-4110-BF5C-6CB94E5B1EA8}"/>
               </a:ext>
             </a:extLst>
           </p:cNvPr>
@@ -3749,7 +3749,7 @@
           <p:cNvPr id="3" name="Right column">
             <a:extLst xmlns:a="http://schemas.openxmlformats.org/drawingml/2006/main">
               <a:ext uri="{FF2B5EF4-FFF2-40B4-BE49-F238E27FC236}">
-                <a16:creationId xmlns:a16="http://schemas.microsoft.com/office/drawing/2014/main" id="{281DC95C-C3B7-49A0-8377-1727DAB663D4}"/>
+                <a16:creationId xmlns:a16="http://schemas.microsoft.com/office/drawing/2014/main" id="{BAA50079-C64D-44CF-A5CE-A2D762AE749D}"/>
               </a:ext>
             </a:extLst>
           </p:cNvPr>
@@ -3923,7 +3923,7 @@
           <p:cNvPr id="3" name="Title">
             <a:extLst xmlns:a="http://schemas.openxmlformats.org/drawingml/2006/main">
               <a:ext uri="{FF2B5EF4-FFF2-40B4-BE49-F238E27FC236}">
-                <a16:creationId xmlns:a16="http://schemas.microsoft.com/office/drawing/2014/main" id="{8DA934BB-182C-41A2-93F8-8CDCCB78328B}"/>
+                <a16:creationId xmlns:a16="http://schemas.microsoft.com/office/drawing/2014/main" id="{F0A8A8DF-B8B3-45C8-B7CF-700E478AAD7B}"/>
               </a:ext>
             </a:extLst>
           </p:cNvPr>
@@ -4080,7 +4080,7 @@
           <p:cNvPr id="2" name="Left column">
             <a:extLst xmlns:a="http://schemas.openxmlformats.org/drawingml/2006/main">
               <a:ext uri="{FF2B5EF4-FFF2-40B4-BE49-F238E27FC236}">
-                <a16:creationId xmlns:a16="http://schemas.microsoft.com/office/drawing/2014/main" id="{426D3B15-6B85-431B-8AC1-2A4EBE3C4599}"/>
+                <a16:creationId xmlns:a16="http://schemas.microsoft.com/office/drawing/2014/main" id="{BB9788F5-8C6E-4993-BE94-B8836196CA1F}"/>
               </a:ext>
             </a:extLst>
           </p:cNvPr>
@@ -4275,12 +4275,12 @@
   </p:cSld>
   <p:clrMap bg1="lt1" tx1="dk1" bg2="lt2" tx2="dk2" accent1="accent1" accent2="accent2" accent3="accent3" accent4="accent4" accent5="accent5" accent6="accent6" hlink="hlink" folHlink="folHlink"/>
   <p:sldLayoutIdLst>
-    <p:sldLayoutId xmlns:r="http://schemas.openxmlformats.org/officeDocument/2006/relationships" id="2147483649" r:id="R2dd55c66801d474a"/>
-    <p:sldLayoutId xmlns:r="http://schemas.openxmlformats.org/officeDocument/2006/relationships" id="2147483650" r:id="R11e1f0aa917746ce"/>
-    <p:sldLayoutId xmlns:r="http://schemas.openxmlformats.org/officeDocument/2006/relationships" id="2147483651" r:id="R56ed924455f64ac7"/>
-    <p:sldLayoutId xmlns:r="http://schemas.openxmlformats.org/officeDocument/2006/relationships" id="2147483652" r:id="R4e8688fdb2384b79"/>
-    <p:sldLayoutId xmlns:r="http://schemas.openxmlformats.org/officeDocument/2006/relationships" id="2147483653" r:id="Rd4fae47ef6184bd5"/>
-    <p:sldLayoutId xmlns:r="http://schemas.openxmlformats.org/officeDocument/2006/relationships" id="2147483654" r:id="Re7fcb0a92c3f436f"/>
+    <p:sldLayoutId xmlns:r="http://schemas.openxmlformats.org/officeDocument/2006/relationships" id="2147483649" r:id="R74ecae8f14904ea2"/>
+    <p:sldLayoutId xmlns:r="http://schemas.openxmlformats.org/officeDocument/2006/relationships" id="2147483650" r:id="R889aa4720ebe46c4"/>
+    <p:sldLayoutId xmlns:r="http://schemas.openxmlformats.org/officeDocument/2006/relationships" id="2147483651" r:id="Rb503b021966547fc"/>
+    <p:sldLayoutId xmlns:r="http://schemas.openxmlformats.org/officeDocument/2006/relationships" id="2147483652" r:id="R29985a33ee964a31"/>
+    <p:sldLayoutId xmlns:r="http://schemas.openxmlformats.org/officeDocument/2006/relationships" id="2147483653" r:id="R02b7a25bb6fd4050"/>
+    <p:sldLayoutId xmlns:r="http://schemas.openxmlformats.org/officeDocument/2006/relationships" id="2147483654" r:id="Rc98474f496894f94"/>
   </p:sldLayoutIdLst>
   <p:txStyles>
     <p:titleStyle>
@@ -4831,7 +4831,7 @@
           <p:cNvPr id="9" name="">
             <a:extLst xmlns:a="http://schemas.openxmlformats.org/drawingml/2006/main">
               <a:ext uri="{FF2B5EF4-FFF2-40B4-BE49-F238E27FC236}">
-                <a16:creationId xmlns:a16="http://schemas.microsoft.com/office/drawing/2014/main" id="{92F2286D-96C6-4730-B76D-26A0C1D96AEC}"/>
+                <a16:creationId xmlns:a16="http://schemas.microsoft.com/office/drawing/2014/main" id="{346538D1-3451-41EE-96FF-2D6A0FCD2A98}"/>
               </a:ext>
             </a:extLst>
           </p:cNvPr>
@@ -4867,7 +4867,7 @@
           <p:cNvPr id="2" name="">
             <a:extLst xmlns:a="http://schemas.openxmlformats.org/drawingml/2006/main">
               <a:ext uri="{FF2B5EF4-FFF2-40B4-BE49-F238E27FC236}">
-                <a16:creationId xmlns:a16="http://schemas.microsoft.com/office/drawing/2014/main" id="{F623A997-0718-4208-854B-281D5EB593FA}"/>
+                <a16:creationId xmlns:a16="http://schemas.microsoft.com/office/drawing/2014/main" id="{A712F949-2FD4-44A4-9DA7-31A28A1E2417}"/>
               </a:ext>
             </a:extLst>
           </p:cNvPr>
@@ -4899,7 +4899,7 @@
           <p:cNvPr id="3" name="">
             <a:extLst xmlns:a="http://schemas.openxmlformats.org/drawingml/2006/main">
               <a:ext uri="{FF2B5EF4-FFF2-40B4-BE49-F238E27FC236}">
-                <a16:creationId xmlns:a16="http://schemas.microsoft.com/office/drawing/2014/main" id="{3A50C2EF-F341-4286-9134-6142C8C2B452}"/>
+                <a16:creationId xmlns:a16="http://schemas.microsoft.com/office/drawing/2014/main" id="{6EE4E155-A975-4098-808F-3B846C777903}"/>
               </a:ext>
             </a:extLst>
           </p:cNvPr>
@@ -4965,7 +4965,7 @@
           <p:cNvPr id="4" name="">
             <a:extLst xmlns:a="http://schemas.openxmlformats.org/drawingml/2006/main">
               <a:ext uri="{FF2B5EF4-FFF2-40B4-BE49-F238E27FC236}">
-                <a16:creationId xmlns:a16="http://schemas.microsoft.com/office/drawing/2014/main" id="{94EB3518-A151-47F7-9566-7AEC8B722FD6}"/>
+                <a16:creationId xmlns:a16="http://schemas.microsoft.com/office/drawing/2014/main" id="{7C164C20-6C15-438A-AC06-A8E5C1C60BBD}"/>
               </a:ext>
             </a:extLst>
           </p:cNvPr>
@@ -5031,7 +5031,7 @@
           <p:cNvPr id="5" name="">
             <a:extLst xmlns:a="http://schemas.openxmlformats.org/drawingml/2006/main">
               <a:ext uri="{FF2B5EF4-FFF2-40B4-BE49-F238E27FC236}">
-                <a16:creationId xmlns:a16="http://schemas.microsoft.com/office/drawing/2014/main" id="{D6116D32-AAA5-44B0-97E3-2E01981A1163}"/>
+                <a16:creationId xmlns:a16="http://schemas.microsoft.com/office/drawing/2014/main" id="{D83CCC81-9A36-4E77-AC70-8CCD2E7D8796}"/>
               </a:ext>
             </a:extLst>
           </p:cNvPr>
@@ -5097,7 +5097,7 @@
           <p:cNvPr id="6" name="">
             <a:extLst xmlns:a="http://schemas.openxmlformats.org/drawingml/2006/main">
               <a:ext uri="{FF2B5EF4-FFF2-40B4-BE49-F238E27FC236}">
-                <a16:creationId xmlns:a16="http://schemas.microsoft.com/office/drawing/2014/main" id="{05D98D09-E4F8-4761-AB2A-0583E6C758F3}"/>
+                <a16:creationId xmlns:a16="http://schemas.microsoft.com/office/drawing/2014/main" id="{FD17B11A-BB84-4AFD-A277-B55B1E592832}"/>
               </a:ext>
             </a:extLst>
           </p:cNvPr>
@@ -5163,7 +5163,7 @@
           <p:cNvPr id="7" name="">
             <a:extLst xmlns:a="http://schemas.openxmlformats.org/drawingml/2006/main">
               <a:ext uri="{FF2B5EF4-FFF2-40B4-BE49-F238E27FC236}">
-                <a16:creationId xmlns:a16="http://schemas.microsoft.com/office/drawing/2014/main" id="{451E2F11-E2A2-4305-8D2B-026453469B88}"/>
+                <a16:creationId xmlns:a16="http://schemas.microsoft.com/office/drawing/2014/main" id="{896905CD-7C7D-42E8-81FA-B54C2BD74446}"/>
               </a:ext>
             </a:extLst>
           </p:cNvPr>
@@ -5229,7 +5229,7 @@
           <p:cNvPr id="8" name="">
             <a:extLst xmlns:a="http://schemas.openxmlformats.org/drawingml/2006/main">
               <a:ext uri="{FF2B5EF4-FFF2-40B4-BE49-F238E27FC236}">
-                <a16:creationId xmlns:a16="http://schemas.microsoft.com/office/drawing/2014/main" id="{732969AC-B1FF-47F4-A0D0-C1407A3040AF}"/>
+                <a16:creationId xmlns:a16="http://schemas.microsoft.com/office/drawing/2014/main" id="{2DEC78CC-9AC5-493A-9445-9C02596C4212}"/>
               </a:ext>
             </a:extLst>
           </p:cNvPr>
@@ -5293,7 +5293,7 @@
     </p:spTree>
     <p:extLst>
       <p:ext uri="{BB962C8B-B14F-4D97-AF65-F5344CB8AC3E}">
-        <p14:creationId xmlns:p14="http://schemas.microsoft.com/office/powerpoint/2010/main" val="964250551"/>
+        <p14:creationId xmlns:p14="http://schemas.microsoft.com/office/powerpoint/2010/main" val="449828936"/>
       </p:ext>
     </p:extLst>
   </p:cSld>
@@ -5324,7 +5324,7 @@
           <p:cNvPr id="25" name="">
             <a:extLst xmlns:a="http://schemas.openxmlformats.org/drawingml/2006/main">
               <a:ext uri="{FF2B5EF4-FFF2-40B4-BE49-F238E27FC236}">
-                <a16:creationId xmlns:a16="http://schemas.microsoft.com/office/drawing/2014/main" id="{6DBF5CAF-0BCE-4D36-816B-FEBC80A32A36}"/>
+                <a16:creationId xmlns:a16="http://schemas.microsoft.com/office/drawing/2014/main" id="{CD4DE38E-D867-40FE-8542-E955081228B7}"/>
               </a:ext>
             </a:extLst>
           </p:cNvPr>
@@ -5390,7 +5390,7 @@
           <p:cNvPr id="2" name="">
             <a:extLst xmlns:a="http://schemas.openxmlformats.org/drawingml/2006/main">
               <a:ext uri="{FF2B5EF4-FFF2-40B4-BE49-F238E27FC236}">
-                <a16:creationId xmlns:a16="http://schemas.microsoft.com/office/drawing/2014/main" id="{B826B6E5-D864-42A8-B3D2-091F2B21B955}"/>
+                <a16:creationId xmlns:a16="http://schemas.microsoft.com/office/drawing/2014/main" id="{D3827ACD-2D1E-429E-BF2E-299F1CD489C6}"/>
               </a:ext>
             </a:extLst>
           </p:cNvPr>
@@ -5456,7 +5456,7 @@
           <p:cNvPr id="3" name="">
             <a:extLst xmlns:a="http://schemas.openxmlformats.org/drawingml/2006/main">
               <a:ext uri="{FF2B5EF4-FFF2-40B4-BE49-F238E27FC236}">
-                <a16:creationId xmlns:a16="http://schemas.microsoft.com/office/drawing/2014/main" id="{2A926CC0-700F-4065-B9D0-D71B340B1062}"/>
+                <a16:creationId xmlns:a16="http://schemas.microsoft.com/office/drawing/2014/main" id="{67A415BF-5D0C-4BEA-A67F-8DC9F4589D04}"/>
               </a:ext>
             </a:extLst>
           </p:cNvPr>
@@ -5488,7 +5488,7 @@
           <p:cNvPr id="4" name="">
             <a:extLst xmlns:a="http://schemas.openxmlformats.org/drawingml/2006/main">
               <a:ext uri="{FF2B5EF4-FFF2-40B4-BE49-F238E27FC236}">
-                <a16:creationId xmlns:a16="http://schemas.microsoft.com/office/drawing/2014/main" id="{4562B29E-7F93-4638-92FE-3FE923C7F5D2}"/>
+                <a16:creationId xmlns:a16="http://schemas.microsoft.com/office/drawing/2014/main" id="{AD363EA2-919A-40DB-803A-678AD42717A0}"/>
               </a:ext>
             </a:extLst>
           </p:cNvPr>
@@ -5522,7 +5522,7 @@
           <p:cNvPr id="5" name="">
             <a:extLst xmlns:a="http://schemas.openxmlformats.org/drawingml/2006/main">
               <a:ext uri="{FF2B5EF4-FFF2-40B4-BE49-F238E27FC236}">
-                <a16:creationId xmlns:a16="http://schemas.microsoft.com/office/drawing/2014/main" id="{A01B1E1B-5E95-486C-B679-BD90F4418586}"/>
+                <a16:creationId xmlns:a16="http://schemas.microsoft.com/office/drawing/2014/main" id="{C65E2CE6-AD12-4679-9F8E-7B2D5D7C59BB}"/>
               </a:ext>
             </a:extLst>
           </p:cNvPr>
@@ -5554,7 +5554,7 @@
           <p:cNvPr id="6" name="">
             <a:extLst xmlns:a="http://schemas.openxmlformats.org/drawingml/2006/main">
               <a:ext uri="{FF2B5EF4-FFF2-40B4-BE49-F238E27FC236}">
-                <a16:creationId xmlns:a16="http://schemas.microsoft.com/office/drawing/2014/main" id="{2D0C25C9-06B2-4EFA-B7DC-42C9D1575484}"/>
+                <a16:creationId xmlns:a16="http://schemas.microsoft.com/office/drawing/2014/main" id="{08C6EFCE-761F-427B-A60D-D0729B005E1B}"/>
               </a:ext>
             </a:extLst>
           </p:cNvPr>
@@ -5586,7 +5586,7 @@
           <p:cNvPr id="7" name="">
             <a:extLst xmlns:a="http://schemas.openxmlformats.org/drawingml/2006/main">
               <a:ext uri="{FF2B5EF4-FFF2-40B4-BE49-F238E27FC236}">
-                <a16:creationId xmlns:a16="http://schemas.microsoft.com/office/drawing/2014/main" id="{0FAF4697-612F-4D93-B01B-448839C843F7}"/>
+                <a16:creationId xmlns:a16="http://schemas.microsoft.com/office/drawing/2014/main" id="{B9CE02D0-E53F-43D4-9F3E-8033D9E20457}"/>
               </a:ext>
             </a:extLst>
           </p:cNvPr>
@@ -5652,7 +5652,7 @@
           <p:cNvPr id="8" name="">
             <a:extLst xmlns:a="http://schemas.openxmlformats.org/drawingml/2006/main">
               <a:ext uri="{FF2B5EF4-FFF2-40B4-BE49-F238E27FC236}">
-                <a16:creationId xmlns:a16="http://schemas.microsoft.com/office/drawing/2014/main" id="{CAE5EAF3-2D33-4BEF-A5D6-F98E33B56910}"/>
+                <a16:creationId xmlns:a16="http://schemas.microsoft.com/office/drawing/2014/main" id="{0EFD80ED-206A-4A1A-8FDB-772536B1177E}"/>
               </a:ext>
             </a:extLst>
           </p:cNvPr>
@@ -5718,7 +5718,7 @@
           <p:cNvPr id="9" name="">
             <a:extLst xmlns:a="http://schemas.openxmlformats.org/drawingml/2006/main">
               <a:ext uri="{FF2B5EF4-FFF2-40B4-BE49-F238E27FC236}">
-                <a16:creationId xmlns:a16="http://schemas.microsoft.com/office/drawing/2014/main" id="{97B1A974-1F66-4E57-91AA-B8890EBA4D79}"/>
+                <a16:creationId xmlns:a16="http://schemas.microsoft.com/office/drawing/2014/main" id="{FC1DF4BB-0CE5-4EC9-A33E-1431FD35D5A0}"/>
               </a:ext>
             </a:extLst>
           </p:cNvPr>
@@ -5784,7 +5784,7 @@
           <p:cNvPr id="10" name="">
             <a:extLst xmlns:a="http://schemas.openxmlformats.org/drawingml/2006/main">
               <a:ext uri="{FF2B5EF4-FFF2-40B4-BE49-F238E27FC236}">
-                <a16:creationId xmlns:a16="http://schemas.microsoft.com/office/drawing/2014/main" id="{D8152C97-9EC2-4E60-A630-D48B8A6513DC}"/>
+                <a16:creationId xmlns:a16="http://schemas.microsoft.com/office/drawing/2014/main" id="{03C6503F-52E1-4593-96F3-D693C295BD1D}"/>
               </a:ext>
             </a:extLst>
           </p:cNvPr>
@@ -5816,7 +5816,7 @@
           <p:cNvPr id="11" name="">
             <a:extLst xmlns:a="http://schemas.openxmlformats.org/drawingml/2006/main">
               <a:ext uri="{FF2B5EF4-FFF2-40B4-BE49-F238E27FC236}">
-                <a16:creationId xmlns:a16="http://schemas.microsoft.com/office/drawing/2014/main" id="{B6F820EB-77E1-4EDC-B442-756B0812F1D2}"/>
+                <a16:creationId xmlns:a16="http://schemas.microsoft.com/office/drawing/2014/main" id="{58C52F01-B426-4AD6-BB9E-1BF167342554}"/>
               </a:ext>
             </a:extLst>
           </p:cNvPr>
@@ -5882,7 +5882,7 @@
           <p:cNvPr id="12" name="">
             <a:extLst xmlns:a="http://schemas.openxmlformats.org/drawingml/2006/main">
               <a:ext uri="{FF2B5EF4-FFF2-40B4-BE49-F238E27FC236}">
-                <a16:creationId xmlns:a16="http://schemas.microsoft.com/office/drawing/2014/main" id="{94302064-14BF-483D-9D83-AE510F6C928E}"/>
+                <a16:creationId xmlns:a16="http://schemas.microsoft.com/office/drawing/2014/main" id="{C7993098-5391-482D-A97E-68758867C376}"/>
               </a:ext>
             </a:extLst>
           </p:cNvPr>
@@ -5916,7 +5916,7 @@
           <p:cNvPr id="13" name="">
             <a:extLst xmlns:a="http://schemas.openxmlformats.org/drawingml/2006/main">
               <a:ext uri="{FF2B5EF4-FFF2-40B4-BE49-F238E27FC236}">
-                <a16:creationId xmlns:a16="http://schemas.microsoft.com/office/drawing/2014/main" id="{0D86245F-345F-4DF8-8A33-248406098D80}"/>
+                <a16:creationId xmlns:a16="http://schemas.microsoft.com/office/drawing/2014/main" id="{5F50B08A-D298-4EF0-9A82-50FAA60B9723}"/>
               </a:ext>
             </a:extLst>
           </p:cNvPr>
@@ -5982,7 +5982,7 @@
           <p:cNvPr id="14" name="">
             <a:extLst xmlns:a="http://schemas.openxmlformats.org/drawingml/2006/main">
               <a:ext uri="{FF2B5EF4-FFF2-40B4-BE49-F238E27FC236}">
-                <a16:creationId xmlns:a16="http://schemas.microsoft.com/office/drawing/2014/main" id="{54EA0BAA-0AF4-451D-8FAB-478A828A38EF}"/>
+                <a16:creationId xmlns:a16="http://schemas.microsoft.com/office/drawing/2014/main" id="{6E94DBA0-C0B4-489D-93B2-4F82FEDEFE8C}"/>
               </a:ext>
             </a:extLst>
           </p:cNvPr>
@@ -6048,7 +6048,7 @@
           <p:cNvPr id="15" name="">
             <a:extLst xmlns:a="http://schemas.openxmlformats.org/drawingml/2006/main">
               <a:ext uri="{FF2B5EF4-FFF2-40B4-BE49-F238E27FC236}">
-                <a16:creationId xmlns:a16="http://schemas.microsoft.com/office/drawing/2014/main" id="{54152CE4-8356-486E-A22A-0C76FAD3320B}"/>
+                <a16:creationId xmlns:a16="http://schemas.microsoft.com/office/drawing/2014/main" id="{C757041E-2A6A-49B0-9E4D-06F91A5A10B2}"/>
               </a:ext>
             </a:extLst>
           </p:cNvPr>
@@ -6114,7 +6114,7 @@
           <p:cNvPr id="16" name="">
             <a:extLst xmlns:a="http://schemas.openxmlformats.org/drawingml/2006/main">
               <a:ext uri="{FF2B5EF4-FFF2-40B4-BE49-F238E27FC236}">
-                <a16:creationId xmlns:a16="http://schemas.microsoft.com/office/drawing/2014/main" id="{5AFCC2AE-9C8F-40F7-98FA-1B7CD4C4693C}"/>
+                <a16:creationId xmlns:a16="http://schemas.microsoft.com/office/drawing/2014/main" id="{942A7BF6-A7CE-4A1B-B55E-E215AA6D3BE2}"/>
               </a:ext>
             </a:extLst>
           </p:cNvPr>
@@ -6180,7 +6180,7 @@
           <p:cNvPr id="17" name="">
             <a:extLst xmlns:a="http://schemas.openxmlformats.org/drawingml/2006/main">
               <a:ext uri="{FF2B5EF4-FFF2-40B4-BE49-F238E27FC236}">
-                <a16:creationId xmlns:a16="http://schemas.microsoft.com/office/drawing/2014/main" id="{BFFBA59A-E634-470E-8B98-BE1A6FDBBCEB}"/>
+                <a16:creationId xmlns:a16="http://schemas.microsoft.com/office/drawing/2014/main" id="{5E86A177-EC4F-4ED1-AD2A-94B9D18F06CE}"/>
               </a:ext>
             </a:extLst>
           </p:cNvPr>
@@ -6246,7 +6246,7 @@
           <p:cNvPr id="18" name="">
             <a:extLst xmlns:a="http://schemas.openxmlformats.org/drawingml/2006/main">
               <a:ext uri="{FF2B5EF4-FFF2-40B4-BE49-F238E27FC236}">
-                <a16:creationId xmlns:a16="http://schemas.microsoft.com/office/drawing/2014/main" id="{D7BFDDBA-F1D8-4B7E-86D2-87CAFF940844}"/>
+                <a16:creationId xmlns:a16="http://schemas.microsoft.com/office/drawing/2014/main" id="{7E6FD31C-3A98-442A-A9C2-584657AEA3D3}"/>
               </a:ext>
             </a:extLst>
           </p:cNvPr>
@@ -6312,7 +6312,7 @@
           <p:cNvPr id="19" name="">
             <a:extLst xmlns:a="http://schemas.openxmlformats.org/drawingml/2006/main">
               <a:ext uri="{FF2B5EF4-FFF2-40B4-BE49-F238E27FC236}">
-                <a16:creationId xmlns:a16="http://schemas.microsoft.com/office/drawing/2014/main" id="{6C3CE355-3ABB-461E-87C1-E69DF9C97B4C}"/>
+                <a16:creationId xmlns:a16="http://schemas.microsoft.com/office/drawing/2014/main" id="{00C22413-75E9-4BDA-BA80-BEA0664B3657}"/>
               </a:ext>
             </a:extLst>
           </p:cNvPr>
@@ -6378,7 +6378,7 @@
           <p:cNvPr id="20" name="">
             <a:extLst xmlns:a="http://schemas.openxmlformats.org/drawingml/2006/main">
               <a:ext uri="{FF2B5EF4-FFF2-40B4-BE49-F238E27FC236}">
-                <a16:creationId xmlns:a16="http://schemas.microsoft.com/office/drawing/2014/main" id="{1A1CD09A-0DD9-406F-89D3-7B226569DCE0}"/>
+                <a16:creationId xmlns:a16="http://schemas.microsoft.com/office/drawing/2014/main" id="{22E47CC6-AAC4-42F4-8873-42371517651D}"/>
               </a:ext>
             </a:extLst>
           </p:cNvPr>
@@ -6444,7 +6444,7 @@
           <p:cNvPr id="21" name="">
             <a:extLst xmlns:a="http://schemas.openxmlformats.org/drawingml/2006/main">
               <a:ext uri="{FF2B5EF4-FFF2-40B4-BE49-F238E27FC236}">
-                <a16:creationId xmlns:a16="http://schemas.microsoft.com/office/drawing/2014/main" id="{6F88AD1C-A306-4B0B-82D0-A29DBFDA67DF}"/>
+                <a16:creationId xmlns:a16="http://schemas.microsoft.com/office/drawing/2014/main" id="{A5043D9A-DF67-4378-A696-AE5D0656AF3B}"/>
               </a:ext>
             </a:extLst>
           </p:cNvPr>
@@ -6510,7 +6510,7 @@
           <p:cNvPr id="22" name="">
             <a:extLst xmlns:a="http://schemas.openxmlformats.org/drawingml/2006/main">
               <a:ext uri="{FF2B5EF4-FFF2-40B4-BE49-F238E27FC236}">
-                <a16:creationId xmlns:a16="http://schemas.microsoft.com/office/drawing/2014/main" id="{D8F81C65-833C-4158-9E1B-0EF55F282FCF}"/>
+                <a16:creationId xmlns:a16="http://schemas.microsoft.com/office/drawing/2014/main" id="{D7D744DD-D219-44D6-A110-57A3617AC2FF}"/>
               </a:ext>
             </a:extLst>
           </p:cNvPr>
@@ -6576,7 +6576,7 @@
           <p:cNvPr id="23" name="">
             <a:extLst xmlns:a="http://schemas.openxmlformats.org/drawingml/2006/main">
               <a:ext uri="{FF2B5EF4-FFF2-40B4-BE49-F238E27FC236}">
-                <a16:creationId xmlns:a16="http://schemas.microsoft.com/office/drawing/2014/main" id="{3A868F19-C190-4974-9711-5B6DC45B745E}"/>
+                <a16:creationId xmlns:a16="http://schemas.microsoft.com/office/drawing/2014/main" id="{84AF0C7D-4EF0-4095-99BE-73180BF5B8C0}"/>
               </a:ext>
             </a:extLst>
           </p:cNvPr>
@@ -6642,7 +6642,7 @@
           <p:cNvPr id="24" name="">
             <a:extLst xmlns:a="http://schemas.openxmlformats.org/drawingml/2006/main">
               <a:ext uri="{FF2B5EF4-FFF2-40B4-BE49-F238E27FC236}">
-                <a16:creationId xmlns:a16="http://schemas.microsoft.com/office/drawing/2014/main" id="{6B3681B7-E45B-45D3-9673-5713A35F60DD}"/>
+                <a16:creationId xmlns:a16="http://schemas.microsoft.com/office/drawing/2014/main" id="{28F1945A-6074-4345-A345-7A0E94A232D8}"/>
               </a:ext>
             </a:extLst>
           </p:cNvPr>
@@ -6706,7 +6706,7 @@
     </p:spTree>
     <p:extLst>
       <p:ext uri="{BB962C8B-B14F-4D97-AF65-F5344CB8AC3E}">
-        <p14:creationId xmlns:p14="http://schemas.microsoft.com/office/powerpoint/2010/main" val="117315261"/>
+        <p14:creationId xmlns:p14="http://schemas.microsoft.com/office/powerpoint/2010/main" val="2053226776"/>
       </p:ext>
     </p:extLst>
   </p:cSld>
@@ -6737,7 +6737,7 @@
           <p:cNvPr id="26" name="">
             <a:extLst xmlns:a="http://schemas.openxmlformats.org/drawingml/2006/main">
               <a:ext uri="{FF2B5EF4-FFF2-40B4-BE49-F238E27FC236}">
-                <a16:creationId xmlns:a16="http://schemas.microsoft.com/office/drawing/2014/main" id="{3540321C-38F4-4663-96D5-D5C1A6E23232}"/>
+                <a16:creationId xmlns:a16="http://schemas.microsoft.com/office/drawing/2014/main" id="{3ADBDFD9-12C6-4A67-BE12-4F15C33794C7}"/>
               </a:ext>
             </a:extLst>
           </p:cNvPr>
@@ -6803,7 +6803,7 @@
           <p:cNvPr id="2" name="">
             <a:extLst xmlns:a="http://schemas.openxmlformats.org/drawingml/2006/main">
               <a:ext uri="{FF2B5EF4-FFF2-40B4-BE49-F238E27FC236}">
-                <a16:creationId xmlns:a16="http://schemas.microsoft.com/office/drawing/2014/main" id="{03B39508-DD47-44A8-8699-616292BE55D9}"/>
+                <a16:creationId xmlns:a16="http://schemas.microsoft.com/office/drawing/2014/main" id="{443B8A10-5E67-46E8-B0DB-8C004A3D5D41}"/>
               </a:ext>
             </a:extLst>
           </p:cNvPr>
@@ -6869,7 +6869,7 @@
           <p:cNvPr id="3" name="">
             <a:extLst xmlns:a="http://schemas.openxmlformats.org/drawingml/2006/main">
               <a:ext uri="{FF2B5EF4-FFF2-40B4-BE49-F238E27FC236}">
-                <a16:creationId xmlns:a16="http://schemas.microsoft.com/office/drawing/2014/main" id="{17AC1BB7-FFE5-4766-8EE1-0CF6FE61EB76}"/>
+                <a16:creationId xmlns:a16="http://schemas.microsoft.com/office/drawing/2014/main" id="{81C21F19-949E-43EC-BCD8-77A5F7C7DA11}"/>
               </a:ext>
             </a:extLst>
           </p:cNvPr>
@@ -6901,7 +6901,7 @@
           <p:cNvPr id="4" name="">
             <a:extLst xmlns:a="http://schemas.openxmlformats.org/drawingml/2006/main">
               <a:ext uri="{FF2B5EF4-FFF2-40B4-BE49-F238E27FC236}">
-                <a16:creationId xmlns:a16="http://schemas.microsoft.com/office/drawing/2014/main" id="{4E720C0A-8D9B-48B3-B10A-DE9822C30191}"/>
+                <a16:creationId xmlns:a16="http://schemas.microsoft.com/office/drawing/2014/main" id="{1BF888B3-3384-4C45-ADCA-0CF0FCBB20DD}"/>
               </a:ext>
             </a:extLst>
           </p:cNvPr>
@@ -6935,7 +6935,7 @@
           <p:cNvPr id="5" name="">
             <a:extLst xmlns:a="http://schemas.openxmlformats.org/drawingml/2006/main">
               <a:ext uri="{FF2B5EF4-FFF2-40B4-BE49-F238E27FC236}">
-                <a16:creationId xmlns:a16="http://schemas.microsoft.com/office/drawing/2014/main" id="{DC94F029-FCD6-4DDD-8B57-C9288617C2BD}"/>
+                <a16:creationId xmlns:a16="http://schemas.microsoft.com/office/drawing/2014/main" id="{5F39FFF1-4445-4720-A5BF-31FEB06501E8}"/>
               </a:ext>
             </a:extLst>
           </p:cNvPr>
@@ -7001,7 +7001,7 @@
           <p:cNvPr id="6" name="">
             <a:extLst xmlns:a="http://schemas.openxmlformats.org/drawingml/2006/main">
               <a:ext uri="{FF2B5EF4-FFF2-40B4-BE49-F238E27FC236}">
-                <a16:creationId xmlns:a16="http://schemas.microsoft.com/office/drawing/2014/main" id="{8744C49D-E148-49F0-B684-C00EB28B101C}"/>
+                <a16:creationId xmlns:a16="http://schemas.microsoft.com/office/drawing/2014/main" id="{689D28E8-F031-4620-BA03-E19B5B6492F4}"/>
               </a:ext>
             </a:extLst>
           </p:cNvPr>
@@ -7067,7 +7067,7 @@
           <p:cNvPr id="7" name="">
             <a:extLst xmlns:a="http://schemas.openxmlformats.org/drawingml/2006/main">
               <a:ext uri="{FF2B5EF4-FFF2-40B4-BE49-F238E27FC236}">
-                <a16:creationId xmlns:a16="http://schemas.microsoft.com/office/drawing/2014/main" id="{06DECA99-A4F6-44BA-9CCE-B32F178BCB3C}"/>
+                <a16:creationId xmlns:a16="http://schemas.microsoft.com/office/drawing/2014/main" id="{41697287-8EA2-479B-BF68-F8D3DEEF4D0B}"/>
               </a:ext>
             </a:extLst>
           </p:cNvPr>
@@ -7133,7 +7133,7 @@
           <p:cNvPr id="8" name="">
             <a:extLst xmlns:a="http://schemas.openxmlformats.org/drawingml/2006/main">
               <a:ext uri="{FF2B5EF4-FFF2-40B4-BE49-F238E27FC236}">
-                <a16:creationId xmlns:a16="http://schemas.microsoft.com/office/drawing/2014/main" id="{D011D84C-CD45-4B8A-92A2-31B922C485F8}"/>
+                <a16:creationId xmlns:a16="http://schemas.microsoft.com/office/drawing/2014/main" id="{01839A60-BEC4-4E72-8902-D41ACCCA645A}"/>
               </a:ext>
             </a:extLst>
           </p:cNvPr>
@@ -7199,7 +7199,7 @@
           <p:cNvPr id="9" name="">
             <a:extLst xmlns:a="http://schemas.openxmlformats.org/drawingml/2006/main">
               <a:ext uri="{FF2B5EF4-FFF2-40B4-BE49-F238E27FC236}">
-                <a16:creationId xmlns:a16="http://schemas.microsoft.com/office/drawing/2014/main" id="{69ABE1C5-2576-4FCD-98AF-82C8C86BF21D}"/>
+                <a16:creationId xmlns:a16="http://schemas.microsoft.com/office/drawing/2014/main" id="{7D99C8CB-D907-4CFB-B7A8-D7CF099524AC}"/>
               </a:ext>
             </a:extLst>
           </p:cNvPr>
@@ -7265,7 +7265,7 @@
           <p:cNvPr id="10" name="">
             <a:extLst xmlns:a="http://schemas.openxmlformats.org/drawingml/2006/main">
               <a:ext uri="{FF2B5EF4-FFF2-40B4-BE49-F238E27FC236}">
-                <a16:creationId xmlns:a16="http://schemas.microsoft.com/office/drawing/2014/main" id="{BF8CE66D-E01E-43B7-B6D4-E8A372D9E11E}"/>
+                <a16:creationId xmlns:a16="http://schemas.microsoft.com/office/drawing/2014/main" id="{DFA6BFB2-9154-49AC-9CF8-D27A5595F777}"/>
               </a:ext>
             </a:extLst>
           </p:cNvPr>
@@ -7299,7 +7299,7 @@
           <p:cNvPr id="11" name="">
             <a:extLst xmlns:a="http://schemas.openxmlformats.org/drawingml/2006/main">
               <a:ext uri="{FF2B5EF4-FFF2-40B4-BE49-F238E27FC236}">
-                <a16:creationId xmlns:a16="http://schemas.microsoft.com/office/drawing/2014/main" id="{CC0B6694-E9C9-4474-A2E2-95B054DF4F11}"/>
+                <a16:creationId xmlns:a16="http://schemas.microsoft.com/office/drawing/2014/main" id="{52680BF8-C8B8-4DFF-8718-8AD36A651768}"/>
               </a:ext>
             </a:extLst>
           </p:cNvPr>
@@ -7365,7 +7365,7 @@
           <p:cNvPr id="12" name="">
             <a:extLst xmlns:a="http://schemas.openxmlformats.org/drawingml/2006/main">
               <a:ext uri="{FF2B5EF4-FFF2-40B4-BE49-F238E27FC236}">
-                <a16:creationId xmlns:a16="http://schemas.microsoft.com/office/drawing/2014/main" id="{2B90EC83-64DD-4A16-AB33-1AD96F0880F7}"/>
+                <a16:creationId xmlns:a16="http://schemas.microsoft.com/office/drawing/2014/main" id="{268191DA-17F4-4E44-B93B-F4F2B6E993E1}"/>
               </a:ext>
             </a:extLst>
           </p:cNvPr>
@@ -7431,7 +7431,7 @@
           <p:cNvPr id="13" name="">
             <a:extLst xmlns:a="http://schemas.openxmlformats.org/drawingml/2006/main">
               <a:ext uri="{FF2B5EF4-FFF2-40B4-BE49-F238E27FC236}">
-                <a16:creationId xmlns:a16="http://schemas.microsoft.com/office/drawing/2014/main" id="{8D0C6A52-4CA6-4725-BD05-6B34AC1D3BC1}"/>
+                <a16:creationId xmlns:a16="http://schemas.microsoft.com/office/drawing/2014/main" id="{85E3D563-CFA7-43E1-8D0C-B546D1DB619B}"/>
               </a:ext>
             </a:extLst>
           </p:cNvPr>
@@ -7465,7 +7465,7 @@
           <p:cNvPr id="14" name="">
             <a:extLst xmlns:a="http://schemas.openxmlformats.org/drawingml/2006/main">
               <a:ext uri="{FF2B5EF4-FFF2-40B4-BE49-F238E27FC236}">
-                <a16:creationId xmlns:a16="http://schemas.microsoft.com/office/drawing/2014/main" id="{37451263-5631-49CC-92F4-ED5B4ABC76DB}"/>
+                <a16:creationId xmlns:a16="http://schemas.microsoft.com/office/drawing/2014/main" id="{1B342C9A-2F94-4716-9EFB-8E65224AE9C2}"/>
               </a:ext>
             </a:extLst>
           </p:cNvPr>
@@ -7531,7 +7531,7 @@
           <p:cNvPr id="15" name="">
             <a:extLst xmlns:a="http://schemas.openxmlformats.org/drawingml/2006/main">
               <a:ext uri="{FF2B5EF4-FFF2-40B4-BE49-F238E27FC236}">
-                <a16:creationId xmlns:a16="http://schemas.microsoft.com/office/drawing/2014/main" id="{F0C847ED-010E-43E5-A03A-4D20038CE777}"/>
+                <a16:creationId xmlns:a16="http://schemas.microsoft.com/office/drawing/2014/main" id="{DCFF5051-C3B9-4C63-8A92-00E984F088D2}"/>
               </a:ext>
             </a:extLst>
           </p:cNvPr>
@@ -7597,7 +7597,7 @@
           <p:cNvPr id="16" name="">
             <a:extLst xmlns:a="http://schemas.openxmlformats.org/drawingml/2006/main">
               <a:ext uri="{FF2B5EF4-FFF2-40B4-BE49-F238E27FC236}">
-                <a16:creationId xmlns:a16="http://schemas.microsoft.com/office/drawing/2014/main" id="{4EB3CBB5-1288-4268-91EF-2BD90717715F}"/>
+                <a16:creationId xmlns:a16="http://schemas.microsoft.com/office/drawing/2014/main" id="{9FC7A999-1CCD-40D5-91E0-B2774923D277}"/>
               </a:ext>
             </a:extLst>
           </p:cNvPr>
@@ -7631,7 +7631,7 @@
           <p:cNvPr id="17" name="">
             <a:extLst xmlns:a="http://schemas.openxmlformats.org/drawingml/2006/main">
               <a:ext uri="{FF2B5EF4-FFF2-40B4-BE49-F238E27FC236}">
-                <a16:creationId xmlns:a16="http://schemas.microsoft.com/office/drawing/2014/main" id="{CA5DBD96-4AE4-491D-8BAD-9E1F005DCC8F}"/>
+                <a16:creationId xmlns:a16="http://schemas.microsoft.com/office/drawing/2014/main" id="{72E01CF4-66E8-48EF-BE61-A525DB602FD0}"/>
               </a:ext>
             </a:extLst>
           </p:cNvPr>
@@ -7697,7 +7697,7 @@
           <p:cNvPr id="18" name="">
             <a:extLst xmlns:a="http://schemas.openxmlformats.org/drawingml/2006/main">
               <a:ext uri="{FF2B5EF4-FFF2-40B4-BE49-F238E27FC236}">
-                <a16:creationId xmlns:a16="http://schemas.microsoft.com/office/drawing/2014/main" id="{F05FC918-F5AC-4B97-B67B-8D8A512233E0}"/>
+                <a16:creationId xmlns:a16="http://schemas.microsoft.com/office/drawing/2014/main" id="{647598E9-03A3-4083-9B99-A57EE68A01A0}"/>
               </a:ext>
             </a:extLst>
           </p:cNvPr>
@@ -7763,7 +7763,7 @@
           <p:cNvPr id="19" name="">
             <a:extLst xmlns:a="http://schemas.openxmlformats.org/drawingml/2006/main">
               <a:ext uri="{FF2B5EF4-FFF2-40B4-BE49-F238E27FC236}">
-                <a16:creationId xmlns:a16="http://schemas.microsoft.com/office/drawing/2014/main" id="{7BC459E2-7882-4957-9DCA-D015268C5154}"/>
+                <a16:creationId xmlns:a16="http://schemas.microsoft.com/office/drawing/2014/main" id="{1589BCB4-0337-42A5-9EA9-A6CF37A88138}"/>
               </a:ext>
             </a:extLst>
           </p:cNvPr>
@@ -7829,7 +7829,7 @@
           <p:cNvPr id="20" name="">
             <a:extLst xmlns:a="http://schemas.openxmlformats.org/drawingml/2006/main">
               <a:ext uri="{FF2B5EF4-FFF2-40B4-BE49-F238E27FC236}">
-                <a16:creationId xmlns:a16="http://schemas.microsoft.com/office/drawing/2014/main" id="{08B94FE4-006B-4FF6-8C0E-4F463F1461B9}"/>
+                <a16:creationId xmlns:a16="http://schemas.microsoft.com/office/drawing/2014/main" id="{E1DEE12B-879B-4C04-AD16-83E682FADDD8}"/>
               </a:ext>
             </a:extLst>
           </p:cNvPr>
@@ -7895,7 +7895,7 @@
           <p:cNvPr id="21" name="">
             <a:extLst xmlns:a="http://schemas.openxmlformats.org/drawingml/2006/main">
               <a:ext uri="{FF2B5EF4-FFF2-40B4-BE49-F238E27FC236}">
-                <a16:creationId xmlns:a16="http://schemas.microsoft.com/office/drawing/2014/main" id="{C27E977F-0D14-461B-AC51-CCFBA7CE87AD}"/>
+                <a16:creationId xmlns:a16="http://schemas.microsoft.com/office/drawing/2014/main" id="{AE8C9C88-0BEB-4E60-8D67-0F2959BBF043}"/>
               </a:ext>
             </a:extLst>
           </p:cNvPr>
@@ -7961,7 +7961,7 @@
           <p:cNvPr id="22" name="">
             <a:extLst xmlns:a="http://schemas.openxmlformats.org/drawingml/2006/main">
               <a:ext uri="{FF2B5EF4-FFF2-40B4-BE49-F238E27FC236}">
-                <a16:creationId xmlns:a16="http://schemas.microsoft.com/office/drawing/2014/main" id="{41CB5E55-CA3C-41AE-BCA3-F1509DDA8CDA}"/>
+                <a16:creationId xmlns:a16="http://schemas.microsoft.com/office/drawing/2014/main" id="{FAC8B4C9-B36F-4771-93F8-563E58350A39}"/>
               </a:ext>
             </a:extLst>
           </p:cNvPr>
@@ -8027,7 +8027,7 @@
           <p:cNvPr id="23" name="">
             <a:extLst xmlns:a="http://schemas.openxmlformats.org/drawingml/2006/main">
               <a:ext uri="{FF2B5EF4-FFF2-40B4-BE49-F238E27FC236}">
-                <a16:creationId xmlns:a16="http://schemas.microsoft.com/office/drawing/2014/main" id="{2DFD408A-EF35-49BE-AF8B-F2D54027F6D3}"/>
+                <a16:creationId xmlns:a16="http://schemas.microsoft.com/office/drawing/2014/main" id="{D7A473AC-86D3-49BA-A9C1-20155AC7E459}"/>
               </a:ext>
             </a:extLst>
           </p:cNvPr>
@@ -8093,7 +8093,7 @@
           <p:cNvPr id="24" name="">
             <a:extLst xmlns:a="http://schemas.openxmlformats.org/drawingml/2006/main">
               <a:ext uri="{FF2B5EF4-FFF2-40B4-BE49-F238E27FC236}">
-                <a16:creationId xmlns:a16="http://schemas.microsoft.com/office/drawing/2014/main" id="{39B40213-BCAF-4FBA-994A-A71A040BB528}"/>
+                <a16:creationId xmlns:a16="http://schemas.microsoft.com/office/drawing/2014/main" id="{E5EACB5A-F90F-4B6F-8DD9-D8F00DB8EE7B}"/>
               </a:ext>
             </a:extLst>
           </p:cNvPr>
@@ -8159,7 +8159,7 @@
           <p:cNvPr id="25" name="">
             <a:extLst xmlns:a="http://schemas.openxmlformats.org/drawingml/2006/main">
               <a:ext uri="{FF2B5EF4-FFF2-40B4-BE49-F238E27FC236}">
-                <a16:creationId xmlns:a16="http://schemas.microsoft.com/office/drawing/2014/main" id="{E17BB71F-AC65-4CFC-B292-07B2941427CB}"/>
+                <a16:creationId xmlns:a16="http://schemas.microsoft.com/office/drawing/2014/main" id="{33D67900-C8CF-429E-90DC-7ECBA2D4699D}"/>
               </a:ext>
             </a:extLst>
           </p:cNvPr>
@@ -8223,7 +8223,7 @@
     </p:spTree>
     <p:extLst>
       <p:ext uri="{BB962C8B-B14F-4D97-AF65-F5344CB8AC3E}">
-        <p14:creationId xmlns:p14="http://schemas.microsoft.com/office/powerpoint/2010/main" val="1960674229"/>
+        <p14:creationId xmlns:p14="http://schemas.microsoft.com/office/powerpoint/2010/main" val="1328275637"/>
       </p:ext>
     </p:extLst>
   </p:cSld>
@@ -8254,7 +8254,7 @@
           <p:cNvPr id="23" name="">
             <a:extLst xmlns:a="http://schemas.openxmlformats.org/drawingml/2006/main">
               <a:ext uri="{FF2B5EF4-FFF2-40B4-BE49-F238E27FC236}">
-                <a16:creationId xmlns:a16="http://schemas.microsoft.com/office/drawing/2014/main" id="{135E4420-5250-4AD6-A28A-BDEF61ECDA95}"/>
+                <a16:creationId xmlns:a16="http://schemas.microsoft.com/office/drawing/2014/main" id="{0ADE7FF0-600E-4397-A666-9F6DE201995D}"/>
               </a:ext>
             </a:extLst>
           </p:cNvPr>
@@ -8320,7 +8320,7 @@
           <p:cNvPr id="2" name="">
             <a:extLst xmlns:a="http://schemas.openxmlformats.org/drawingml/2006/main">
               <a:ext uri="{FF2B5EF4-FFF2-40B4-BE49-F238E27FC236}">
-                <a16:creationId xmlns:a16="http://schemas.microsoft.com/office/drawing/2014/main" id="{E29E76AC-256F-4783-9494-E8D99431CB98}"/>
+                <a16:creationId xmlns:a16="http://schemas.microsoft.com/office/drawing/2014/main" id="{9082B744-47AF-4BA8-AC25-4ACFEE9FA382}"/>
               </a:ext>
             </a:extLst>
           </p:cNvPr>
@@ -8386,7 +8386,7 @@
           <p:cNvPr id="3" name="">
             <a:extLst xmlns:a="http://schemas.openxmlformats.org/drawingml/2006/main">
               <a:ext uri="{FF2B5EF4-FFF2-40B4-BE49-F238E27FC236}">
-                <a16:creationId xmlns:a16="http://schemas.microsoft.com/office/drawing/2014/main" id="{7CF9EDF6-BF89-4BC3-920B-A4CF004522FD}"/>
+                <a16:creationId xmlns:a16="http://schemas.microsoft.com/office/drawing/2014/main" id="{02853F3D-211E-4357-9322-B9A5EC9CE449}"/>
               </a:ext>
             </a:extLst>
           </p:cNvPr>
@@ -8418,7 +8418,7 @@
           <p:cNvPr id="4" name="">
             <a:extLst xmlns:a="http://schemas.openxmlformats.org/drawingml/2006/main">
               <a:ext uri="{FF2B5EF4-FFF2-40B4-BE49-F238E27FC236}">
-                <a16:creationId xmlns:a16="http://schemas.microsoft.com/office/drawing/2014/main" id="{29C6D023-8726-4E56-A0B7-97C41FFFD4AE}"/>
+                <a16:creationId xmlns:a16="http://schemas.microsoft.com/office/drawing/2014/main" id="{956E2489-16BF-4BD2-A113-DEA1DAE78457}"/>
               </a:ext>
             </a:extLst>
           </p:cNvPr>
@@ -8452,7 +8452,7 @@
           <p:cNvPr id="5" name="">
             <a:extLst xmlns:a="http://schemas.openxmlformats.org/drawingml/2006/main">
               <a:ext uri="{FF2B5EF4-FFF2-40B4-BE49-F238E27FC236}">
-                <a16:creationId xmlns:a16="http://schemas.microsoft.com/office/drawing/2014/main" id="{BDB929A3-59D6-4D99-81B9-655CB8B1537B}"/>
+                <a16:creationId xmlns:a16="http://schemas.microsoft.com/office/drawing/2014/main" id="{5D7AC608-9018-4960-A96A-EBCD2715CA21}"/>
               </a:ext>
             </a:extLst>
           </p:cNvPr>
@@ -8518,7 +8518,7 @@
           <p:cNvPr id="6" name="">
             <a:extLst xmlns:a="http://schemas.openxmlformats.org/drawingml/2006/main">
               <a:ext uri="{FF2B5EF4-FFF2-40B4-BE49-F238E27FC236}">
-                <a16:creationId xmlns:a16="http://schemas.microsoft.com/office/drawing/2014/main" id="{6E97DC06-50FA-4482-92C1-C23733AD70CF}"/>
+                <a16:creationId xmlns:a16="http://schemas.microsoft.com/office/drawing/2014/main" id="{EB5F4EF2-0C0F-4939-ADE4-BC43966F85EE}"/>
               </a:ext>
             </a:extLst>
           </p:cNvPr>
@@ -8584,7 +8584,7 @@
           <p:cNvPr id="7" name="">
             <a:extLst xmlns:a="http://schemas.openxmlformats.org/drawingml/2006/main">
               <a:ext uri="{FF2B5EF4-FFF2-40B4-BE49-F238E27FC236}">
-                <a16:creationId xmlns:a16="http://schemas.microsoft.com/office/drawing/2014/main" id="{F6631EEC-7922-4146-9A9C-767FBA72A58D}"/>
+                <a16:creationId xmlns:a16="http://schemas.microsoft.com/office/drawing/2014/main" id="{DF4C1B06-403A-4A1F-8407-228B008F45C0}"/>
               </a:ext>
             </a:extLst>
           </p:cNvPr>
@@ -8650,7 +8650,7 @@
           <p:cNvPr id="8" name="">
             <a:extLst xmlns:a="http://schemas.openxmlformats.org/drawingml/2006/main">
               <a:ext uri="{FF2B5EF4-FFF2-40B4-BE49-F238E27FC236}">
-                <a16:creationId xmlns:a16="http://schemas.microsoft.com/office/drawing/2014/main" id="{1E0C73FB-006D-43A2-97A0-6F223C854A91}"/>
+                <a16:creationId xmlns:a16="http://schemas.microsoft.com/office/drawing/2014/main" id="{7C7229AF-F636-4CBC-8B53-C3B7FA27FB2C}"/>
               </a:ext>
             </a:extLst>
           </p:cNvPr>
@@ -8684,7 +8684,7 @@
           <p:cNvPr id="9" name="">
             <a:extLst xmlns:a="http://schemas.openxmlformats.org/drawingml/2006/main">
               <a:ext uri="{FF2B5EF4-FFF2-40B4-BE49-F238E27FC236}">
-                <a16:creationId xmlns:a16="http://schemas.microsoft.com/office/drawing/2014/main" id="{123B3F7F-7345-4B7F-9857-9C4F8A6CB571}"/>
+                <a16:creationId xmlns:a16="http://schemas.microsoft.com/office/drawing/2014/main" id="{559C4B10-FB00-4FF3-9023-DF8B7F43F57C}"/>
               </a:ext>
             </a:extLst>
           </p:cNvPr>
@@ -8750,7 +8750,7 @@
           <p:cNvPr id="10" name="">
             <a:extLst xmlns:a="http://schemas.openxmlformats.org/drawingml/2006/main">
               <a:ext uri="{FF2B5EF4-FFF2-40B4-BE49-F238E27FC236}">
-                <a16:creationId xmlns:a16="http://schemas.microsoft.com/office/drawing/2014/main" id="{85A94E20-844F-4578-B0AC-75A62E46EFF2}"/>
+                <a16:creationId xmlns:a16="http://schemas.microsoft.com/office/drawing/2014/main" id="{51BE47D1-47D6-410E-9190-D25582840EAD}"/>
               </a:ext>
             </a:extLst>
           </p:cNvPr>
@@ -8816,7 +8816,7 @@
           <p:cNvPr id="11" name="">
             <a:extLst xmlns:a="http://schemas.openxmlformats.org/drawingml/2006/main">
               <a:ext uri="{FF2B5EF4-FFF2-40B4-BE49-F238E27FC236}">
-                <a16:creationId xmlns:a16="http://schemas.microsoft.com/office/drawing/2014/main" id="{AC79808A-EBD7-459E-989F-F659F66B14BA}"/>
+                <a16:creationId xmlns:a16="http://schemas.microsoft.com/office/drawing/2014/main" id="{63063459-6DDC-4083-83AC-1B62275F822E}"/>
               </a:ext>
             </a:extLst>
           </p:cNvPr>
@@ -8882,7 +8882,7 @@
           <p:cNvPr id="12" name="">
             <a:extLst xmlns:a="http://schemas.openxmlformats.org/drawingml/2006/main">
               <a:ext uri="{FF2B5EF4-FFF2-40B4-BE49-F238E27FC236}">
-                <a16:creationId xmlns:a16="http://schemas.microsoft.com/office/drawing/2014/main" id="{B124CD7C-D2CC-4809-ABD5-959186139934}"/>
+                <a16:creationId xmlns:a16="http://schemas.microsoft.com/office/drawing/2014/main" id="{C85B6F2E-C43A-4F45-8C1C-43E09CDE3618}"/>
               </a:ext>
             </a:extLst>
           </p:cNvPr>
@@ -8916,7 +8916,7 @@
           <p:cNvPr id="13" name="">
             <a:extLst xmlns:a="http://schemas.openxmlformats.org/drawingml/2006/main">
               <a:ext uri="{FF2B5EF4-FFF2-40B4-BE49-F238E27FC236}">
-                <a16:creationId xmlns:a16="http://schemas.microsoft.com/office/drawing/2014/main" id="{2A671930-A5EC-4760-B88C-1FCCC35FF9E3}"/>
+                <a16:creationId xmlns:a16="http://schemas.microsoft.com/office/drawing/2014/main" id="{56807592-7A38-42C5-A021-B8A503FA8B1B}"/>
               </a:ext>
             </a:extLst>
           </p:cNvPr>
@@ -8982,7 +8982,7 @@
           <p:cNvPr id="14" name="">
             <a:extLst xmlns:a="http://schemas.openxmlformats.org/drawingml/2006/main">
               <a:ext uri="{FF2B5EF4-FFF2-40B4-BE49-F238E27FC236}">
-                <a16:creationId xmlns:a16="http://schemas.microsoft.com/office/drawing/2014/main" id="{065B6670-FD4D-4E75-886A-298998AA50E6}"/>
+                <a16:creationId xmlns:a16="http://schemas.microsoft.com/office/drawing/2014/main" id="{BCEEFE62-2DB8-45C7-B09E-5D2DA27A3185}"/>
               </a:ext>
             </a:extLst>
           </p:cNvPr>
@@ -9048,7 +9048,7 @@
           <p:cNvPr id="15" name="">
             <a:extLst xmlns:a="http://schemas.openxmlformats.org/drawingml/2006/main">
               <a:ext uri="{FF2B5EF4-FFF2-40B4-BE49-F238E27FC236}">
-                <a16:creationId xmlns:a16="http://schemas.microsoft.com/office/drawing/2014/main" id="{8B3CA267-5231-4A55-903D-E69D51CF7615}"/>
+                <a16:creationId xmlns:a16="http://schemas.microsoft.com/office/drawing/2014/main" id="{84168808-4231-486D-84B6-AE2FD2C71FFF}"/>
               </a:ext>
             </a:extLst>
           </p:cNvPr>
@@ -9114,7 +9114,7 @@
           <p:cNvPr id="16" name="">
             <a:extLst xmlns:a="http://schemas.openxmlformats.org/drawingml/2006/main">
               <a:ext uri="{FF2B5EF4-FFF2-40B4-BE49-F238E27FC236}">
-                <a16:creationId xmlns:a16="http://schemas.microsoft.com/office/drawing/2014/main" id="{17839626-CE61-4DA6-A11C-CEDB6754D64E}"/>
+                <a16:creationId xmlns:a16="http://schemas.microsoft.com/office/drawing/2014/main" id="{E58E96EB-3F34-4B75-A662-3D85CABABC13}"/>
               </a:ext>
             </a:extLst>
           </p:cNvPr>
@@ -9180,7 +9180,7 @@
           <p:cNvPr id="17" name="">
             <a:extLst xmlns:a="http://schemas.openxmlformats.org/drawingml/2006/main">
               <a:ext uri="{FF2B5EF4-FFF2-40B4-BE49-F238E27FC236}">
-                <a16:creationId xmlns:a16="http://schemas.microsoft.com/office/drawing/2014/main" id="{3B18D2AB-03AE-4378-9527-DDBE55424362}"/>
+                <a16:creationId xmlns:a16="http://schemas.microsoft.com/office/drawing/2014/main" id="{5837CB65-0248-4759-9EE7-35C768E81482}"/>
               </a:ext>
             </a:extLst>
           </p:cNvPr>
@@ -9246,7 +9246,7 @@
           <p:cNvPr id="18" name="">
             <a:extLst xmlns:a="http://schemas.openxmlformats.org/drawingml/2006/main">
               <a:ext uri="{FF2B5EF4-FFF2-40B4-BE49-F238E27FC236}">
-                <a16:creationId xmlns:a16="http://schemas.microsoft.com/office/drawing/2014/main" id="{BC6919C1-BD5C-4A08-86B8-957FBE459222}"/>
+                <a16:creationId xmlns:a16="http://schemas.microsoft.com/office/drawing/2014/main" id="{9A1C2763-6AE8-4C26-BDA7-4C285B901FAB}"/>
               </a:ext>
             </a:extLst>
           </p:cNvPr>
@@ -9312,7 +9312,7 @@
           <p:cNvPr id="19" name="">
             <a:extLst xmlns:a="http://schemas.openxmlformats.org/drawingml/2006/main">
               <a:ext uri="{FF2B5EF4-FFF2-40B4-BE49-F238E27FC236}">
-                <a16:creationId xmlns:a16="http://schemas.microsoft.com/office/drawing/2014/main" id="{EBE313BC-0DDE-491E-BC80-0E46B37EA808}"/>
+                <a16:creationId xmlns:a16="http://schemas.microsoft.com/office/drawing/2014/main" id="{A7FF8DC1-AB4E-40D3-8C1C-651C2DC9768C}"/>
               </a:ext>
             </a:extLst>
           </p:cNvPr>
@@ -9378,7 +9378,7 @@
           <p:cNvPr id="20" name="">
             <a:extLst xmlns:a="http://schemas.openxmlformats.org/drawingml/2006/main">
               <a:ext uri="{FF2B5EF4-FFF2-40B4-BE49-F238E27FC236}">
-                <a16:creationId xmlns:a16="http://schemas.microsoft.com/office/drawing/2014/main" id="{AEB7F4B3-E335-40B7-8573-029BD82BF451}"/>
+                <a16:creationId xmlns:a16="http://schemas.microsoft.com/office/drawing/2014/main" id="{3710B58D-87FE-4FD1-BB69-6CE923D34A1F}"/>
               </a:ext>
             </a:extLst>
           </p:cNvPr>
@@ -9444,7 +9444,7 @@
           <p:cNvPr id="21" name="">
             <a:extLst xmlns:a="http://schemas.openxmlformats.org/drawingml/2006/main">
               <a:ext uri="{FF2B5EF4-FFF2-40B4-BE49-F238E27FC236}">
-                <a16:creationId xmlns:a16="http://schemas.microsoft.com/office/drawing/2014/main" id="{AA153F39-0D80-45D6-BD5B-BCB63BCF2EE5}"/>
+                <a16:creationId xmlns:a16="http://schemas.microsoft.com/office/drawing/2014/main" id="{E1A8BA64-8263-4751-9B99-CDE13B8AB811}"/>
               </a:ext>
             </a:extLst>
           </p:cNvPr>
@@ -9510,7 +9510,7 @@
           <p:cNvPr id="22" name="">
             <a:extLst xmlns:a="http://schemas.openxmlformats.org/drawingml/2006/main">
               <a:ext uri="{FF2B5EF4-FFF2-40B4-BE49-F238E27FC236}">
-                <a16:creationId xmlns:a16="http://schemas.microsoft.com/office/drawing/2014/main" id="{C98E1365-10AF-4C7D-8ED1-0B48D6EE49B4}"/>
+                <a16:creationId xmlns:a16="http://schemas.microsoft.com/office/drawing/2014/main" id="{E22CB026-835A-48C7-8EF5-63CE67107D2B}"/>
               </a:ext>
             </a:extLst>
           </p:cNvPr>
@@ -9574,7 +9574,7 @@
     </p:spTree>
     <p:extLst>
       <p:ext uri="{BB962C8B-B14F-4D97-AF65-F5344CB8AC3E}">
-        <p14:creationId xmlns:p14="http://schemas.microsoft.com/office/powerpoint/2010/main" val="2147161370"/>
+        <p14:creationId xmlns:p14="http://schemas.microsoft.com/office/powerpoint/2010/main" val="1181136357"/>
       </p:ext>
     </p:extLst>
   </p:cSld>
@@ -9605,7 +9605,7 @@
           <p:cNvPr id="46" name="">
             <a:extLst xmlns:a="http://schemas.openxmlformats.org/drawingml/2006/main">
               <a:ext uri="{FF2B5EF4-FFF2-40B4-BE49-F238E27FC236}">
-                <a16:creationId xmlns:a16="http://schemas.microsoft.com/office/drawing/2014/main" id="{F3CCBA40-8314-44BF-9301-0C89EE73CF7A}"/>
+                <a16:creationId xmlns:a16="http://schemas.microsoft.com/office/drawing/2014/main" id="{7EF1CE13-2A37-4E6A-9475-9322A2D7CBA4}"/>
               </a:ext>
             </a:extLst>
           </p:cNvPr>
@@ -9671,7 +9671,7 @@
           <p:cNvPr id="2" name="">
             <a:extLst xmlns:a="http://schemas.openxmlformats.org/drawingml/2006/main">
               <a:ext uri="{FF2B5EF4-FFF2-40B4-BE49-F238E27FC236}">
-                <a16:creationId xmlns:a16="http://schemas.microsoft.com/office/drawing/2014/main" id="{DB4E8ED2-0DF0-4B4E-B2B0-A0BD3963FF51}"/>
+                <a16:creationId xmlns:a16="http://schemas.microsoft.com/office/drawing/2014/main" id="{2007D4CF-FDB8-4820-A50C-E2AE09B4AC4E}"/>
               </a:ext>
             </a:extLst>
           </p:cNvPr>
@@ -9737,7 +9737,7 @@
           <p:cNvPr id="3" name="">
             <a:extLst xmlns:a="http://schemas.openxmlformats.org/drawingml/2006/main">
               <a:ext uri="{FF2B5EF4-FFF2-40B4-BE49-F238E27FC236}">
-                <a16:creationId xmlns:a16="http://schemas.microsoft.com/office/drawing/2014/main" id="{E8D8F924-7026-49F5-AFD9-7B2801259870}"/>
+                <a16:creationId xmlns:a16="http://schemas.microsoft.com/office/drawing/2014/main" id="{203F5743-06B9-427A-84EB-A2DE2EAAA433}"/>
               </a:ext>
             </a:extLst>
           </p:cNvPr>
@@ -9769,7 +9769,7 @@
           <p:cNvPr id="4" name="">
             <a:extLst xmlns:a="http://schemas.openxmlformats.org/drawingml/2006/main">
               <a:ext uri="{FF2B5EF4-FFF2-40B4-BE49-F238E27FC236}">
-                <a16:creationId xmlns:a16="http://schemas.microsoft.com/office/drawing/2014/main" id="{FD4B2CBE-E7F5-4420-9776-AF897730F1C8}"/>
+                <a16:creationId xmlns:a16="http://schemas.microsoft.com/office/drawing/2014/main" id="{C2BC2387-B31D-4E80-8286-E9C446453E17}"/>
               </a:ext>
             </a:extLst>
           </p:cNvPr>
@@ -9803,7 +9803,7 @@
           <p:cNvPr id="5" name="">
             <a:extLst xmlns:a="http://schemas.openxmlformats.org/drawingml/2006/main">
               <a:ext uri="{FF2B5EF4-FFF2-40B4-BE49-F238E27FC236}">
-                <a16:creationId xmlns:a16="http://schemas.microsoft.com/office/drawing/2014/main" id="{7570671A-EC06-44D0-9EB0-A956A2A143EF}"/>
+                <a16:creationId xmlns:a16="http://schemas.microsoft.com/office/drawing/2014/main" id="{24AFC0C2-EA5E-47F5-BFB9-A7C9DE1B31DD}"/>
               </a:ext>
             </a:extLst>
           </p:cNvPr>
@@ -9869,7 +9869,7 @@
           <p:cNvPr id="6" name="">
             <a:extLst xmlns:a="http://schemas.openxmlformats.org/drawingml/2006/main">
               <a:ext uri="{FF2B5EF4-FFF2-40B4-BE49-F238E27FC236}">
-                <a16:creationId xmlns:a16="http://schemas.microsoft.com/office/drawing/2014/main" id="{A6A8886C-8FB6-4C40-BD5B-A64D7C56BAB1}"/>
+                <a16:creationId xmlns:a16="http://schemas.microsoft.com/office/drawing/2014/main" id="{B74EEA63-76E9-4CBB-ABB8-B577A264904A}"/>
               </a:ext>
             </a:extLst>
           </p:cNvPr>
@@ -9935,7 +9935,7 @@
           <p:cNvPr id="7" name="">
             <a:extLst xmlns:a="http://schemas.openxmlformats.org/drawingml/2006/main">
               <a:ext uri="{FF2B5EF4-FFF2-40B4-BE49-F238E27FC236}">
-                <a16:creationId xmlns:a16="http://schemas.microsoft.com/office/drawing/2014/main" id="{E27A8910-411F-4ACC-BAAC-3FDE8AAD81F3}"/>
+                <a16:creationId xmlns:a16="http://schemas.microsoft.com/office/drawing/2014/main" id="{64AECEBF-2D82-4091-AD01-9B6F3F2E284D}"/>
               </a:ext>
             </a:extLst>
           </p:cNvPr>
@@ -10001,7 +10001,7 @@
           <p:cNvPr id="8" name="">
             <a:extLst xmlns:a="http://schemas.openxmlformats.org/drawingml/2006/main">
               <a:ext uri="{FF2B5EF4-FFF2-40B4-BE49-F238E27FC236}">
-                <a16:creationId xmlns:a16="http://schemas.microsoft.com/office/drawing/2014/main" id="{06579559-1702-47D5-BDC3-F2F0D84FD5A3}"/>
+                <a16:creationId xmlns:a16="http://schemas.microsoft.com/office/drawing/2014/main" id="{96CDFB54-0712-4C22-801C-3D2CFC70671F}"/>
               </a:ext>
             </a:extLst>
           </p:cNvPr>
@@ -10067,7 +10067,7 @@
           <p:cNvPr id="9" name="">
             <a:extLst xmlns:a="http://schemas.openxmlformats.org/drawingml/2006/main">
               <a:ext uri="{FF2B5EF4-FFF2-40B4-BE49-F238E27FC236}">
-                <a16:creationId xmlns:a16="http://schemas.microsoft.com/office/drawing/2014/main" id="{EE0913C2-4802-4FD4-8429-2E9BE94EB28C}"/>
+                <a16:creationId xmlns:a16="http://schemas.microsoft.com/office/drawing/2014/main" id="{DD14142C-C4E8-4B0D-8F87-EA93FB9E04B0}"/>
               </a:ext>
             </a:extLst>
           </p:cNvPr>
@@ -10133,7 +10133,7 @@
           <p:cNvPr id="10" name="">
             <a:extLst xmlns:a="http://schemas.openxmlformats.org/drawingml/2006/main">
               <a:ext uri="{FF2B5EF4-FFF2-40B4-BE49-F238E27FC236}">
-                <a16:creationId xmlns:a16="http://schemas.microsoft.com/office/drawing/2014/main" id="{BC901592-A1B7-4133-9E58-F051E2C78575}"/>
+                <a16:creationId xmlns:a16="http://schemas.microsoft.com/office/drawing/2014/main" id="{04E16F72-CD7B-4A4C-80FC-4B8FFA7150A7}"/>
               </a:ext>
             </a:extLst>
           </p:cNvPr>
@@ -10199,7 +10199,7 @@
           <p:cNvPr id="11" name="">
             <a:extLst xmlns:a="http://schemas.openxmlformats.org/drawingml/2006/main">
               <a:ext uri="{FF2B5EF4-FFF2-40B4-BE49-F238E27FC236}">
-                <a16:creationId xmlns:a16="http://schemas.microsoft.com/office/drawing/2014/main" id="{2E00E259-4C5A-486C-B5A6-8334E562E01E}"/>
+                <a16:creationId xmlns:a16="http://schemas.microsoft.com/office/drawing/2014/main" id="{647087C0-70CD-497D-B8EA-829F1B7CC4ED}"/>
               </a:ext>
             </a:extLst>
           </p:cNvPr>
@@ -10265,7 +10265,7 @@
           <p:cNvPr id="12" name="">
             <a:extLst xmlns:a="http://schemas.openxmlformats.org/drawingml/2006/main">
               <a:ext uri="{FF2B5EF4-FFF2-40B4-BE49-F238E27FC236}">
-                <a16:creationId xmlns:a16="http://schemas.microsoft.com/office/drawing/2014/main" id="{F06E0229-AB7C-49F6-9469-26F0D7EE74D8}"/>
+                <a16:creationId xmlns:a16="http://schemas.microsoft.com/office/drawing/2014/main" id="{E5C19F1F-E02A-4C36-87D8-3D65E707FB53}"/>
               </a:ext>
             </a:extLst>
           </p:cNvPr>
@@ -10331,7 +10331,7 @@
           <p:cNvPr id="13" name="">
             <a:extLst xmlns:a="http://schemas.openxmlformats.org/drawingml/2006/main">
               <a:ext uri="{FF2B5EF4-FFF2-40B4-BE49-F238E27FC236}">
-                <a16:creationId xmlns:a16="http://schemas.microsoft.com/office/drawing/2014/main" id="{02A8AB18-3DDD-4B73-8533-83B3C73DF247}"/>
+                <a16:creationId xmlns:a16="http://schemas.microsoft.com/office/drawing/2014/main" id="{98347EFD-D66C-433C-8DFF-DA002D2EB6DA}"/>
               </a:ext>
             </a:extLst>
           </p:cNvPr>
@@ -10397,7 +10397,7 @@
           <p:cNvPr id="14" name="">
             <a:extLst xmlns:a="http://schemas.openxmlformats.org/drawingml/2006/main">
               <a:ext uri="{FF2B5EF4-FFF2-40B4-BE49-F238E27FC236}">
-                <a16:creationId xmlns:a16="http://schemas.microsoft.com/office/drawing/2014/main" id="{0E31C037-2F6E-44E1-9C40-FDA92A45D234}"/>
+                <a16:creationId xmlns:a16="http://schemas.microsoft.com/office/drawing/2014/main" id="{51C6B51A-7FEA-4908-98C4-60FEB6BAC19E}"/>
               </a:ext>
             </a:extLst>
           </p:cNvPr>
@@ -10431,7 +10431,7 @@
           <p:cNvPr id="15" name="">
             <a:extLst xmlns:a="http://schemas.openxmlformats.org/drawingml/2006/main">
               <a:ext uri="{FF2B5EF4-FFF2-40B4-BE49-F238E27FC236}">
-                <a16:creationId xmlns:a16="http://schemas.microsoft.com/office/drawing/2014/main" id="{DB596ED3-F595-4F66-B879-A0A2B4F2D45B}"/>
+                <a16:creationId xmlns:a16="http://schemas.microsoft.com/office/drawing/2014/main" id="{85237192-6983-4382-AF23-4AFAAE5C9B74}"/>
               </a:ext>
             </a:extLst>
           </p:cNvPr>
@@ -10497,7 +10497,7 @@
           <p:cNvPr id="16" name="">
             <a:extLst xmlns:a="http://schemas.openxmlformats.org/drawingml/2006/main">
               <a:ext uri="{FF2B5EF4-FFF2-40B4-BE49-F238E27FC236}">
-                <a16:creationId xmlns:a16="http://schemas.microsoft.com/office/drawing/2014/main" id="{4CEA8775-6A6E-4C5E-977E-72194D6864D8}"/>
+                <a16:creationId xmlns:a16="http://schemas.microsoft.com/office/drawing/2014/main" id="{A1238BF7-7DF2-4FB9-8A72-A9E0D7D9C4DA}"/>
               </a:ext>
             </a:extLst>
           </p:cNvPr>
@@ -10563,7 +10563,7 @@
           <p:cNvPr id="17" name="">
             <a:extLst xmlns:a="http://schemas.openxmlformats.org/drawingml/2006/main">
               <a:ext uri="{FF2B5EF4-FFF2-40B4-BE49-F238E27FC236}">
-                <a16:creationId xmlns:a16="http://schemas.microsoft.com/office/drawing/2014/main" id="{3A3D4ED0-4D3D-4223-A30E-84BCF3BBB133}"/>
+                <a16:creationId xmlns:a16="http://schemas.microsoft.com/office/drawing/2014/main" id="{AFC00CD8-0077-42E2-915E-7C1CD4966B75}"/>
               </a:ext>
             </a:extLst>
           </p:cNvPr>
@@ -10629,7 +10629,7 @@
           <p:cNvPr id="18" name="">
             <a:extLst xmlns:a="http://schemas.openxmlformats.org/drawingml/2006/main">
               <a:ext uri="{FF2B5EF4-FFF2-40B4-BE49-F238E27FC236}">
-                <a16:creationId xmlns:a16="http://schemas.microsoft.com/office/drawing/2014/main" id="{6F9E6AA2-43AB-4FAB-B1ED-370CC2E109E3}"/>
+                <a16:creationId xmlns:a16="http://schemas.microsoft.com/office/drawing/2014/main" id="{F894E2AE-67B6-44B6-B2AF-6ADCEF2E28A3}"/>
               </a:ext>
             </a:extLst>
           </p:cNvPr>
@@ -10695,7 +10695,7 @@
           <p:cNvPr id="19" name="">
             <a:extLst xmlns:a="http://schemas.openxmlformats.org/drawingml/2006/main">
               <a:ext uri="{FF2B5EF4-FFF2-40B4-BE49-F238E27FC236}">
-                <a16:creationId xmlns:a16="http://schemas.microsoft.com/office/drawing/2014/main" id="{49170100-95DD-4AD5-A557-C104AA1ABA95}"/>
+                <a16:creationId xmlns:a16="http://schemas.microsoft.com/office/drawing/2014/main" id="{CECA80D7-5441-40E4-B527-ABB7BAC8C080}"/>
               </a:ext>
             </a:extLst>
           </p:cNvPr>
@@ -10761,7 +10761,7 @@
           <p:cNvPr id="20" name="">
             <a:extLst xmlns:a="http://schemas.openxmlformats.org/drawingml/2006/main">
               <a:ext uri="{FF2B5EF4-FFF2-40B4-BE49-F238E27FC236}">
-                <a16:creationId xmlns:a16="http://schemas.microsoft.com/office/drawing/2014/main" id="{530DDDFF-6194-4E64-A86E-CD9FEB574DB8}"/>
+                <a16:creationId xmlns:a16="http://schemas.microsoft.com/office/drawing/2014/main" id="{E8D99BB5-3144-480A-AB25-289B1DDD13E3}"/>
               </a:ext>
             </a:extLst>
           </p:cNvPr>
@@ -10827,7 +10827,7 @@
           <p:cNvPr id="21" name="">
             <a:extLst xmlns:a="http://schemas.openxmlformats.org/drawingml/2006/main">
               <a:ext uri="{FF2B5EF4-FFF2-40B4-BE49-F238E27FC236}">
-                <a16:creationId xmlns:a16="http://schemas.microsoft.com/office/drawing/2014/main" id="{D6DFA26F-E034-406D-8DA5-5CCEFD8C8B5A}"/>
+                <a16:creationId xmlns:a16="http://schemas.microsoft.com/office/drawing/2014/main" id="{C7E03A62-C8F4-4FF4-8B86-9F5E7D15B241}"/>
               </a:ext>
             </a:extLst>
           </p:cNvPr>
@@ -10893,7 +10893,7 @@
           <p:cNvPr id="22" name="">
             <a:extLst xmlns:a="http://schemas.openxmlformats.org/drawingml/2006/main">
               <a:ext uri="{FF2B5EF4-FFF2-40B4-BE49-F238E27FC236}">
-                <a16:creationId xmlns:a16="http://schemas.microsoft.com/office/drawing/2014/main" id="{18FEEDC7-8E5F-4B13-B1E7-B3D275343D63}"/>
+                <a16:creationId xmlns:a16="http://schemas.microsoft.com/office/drawing/2014/main" id="{844F3533-7C79-4734-B0EE-6D89F2FF4077}"/>
               </a:ext>
             </a:extLst>
           </p:cNvPr>
@@ -10959,7 +10959,7 @@
           <p:cNvPr id="23" name="">
             <a:extLst xmlns:a="http://schemas.openxmlformats.org/drawingml/2006/main">
               <a:ext uri="{FF2B5EF4-FFF2-40B4-BE49-F238E27FC236}">
-                <a16:creationId xmlns:a16="http://schemas.microsoft.com/office/drawing/2014/main" id="{04CA1946-0303-4514-B3BE-3C79FB0771AC}"/>
+                <a16:creationId xmlns:a16="http://schemas.microsoft.com/office/drawing/2014/main" id="{D153FA2A-F604-4287-9C82-53EFA4C11ACC}"/>
               </a:ext>
             </a:extLst>
           </p:cNvPr>
@@ -11025,7 +11025,7 @@
           <p:cNvPr id="24" name="">
             <a:extLst xmlns:a="http://schemas.openxmlformats.org/drawingml/2006/main">
               <a:ext uri="{FF2B5EF4-FFF2-40B4-BE49-F238E27FC236}">
-                <a16:creationId xmlns:a16="http://schemas.microsoft.com/office/drawing/2014/main" id="{24AA237D-3C61-4B91-80D1-9B0379E1303E}"/>
+                <a16:creationId xmlns:a16="http://schemas.microsoft.com/office/drawing/2014/main" id="{E405A084-6695-478C-9038-93BE4D606D94}"/>
               </a:ext>
             </a:extLst>
           </p:cNvPr>
@@ -11059,7 +11059,7 @@
           <p:cNvPr id="25" name="">
             <a:extLst xmlns:a="http://schemas.openxmlformats.org/drawingml/2006/main">
               <a:ext uri="{FF2B5EF4-FFF2-40B4-BE49-F238E27FC236}">
-                <a16:creationId xmlns:a16="http://schemas.microsoft.com/office/drawing/2014/main" id="{9D1D5ABC-DC49-43B5-978B-BC3F58115A77}"/>
+                <a16:creationId xmlns:a16="http://schemas.microsoft.com/office/drawing/2014/main" id="{452448E7-3D31-42DB-9A78-97EAD0DA8EB2}"/>
               </a:ext>
             </a:extLst>
           </p:cNvPr>
@@ -11125,7 +11125,7 @@
           <p:cNvPr id="26" name="">
             <a:extLst xmlns:a="http://schemas.openxmlformats.org/drawingml/2006/main">
               <a:ext uri="{FF2B5EF4-FFF2-40B4-BE49-F238E27FC236}">
-                <a16:creationId xmlns:a16="http://schemas.microsoft.com/office/drawing/2014/main" id="{FE243E37-5100-47E6-A6CB-8650C06B6B3D}"/>
+                <a16:creationId xmlns:a16="http://schemas.microsoft.com/office/drawing/2014/main" id="{C5F4BB2E-937F-4982-AEC5-7D46B34ECEAB}"/>
               </a:ext>
             </a:extLst>
           </p:cNvPr>
@@ -11191,7 +11191,7 @@
           <p:cNvPr id="27" name="">
             <a:extLst xmlns:a="http://schemas.openxmlformats.org/drawingml/2006/main">
               <a:ext uri="{FF2B5EF4-FFF2-40B4-BE49-F238E27FC236}">
-                <a16:creationId xmlns:a16="http://schemas.microsoft.com/office/drawing/2014/main" id="{6C897AD0-A776-41D0-BFE3-B9A402719D0E}"/>
+                <a16:creationId xmlns:a16="http://schemas.microsoft.com/office/drawing/2014/main" id="{99366F4E-2440-49BC-A23E-F6F6519AEDB3}"/>
               </a:ext>
             </a:extLst>
           </p:cNvPr>
@@ -11257,7 +11257,7 @@
           <p:cNvPr id="28" name="">
             <a:extLst xmlns:a="http://schemas.openxmlformats.org/drawingml/2006/main">
               <a:ext uri="{FF2B5EF4-FFF2-40B4-BE49-F238E27FC236}">
-                <a16:creationId xmlns:a16="http://schemas.microsoft.com/office/drawing/2014/main" id="{460E98D6-E36A-4928-BF90-1061DED816A4}"/>
+                <a16:creationId xmlns:a16="http://schemas.microsoft.com/office/drawing/2014/main" id="{38EA47A4-FF01-4C7C-B1C1-DA1212E8CCCC}"/>
               </a:ext>
             </a:extLst>
           </p:cNvPr>
@@ -11323,7 +11323,7 @@
           <p:cNvPr id="29" name="">
             <a:extLst xmlns:a="http://schemas.openxmlformats.org/drawingml/2006/main">
               <a:ext uri="{FF2B5EF4-FFF2-40B4-BE49-F238E27FC236}">
-                <a16:creationId xmlns:a16="http://schemas.microsoft.com/office/drawing/2014/main" id="{57CC4D4C-254A-4D97-B38E-5DDA56AF0A67}"/>
+                <a16:creationId xmlns:a16="http://schemas.microsoft.com/office/drawing/2014/main" id="{8C7D8FD6-6B42-40A9-A18A-58A2A3A47D02}"/>
               </a:ext>
             </a:extLst>
           </p:cNvPr>
@@ -11389,7 +11389,7 @@
           <p:cNvPr id="30" name="">
             <a:extLst xmlns:a="http://schemas.openxmlformats.org/drawingml/2006/main">
               <a:ext uri="{FF2B5EF4-FFF2-40B4-BE49-F238E27FC236}">
-                <a16:creationId xmlns:a16="http://schemas.microsoft.com/office/drawing/2014/main" id="{26D6CB91-4F14-4571-848C-4E06E63C6B1D}"/>
+                <a16:creationId xmlns:a16="http://schemas.microsoft.com/office/drawing/2014/main" id="{73D42168-CEB2-4C20-A2B3-900FCB570DEE}"/>
               </a:ext>
             </a:extLst>
           </p:cNvPr>
@@ -11455,7 +11455,7 @@
           <p:cNvPr id="31" name="">
             <a:extLst xmlns:a="http://schemas.openxmlformats.org/drawingml/2006/main">
               <a:ext uri="{FF2B5EF4-FFF2-40B4-BE49-F238E27FC236}">
-                <a16:creationId xmlns:a16="http://schemas.microsoft.com/office/drawing/2014/main" id="{B6D05510-C6EB-4DB4-88BC-49D54CF76B54}"/>
+                <a16:creationId xmlns:a16="http://schemas.microsoft.com/office/drawing/2014/main" id="{980BDCEC-C29A-4DF6-92CD-88E15937CEB8}"/>
               </a:ext>
             </a:extLst>
           </p:cNvPr>
@@ -11521,7 +11521,7 @@
           <p:cNvPr id="32" name="">
             <a:extLst xmlns:a="http://schemas.openxmlformats.org/drawingml/2006/main">
               <a:ext uri="{FF2B5EF4-FFF2-40B4-BE49-F238E27FC236}">
-                <a16:creationId xmlns:a16="http://schemas.microsoft.com/office/drawing/2014/main" id="{381BFE8D-A2B4-4428-ACB7-0173A70EF7B1}"/>
+                <a16:creationId xmlns:a16="http://schemas.microsoft.com/office/drawing/2014/main" id="{D2BF24FB-EB79-4B7F-B61A-F0E909EA96ED}"/>
               </a:ext>
             </a:extLst>
           </p:cNvPr>
@@ -11587,7 +11587,7 @@
           <p:cNvPr id="33" name="">
             <a:extLst xmlns:a="http://schemas.openxmlformats.org/drawingml/2006/main">
               <a:ext uri="{FF2B5EF4-FFF2-40B4-BE49-F238E27FC236}">
-                <a16:creationId xmlns:a16="http://schemas.microsoft.com/office/drawing/2014/main" id="{07E40017-53C9-403C-AE5B-19628B272931}"/>
+                <a16:creationId xmlns:a16="http://schemas.microsoft.com/office/drawing/2014/main" id="{8D6AA9E6-BF8C-448C-BD90-FAF96687AD97}"/>
               </a:ext>
             </a:extLst>
           </p:cNvPr>
@@ -11653,7 +11653,7 @@
           <p:cNvPr id="34" name="">
             <a:extLst xmlns:a="http://schemas.openxmlformats.org/drawingml/2006/main">
               <a:ext uri="{FF2B5EF4-FFF2-40B4-BE49-F238E27FC236}">
-                <a16:creationId xmlns:a16="http://schemas.microsoft.com/office/drawing/2014/main" id="{4C0D96A8-888B-4899-9B41-BE68BDA0E9BE}"/>
+                <a16:creationId xmlns:a16="http://schemas.microsoft.com/office/drawing/2014/main" id="{1395599B-D9A5-4FFE-9AB2-3E2EE8E099E4}"/>
               </a:ext>
             </a:extLst>
           </p:cNvPr>
@@ -11719,7 +11719,7 @@
           <p:cNvPr id="35" name="">
             <a:extLst xmlns:a="http://schemas.openxmlformats.org/drawingml/2006/main">
               <a:ext uri="{FF2B5EF4-FFF2-40B4-BE49-F238E27FC236}">
-                <a16:creationId xmlns:a16="http://schemas.microsoft.com/office/drawing/2014/main" id="{33FA8326-3F24-4A92-9A8D-5FCF782CEFE4}"/>
+                <a16:creationId xmlns:a16="http://schemas.microsoft.com/office/drawing/2014/main" id="{8856982E-3AFF-4BB7-B8BE-837A9F7EA065}"/>
               </a:ext>
             </a:extLst>
           </p:cNvPr>
@@ -11785,7 +11785,7 @@
           <p:cNvPr id="36" name="">
             <a:extLst xmlns:a="http://schemas.openxmlformats.org/drawingml/2006/main">
               <a:ext uri="{FF2B5EF4-FFF2-40B4-BE49-F238E27FC236}">
-                <a16:creationId xmlns:a16="http://schemas.microsoft.com/office/drawing/2014/main" id="{CE4D1331-96DC-40CC-AB00-A2B9D7903D39}"/>
+                <a16:creationId xmlns:a16="http://schemas.microsoft.com/office/drawing/2014/main" id="{F28DEE43-2A7A-4CE1-B60D-E62DC99ABA90}"/>
               </a:ext>
             </a:extLst>
           </p:cNvPr>
@@ -11851,7 +11851,7 @@
           <p:cNvPr id="37" name="">
             <a:extLst xmlns:a="http://schemas.openxmlformats.org/drawingml/2006/main">
               <a:ext uri="{FF2B5EF4-FFF2-40B4-BE49-F238E27FC236}">
-                <a16:creationId xmlns:a16="http://schemas.microsoft.com/office/drawing/2014/main" id="{643CF65B-137F-4C59-A0C3-CE1A4BE5318C}"/>
+                <a16:creationId xmlns:a16="http://schemas.microsoft.com/office/drawing/2014/main" id="{05D4DF70-B3E9-4D1D-8036-8E68CAC027A6}"/>
               </a:ext>
             </a:extLst>
           </p:cNvPr>
@@ -11917,7 +11917,7 @@
           <p:cNvPr id="38" name="">
             <a:extLst xmlns:a="http://schemas.openxmlformats.org/drawingml/2006/main">
               <a:ext uri="{FF2B5EF4-FFF2-40B4-BE49-F238E27FC236}">
-                <a16:creationId xmlns:a16="http://schemas.microsoft.com/office/drawing/2014/main" id="{6B11067C-2EF7-4F0B-967F-13C0692913FB}"/>
+                <a16:creationId xmlns:a16="http://schemas.microsoft.com/office/drawing/2014/main" id="{5BE5D629-3EB6-4867-BC44-927CC41B7315}"/>
               </a:ext>
             </a:extLst>
           </p:cNvPr>
@@ -11983,7 +11983,7 @@
           <p:cNvPr id="39" name="">
             <a:extLst xmlns:a="http://schemas.openxmlformats.org/drawingml/2006/main">
               <a:ext uri="{FF2B5EF4-FFF2-40B4-BE49-F238E27FC236}">
-                <a16:creationId xmlns:a16="http://schemas.microsoft.com/office/drawing/2014/main" id="{9FC0FEDC-69B5-41F5-BE41-9E680ED4B93D}"/>
+                <a16:creationId xmlns:a16="http://schemas.microsoft.com/office/drawing/2014/main" id="{AF28D0B8-C9E7-4B9A-A7F5-9FF3D616347D}"/>
               </a:ext>
             </a:extLst>
           </p:cNvPr>
@@ -12049,7 +12049,7 @@
           <p:cNvPr id="40" name="">
             <a:extLst xmlns:a="http://schemas.openxmlformats.org/drawingml/2006/main">
               <a:ext uri="{FF2B5EF4-FFF2-40B4-BE49-F238E27FC236}">
-                <a16:creationId xmlns:a16="http://schemas.microsoft.com/office/drawing/2014/main" id="{119FFAF0-9BA6-401D-BB58-B7003EFB9F8E}"/>
+                <a16:creationId xmlns:a16="http://schemas.microsoft.com/office/drawing/2014/main" id="{665548B8-912B-4303-A244-D70B5D0B3F25}"/>
               </a:ext>
             </a:extLst>
           </p:cNvPr>
@@ -12115,7 +12115,7 @@
           <p:cNvPr id="41" name="">
             <a:extLst xmlns:a="http://schemas.openxmlformats.org/drawingml/2006/main">
               <a:ext uri="{FF2B5EF4-FFF2-40B4-BE49-F238E27FC236}">
-                <a16:creationId xmlns:a16="http://schemas.microsoft.com/office/drawing/2014/main" id="{DB5A15A9-B52E-4F24-B00F-7059BF34DD5B}"/>
+                <a16:creationId xmlns:a16="http://schemas.microsoft.com/office/drawing/2014/main" id="{0F819ECD-1142-457A-882C-313B336121E3}"/>
               </a:ext>
             </a:extLst>
           </p:cNvPr>
@@ -12181,7 +12181,7 @@
           <p:cNvPr id="42" name="">
             <a:extLst xmlns:a="http://schemas.openxmlformats.org/drawingml/2006/main">
               <a:ext uri="{FF2B5EF4-FFF2-40B4-BE49-F238E27FC236}">
-                <a16:creationId xmlns:a16="http://schemas.microsoft.com/office/drawing/2014/main" id="{45446E47-A2C5-4447-8614-FE2399008BAE}"/>
+                <a16:creationId xmlns:a16="http://schemas.microsoft.com/office/drawing/2014/main" id="{EEC21E6C-81C9-4025-8D2D-FF4E944FD4E1}"/>
               </a:ext>
             </a:extLst>
           </p:cNvPr>
@@ -12247,7 +12247,7 @@
           <p:cNvPr id="43" name="">
             <a:extLst xmlns:a="http://schemas.openxmlformats.org/drawingml/2006/main">
               <a:ext uri="{FF2B5EF4-FFF2-40B4-BE49-F238E27FC236}">
-                <a16:creationId xmlns:a16="http://schemas.microsoft.com/office/drawing/2014/main" id="{B8C640E5-BB55-4CAA-94DA-B1907B743985}"/>
+                <a16:creationId xmlns:a16="http://schemas.microsoft.com/office/drawing/2014/main" id="{9C08DD55-6717-4B08-91A0-3D5156E9D9E5}"/>
               </a:ext>
             </a:extLst>
           </p:cNvPr>
@@ -12313,7 +12313,7 @@
           <p:cNvPr id="44" name="">
             <a:extLst xmlns:a="http://schemas.openxmlformats.org/drawingml/2006/main">
               <a:ext uri="{FF2B5EF4-FFF2-40B4-BE49-F238E27FC236}">
-                <a16:creationId xmlns:a16="http://schemas.microsoft.com/office/drawing/2014/main" id="{3525EF15-6951-4055-AF1B-9D7B545529BD}"/>
+                <a16:creationId xmlns:a16="http://schemas.microsoft.com/office/drawing/2014/main" id="{FF38C1F4-A780-4C46-87DB-FE82CCD0F86A}"/>
               </a:ext>
             </a:extLst>
           </p:cNvPr>
@@ -12379,7 +12379,7 @@
           <p:cNvPr id="45" name="">
             <a:extLst xmlns:a="http://schemas.openxmlformats.org/drawingml/2006/main">
               <a:ext uri="{FF2B5EF4-FFF2-40B4-BE49-F238E27FC236}">
-                <a16:creationId xmlns:a16="http://schemas.microsoft.com/office/drawing/2014/main" id="{52F622F8-576B-484E-9C21-B7AE25B00E8D}"/>
+                <a16:creationId xmlns:a16="http://schemas.microsoft.com/office/drawing/2014/main" id="{14A94A65-AABC-45A4-A01F-C4090673E88E}"/>
               </a:ext>
             </a:extLst>
           </p:cNvPr>
@@ -12443,7 +12443,7 @@
     </p:spTree>
     <p:extLst>
       <p:ext uri="{BB962C8B-B14F-4D97-AF65-F5344CB8AC3E}">
-        <p14:creationId xmlns:p14="http://schemas.microsoft.com/office/powerpoint/2010/main" val="2019983589"/>
+        <p14:creationId xmlns:p14="http://schemas.microsoft.com/office/powerpoint/2010/main" val="1159974296"/>
       </p:ext>
     </p:extLst>
   </p:cSld>
@@ -12474,7 +12474,7 @@
           <p:cNvPr id="22" name="">
             <a:extLst xmlns:a="http://schemas.openxmlformats.org/drawingml/2006/main">
               <a:ext uri="{FF2B5EF4-FFF2-40B4-BE49-F238E27FC236}">
-                <a16:creationId xmlns:a16="http://schemas.microsoft.com/office/drawing/2014/main" id="{D53BB058-11A5-440D-B0D9-50D401B1C236}"/>
+                <a16:creationId xmlns:a16="http://schemas.microsoft.com/office/drawing/2014/main" id="{D9B67D0C-D0C4-44FF-ADCB-0FFE742C63E7}"/>
               </a:ext>
             </a:extLst>
           </p:cNvPr>
@@ -12540,7 +12540,7 @@
           <p:cNvPr id="2" name="">
             <a:extLst xmlns:a="http://schemas.openxmlformats.org/drawingml/2006/main">
               <a:ext uri="{FF2B5EF4-FFF2-40B4-BE49-F238E27FC236}">
-                <a16:creationId xmlns:a16="http://schemas.microsoft.com/office/drawing/2014/main" id="{778ED730-FA86-4FBE-9A33-28E4B6D85184}"/>
+                <a16:creationId xmlns:a16="http://schemas.microsoft.com/office/drawing/2014/main" id="{8FC4FC72-8A30-4272-BDC6-C68F3947E0F8}"/>
               </a:ext>
             </a:extLst>
           </p:cNvPr>
@@ -12606,7 +12606,7 @@
           <p:cNvPr id="3" name="">
             <a:extLst xmlns:a="http://schemas.openxmlformats.org/drawingml/2006/main">
               <a:ext uri="{FF2B5EF4-FFF2-40B4-BE49-F238E27FC236}">
-                <a16:creationId xmlns:a16="http://schemas.microsoft.com/office/drawing/2014/main" id="{9943D3BF-274A-4903-A236-B68754B922CE}"/>
+                <a16:creationId xmlns:a16="http://schemas.microsoft.com/office/drawing/2014/main" id="{F523B80C-3625-497E-8A09-E39F6213F6BA}"/>
               </a:ext>
             </a:extLst>
           </p:cNvPr>
@@ -12638,7 +12638,7 @@
           <p:cNvPr id="4" name="">
             <a:extLst xmlns:a="http://schemas.openxmlformats.org/drawingml/2006/main">
               <a:ext uri="{FF2B5EF4-FFF2-40B4-BE49-F238E27FC236}">
-                <a16:creationId xmlns:a16="http://schemas.microsoft.com/office/drawing/2014/main" id="{C15E383A-677E-4F86-89DC-76B07F017527}"/>
+                <a16:creationId xmlns:a16="http://schemas.microsoft.com/office/drawing/2014/main" id="{6ACC9E1F-7F51-4D86-BD82-631D80B7C711}"/>
               </a:ext>
             </a:extLst>
           </p:cNvPr>
@@ -12704,7 +12704,7 @@
           <p:cNvPr id="5" name="">
             <a:extLst xmlns:a="http://schemas.openxmlformats.org/drawingml/2006/main">
               <a:ext uri="{FF2B5EF4-FFF2-40B4-BE49-F238E27FC236}">
-                <a16:creationId xmlns:a16="http://schemas.microsoft.com/office/drawing/2014/main" id="{F3444F95-F624-4349-AB4C-C74B82368396}"/>
+                <a16:creationId xmlns:a16="http://schemas.microsoft.com/office/drawing/2014/main" id="{3F8B6864-0FD8-44AB-8555-2B4F599BA814}"/>
               </a:ext>
             </a:extLst>
           </p:cNvPr>
@@ -12770,7 +12770,7 @@
           <p:cNvPr id="6" name="">
             <a:extLst xmlns:a="http://schemas.openxmlformats.org/drawingml/2006/main">
               <a:ext uri="{FF2B5EF4-FFF2-40B4-BE49-F238E27FC236}">
-                <a16:creationId xmlns:a16="http://schemas.microsoft.com/office/drawing/2014/main" id="{D64DEF19-6BCA-4F59-A89F-E9D01EB4BEAF}"/>
+                <a16:creationId xmlns:a16="http://schemas.microsoft.com/office/drawing/2014/main" id="{856C5152-C03F-4875-98F5-A0A18B04C35A}"/>
               </a:ext>
             </a:extLst>
           </p:cNvPr>
@@ -12836,7 +12836,7 @@
           <p:cNvPr id="7" name="">
             <a:extLst xmlns:a="http://schemas.openxmlformats.org/drawingml/2006/main">
               <a:ext uri="{FF2B5EF4-FFF2-40B4-BE49-F238E27FC236}">
-                <a16:creationId xmlns:a16="http://schemas.microsoft.com/office/drawing/2014/main" id="{9106EB6B-8CDA-479D-870C-FEC143C108D6}"/>
+                <a16:creationId xmlns:a16="http://schemas.microsoft.com/office/drawing/2014/main" id="{EC884A06-53AF-49D9-9489-AD8D937E4F89}"/>
               </a:ext>
             </a:extLst>
           </p:cNvPr>
@@ -12902,7 +12902,7 @@
           <p:cNvPr id="8" name="">
             <a:extLst xmlns:a="http://schemas.openxmlformats.org/drawingml/2006/main">
               <a:ext uri="{FF2B5EF4-FFF2-40B4-BE49-F238E27FC236}">
-                <a16:creationId xmlns:a16="http://schemas.microsoft.com/office/drawing/2014/main" id="{5189BE98-BB30-4422-A73F-952E2F4CD97B}"/>
+                <a16:creationId xmlns:a16="http://schemas.microsoft.com/office/drawing/2014/main" id="{A94CD5E7-B2E8-4571-87A0-FE9917C0F840}"/>
               </a:ext>
             </a:extLst>
           </p:cNvPr>
@@ -12968,7 +12968,7 @@
           <p:cNvPr id="9" name="">
             <a:extLst xmlns:a="http://schemas.openxmlformats.org/drawingml/2006/main">
               <a:ext uri="{FF2B5EF4-FFF2-40B4-BE49-F238E27FC236}">
-                <a16:creationId xmlns:a16="http://schemas.microsoft.com/office/drawing/2014/main" id="{AFA21E7E-EEF8-4621-BAD6-B93063E879C1}"/>
+                <a16:creationId xmlns:a16="http://schemas.microsoft.com/office/drawing/2014/main" id="{469B2842-ABBA-4A5C-B638-922AB8EC58B3}"/>
               </a:ext>
             </a:extLst>
           </p:cNvPr>
@@ -13034,7 +13034,7 @@
           <p:cNvPr id="10" name="">
             <a:extLst xmlns:a="http://schemas.openxmlformats.org/drawingml/2006/main">
               <a:ext uri="{FF2B5EF4-FFF2-40B4-BE49-F238E27FC236}">
-                <a16:creationId xmlns:a16="http://schemas.microsoft.com/office/drawing/2014/main" id="{DF7A5CA2-8425-445D-ADF2-13D2369498D4}"/>
+                <a16:creationId xmlns:a16="http://schemas.microsoft.com/office/drawing/2014/main" id="{10277C12-A6EC-4769-9C7C-42A9080A9889}"/>
               </a:ext>
             </a:extLst>
           </p:cNvPr>
@@ -13100,7 +13100,7 @@
           <p:cNvPr id="11" name="">
             <a:extLst xmlns:a="http://schemas.openxmlformats.org/drawingml/2006/main">
               <a:ext uri="{FF2B5EF4-FFF2-40B4-BE49-F238E27FC236}">
-                <a16:creationId xmlns:a16="http://schemas.microsoft.com/office/drawing/2014/main" id="{BBEB4C29-D026-4BD7-BA8D-972A2703AF09}"/>
+                <a16:creationId xmlns:a16="http://schemas.microsoft.com/office/drawing/2014/main" id="{747D1C62-3886-44FB-8C56-479E01493D5C}"/>
               </a:ext>
             </a:extLst>
           </p:cNvPr>
@@ -13166,7 +13166,7 @@
           <p:cNvPr id="12" name="">
             <a:extLst xmlns:a="http://schemas.openxmlformats.org/drawingml/2006/main">
               <a:ext uri="{FF2B5EF4-FFF2-40B4-BE49-F238E27FC236}">
-                <a16:creationId xmlns:a16="http://schemas.microsoft.com/office/drawing/2014/main" id="{A01DA758-6D4A-4C2B-B6C3-A1AE596F8BA6}"/>
+                <a16:creationId xmlns:a16="http://schemas.microsoft.com/office/drawing/2014/main" id="{2C390130-ED49-4A7A-8D67-19FDC84410F8}"/>
               </a:ext>
             </a:extLst>
           </p:cNvPr>
@@ -13232,7 +13232,7 @@
           <p:cNvPr id="13" name="">
             <a:extLst xmlns:a="http://schemas.openxmlformats.org/drawingml/2006/main">
               <a:ext uri="{FF2B5EF4-FFF2-40B4-BE49-F238E27FC236}">
-                <a16:creationId xmlns:a16="http://schemas.microsoft.com/office/drawing/2014/main" id="{AE7EEC65-D234-4EB0-AB4A-8CCD88D49662}"/>
+                <a16:creationId xmlns:a16="http://schemas.microsoft.com/office/drawing/2014/main" id="{26074F48-570F-44E8-911F-29766551DAFE}"/>
               </a:ext>
             </a:extLst>
           </p:cNvPr>
@@ -13298,7 +13298,7 @@
           <p:cNvPr id="14" name="">
             <a:extLst xmlns:a="http://schemas.openxmlformats.org/drawingml/2006/main">
               <a:ext uri="{FF2B5EF4-FFF2-40B4-BE49-F238E27FC236}">
-                <a16:creationId xmlns:a16="http://schemas.microsoft.com/office/drawing/2014/main" id="{7795D59F-086C-4A38-973E-B699506FF9EB}"/>
+                <a16:creationId xmlns:a16="http://schemas.microsoft.com/office/drawing/2014/main" id="{1803AA6A-F835-4DFC-BAFF-FAC926809238}"/>
               </a:ext>
             </a:extLst>
           </p:cNvPr>
@@ -13364,7 +13364,7 @@
           <p:cNvPr id="15" name="">
             <a:extLst xmlns:a="http://schemas.openxmlformats.org/drawingml/2006/main">
               <a:ext uri="{FF2B5EF4-FFF2-40B4-BE49-F238E27FC236}">
-                <a16:creationId xmlns:a16="http://schemas.microsoft.com/office/drawing/2014/main" id="{74F92A54-C758-4CE2-9D02-13FAF0DF0992}"/>
+                <a16:creationId xmlns:a16="http://schemas.microsoft.com/office/drawing/2014/main" id="{C0197549-DE75-40D2-9107-73998F170426}"/>
               </a:ext>
             </a:extLst>
           </p:cNvPr>
@@ -13430,7 +13430,7 @@
           <p:cNvPr id="16" name="">
             <a:extLst xmlns:a="http://schemas.openxmlformats.org/drawingml/2006/main">
               <a:ext uri="{FF2B5EF4-FFF2-40B4-BE49-F238E27FC236}">
-                <a16:creationId xmlns:a16="http://schemas.microsoft.com/office/drawing/2014/main" id="{8AE4B042-BA31-4120-925C-C505D1CE8687}"/>
+                <a16:creationId xmlns:a16="http://schemas.microsoft.com/office/drawing/2014/main" id="{5C54FA61-5936-441D-A630-774063BFFA1D}"/>
               </a:ext>
             </a:extLst>
           </p:cNvPr>
@@ -13496,7 +13496,7 @@
           <p:cNvPr id="17" name="">
             <a:extLst xmlns:a="http://schemas.openxmlformats.org/drawingml/2006/main">
               <a:ext uri="{FF2B5EF4-FFF2-40B4-BE49-F238E27FC236}">
-                <a16:creationId xmlns:a16="http://schemas.microsoft.com/office/drawing/2014/main" id="{C5AC49FA-513B-4DEE-BC6D-C96B6F6E6434}"/>
+                <a16:creationId xmlns:a16="http://schemas.microsoft.com/office/drawing/2014/main" id="{3C41C4C2-DB10-498D-AF23-F516ED4EB342}"/>
               </a:ext>
             </a:extLst>
           </p:cNvPr>
@@ -13562,7 +13562,7 @@
           <p:cNvPr id="18" name="">
             <a:extLst xmlns:a="http://schemas.openxmlformats.org/drawingml/2006/main">
               <a:ext uri="{FF2B5EF4-FFF2-40B4-BE49-F238E27FC236}">
-                <a16:creationId xmlns:a16="http://schemas.microsoft.com/office/drawing/2014/main" id="{0F00BA22-BBA7-4CA7-B1CA-B213B5AAC58F}"/>
+                <a16:creationId xmlns:a16="http://schemas.microsoft.com/office/drawing/2014/main" id="{4022A69A-E3C8-475E-97F7-DD95F1344690}"/>
               </a:ext>
             </a:extLst>
           </p:cNvPr>
@@ -13628,7 +13628,7 @@
           <p:cNvPr id="19" name="">
             <a:extLst xmlns:a="http://schemas.openxmlformats.org/drawingml/2006/main">
               <a:ext uri="{FF2B5EF4-FFF2-40B4-BE49-F238E27FC236}">
-                <a16:creationId xmlns:a16="http://schemas.microsoft.com/office/drawing/2014/main" id="{F04B622C-0028-4C87-9F83-8690419B590F}"/>
+                <a16:creationId xmlns:a16="http://schemas.microsoft.com/office/drawing/2014/main" id="{57FB3E04-E712-4541-A7FA-F3E44BEBB98F}"/>
               </a:ext>
             </a:extLst>
           </p:cNvPr>
@@ -13694,7 +13694,7 @@
           <p:cNvPr id="20" name="">
             <a:extLst xmlns:a="http://schemas.openxmlformats.org/drawingml/2006/main">
               <a:ext uri="{FF2B5EF4-FFF2-40B4-BE49-F238E27FC236}">
-                <a16:creationId xmlns:a16="http://schemas.microsoft.com/office/drawing/2014/main" id="{FF3FB0E8-C3C0-49C1-AA9F-B494E9A70475}"/>
+                <a16:creationId xmlns:a16="http://schemas.microsoft.com/office/drawing/2014/main" id="{E75CA06D-8250-41E1-81D8-7A33752ED9B0}"/>
               </a:ext>
             </a:extLst>
           </p:cNvPr>
@@ -13760,7 +13760,7 @@
           <p:cNvPr id="21" name="">
             <a:extLst xmlns:a="http://schemas.openxmlformats.org/drawingml/2006/main">
               <a:ext uri="{FF2B5EF4-FFF2-40B4-BE49-F238E27FC236}">
-                <a16:creationId xmlns:a16="http://schemas.microsoft.com/office/drawing/2014/main" id="{6F6535F7-E421-43D6-902A-0513DF711987}"/>
+                <a16:creationId xmlns:a16="http://schemas.microsoft.com/office/drawing/2014/main" id="{07E76484-832C-46F0-859A-2118E2E64484}"/>
               </a:ext>
             </a:extLst>
           </p:cNvPr>
@@ -13824,7 +13824,7 @@
     </p:spTree>
     <p:extLst>
       <p:ext uri="{BB962C8B-B14F-4D97-AF65-F5344CB8AC3E}">
-        <p14:creationId xmlns:p14="http://schemas.microsoft.com/office/powerpoint/2010/main" val="1325025170"/>
+        <p14:creationId xmlns:p14="http://schemas.microsoft.com/office/powerpoint/2010/main" val="1379025314"/>
       </p:ext>
     </p:extLst>
   </p:cSld>
@@ -13855,7 +13855,7 @@
           <p:cNvPr id="23" name="">
             <a:extLst xmlns:a="http://schemas.openxmlformats.org/drawingml/2006/main">
               <a:ext uri="{FF2B5EF4-FFF2-40B4-BE49-F238E27FC236}">
-                <a16:creationId xmlns:a16="http://schemas.microsoft.com/office/drawing/2014/main" id="{EA4905E4-5CCD-4457-9148-09176B41C0B7}"/>
+                <a16:creationId xmlns:a16="http://schemas.microsoft.com/office/drawing/2014/main" id="{D9E79185-32D5-4F42-9C53-A919BCDB30BA}"/>
               </a:ext>
             </a:extLst>
           </p:cNvPr>
@@ -13921,7 +13921,7 @@
           <p:cNvPr id="2" name="">
             <a:extLst xmlns:a="http://schemas.openxmlformats.org/drawingml/2006/main">
               <a:ext uri="{FF2B5EF4-FFF2-40B4-BE49-F238E27FC236}">
-                <a16:creationId xmlns:a16="http://schemas.microsoft.com/office/drawing/2014/main" id="{5D2BC9DD-F50A-4D9B-BA6B-1FF828271C0B}"/>
+                <a16:creationId xmlns:a16="http://schemas.microsoft.com/office/drawing/2014/main" id="{1A28AF36-D224-4AEA-B1E8-414C9427DCFF}"/>
               </a:ext>
             </a:extLst>
           </p:cNvPr>
@@ -13987,7 +13987,7 @@
           <p:cNvPr id="3" name="">
             <a:extLst xmlns:a="http://schemas.openxmlformats.org/drawingml/2006/main">
               <a:ext uri="{FF2B5EF4-FFF2-40B4-BE49-F238E27FC236}">
-                <a16:creationId xmlns:a16="http://schemas.microsoft.com/office/drawing/2014/main" id="{86D81D51-25A3-4455-A7A3-A40CAEF5B590}"/>
+                <a16:creationId xmlns:a16="http://schemas.microsoft.com/office/drawing/2014/main" id="{30BD01EB-A284-404D-B2BF-ED2775066366}"/>
               </a:ext>
             </a:extLst>
           </p:cNvPr>
@@ -14019,7 +14019,7 @@
           <p:cNvPr id="4" name="">
             <a:extLst xmlns:a="http://schemas.openxmlformats.org/drawingml/2006/main">
               <a:ext uri="{FF2B5EF4-FFF2-40B4-BE49-F238E27FC236}">
-                <a16:creationId xmlns:a16="http://schemas.microsoft.com/office/drawing/2014/main" id="{689A43BB-93EE-40BF-AE94-A0CFE3E79887}"/>
+                <a16:creationId xmlns:a16="http://schemas.microsoft.com/office/drawing/2014/main" id="{655084AB-E6D2-4C17-BCB4-CFC8BCE2EC99}"/>
               </a:ext>
             </a:extLst>
           </p:cNvPr>
@@ -14085,7 +14085,7 @@
           <p:cNvPr id="5" name="">
             <a:extLst xmlns:a="http://schemas.openxmlformats.org/drawingml/2006/main">
               <a:ext uri="{FF2B5EF4-FFF2-40B4-BE49-F238E27FC236}">
-                <a16:creationId xmlns:a16="http://schemas.microsoft.com/office/drawing/2014/main" id="{B94013FE-B1E9-4A05-857E-3F688BA99AD8}"/>
+                <a16:creationId xmlns:a16="http://schemas.microsoft.com/office/drawing/2014/main" id="{EB65B930-FE41-41F7-B4DD-EE6126AEEBD2}"/>
               </a:ext>
             </a:extLst>
           </p:cNvPr>
@@ -14119,7 +14119,7 @@
           <p:cNvPr id="6" name="">
             <a:extLst xmlns:a="http://schemas.openxmlformats.org/drawingml/2006/main">
               <a:ext uri="{FF2B5EF4-FFF2-40B4-BE49-F238E27FC236}">
-                <a16:creationId xmlns:a16="http://schemas.microsoft.com/office/drawing/2014/main" id="{94D7870D-1905-495C-9D27-78CEAAE2226D}"/>
+                <a16:creationId xmlns:a16="http://schemas.microsoft.com/office/drawing/2014/main" id="{E0D105FC-5681-4F4A-8269-3463FB0C6FC7}"/>
               </a:ext>
             </a:extLst>
           </p:cNvPr>
@@ -14185,7 +14185,7 @@
           <p:cNvPr id="7" name="">
             <a:extLst xmlns:a="http://schemas.openxmlformats.org/drawingml/2006/main">
               <a:ext uri="{FF2B5EF4-FFF2-40B4-BE49-F238E27FC236}">
-                <a16:creationId xmlns:a16="http://schemas.microsoft.com/office/drawing/2014/main" id="{272D8E4C-FF57-456D-8DBA-6D845FF567EC}"/>
+                <a16:creationId xmlns:a16="http://schemas.microsoft.com/office/drawing/2014/main" id="{E0F1B4B5-1AF4-4D7E-8B0C-F8F824DF72FB}"/>
               </a:ext>
             </a:extLst>
           </p:cNvPr>
@@ -14251,7 +14251,7 @@
           <p:cNvPr id="8" name="">
             <a:extLst xmlns:a="http://schemas.openxmlformats.org/drawingml/2006/main">
               <a:ext uri="{FF2B5EF4-FFF2-40B4-BE49-F238E27FC236}">
-                <a16:creationId xmlns:a16="http://schemas.microsoft.com/office/drawing/2014/main" id="{61AE2D93-CF8B-47D7-9EC2-79CCD3DBACE6}"/>
+                <a16:creationId xmlns:a16="http://schemas.microsoft.com/office/drawing/2014/main" id="{616AB0FF-7329-4B13-B91A-AB00E936EDAF}"/>
               </a:ext>
             </a:extLst>
           </p:cNvPr>
@@ -14317,7 +14317,7 @@
           <p:cNvPr id="9" name="">
             <a:extLst xmlns:a="http://schemas.openxmlformats.org/drawingml/2006/main">
               <a:ext uri="{FF2B5EF4-FFF2-40B4-BE49-F238E27FC236}">
-                <a16:creationId xmlns:a16="http://schemas.microsoft.com/office/drawing/2014/main" id="{E43C919F-6B96-407A-A805-58A1C8718DC5}"/>
+                <a16:creationId xmlns:a16="http://schemas.microsoft.com/office/drawing/2014/main" id="{D67E41CB-3AF5-46C3-8F20-44D7EEB796F6}"/>
               </a:ext>
             </a:extLst>
           </p:cNvPr>
@@ -14351,7 +14351,7 @@
           <p:cNvPr id="10" name="">
             <a:extLst xmlns:a="http://schemas.openxmlformats.org/drawingml/2006/main">
               <a:ext uri="{FF2B5EF4-FFF2-40B4-BE49-F238E27FC236}">
-                <a16:creationId xmlns:a16="http://schemas.microsoft.com/office/drawing/2014/main" id="{145734C8-248B-46AE-802B-F00247611F18}"/>
+                <a16:creationId xmlns:a16="http://schemas.microsoft.com/office/drawing/2014/main" id="{317CABF4-243F-4F60-8547-9BA3C89D9864}"/>
               </a:ext>
             </a:extLst>
           </p:cNvPr>
@@ -14417,7 +14417,7 @@
           <p:cNvPr id="11" name="">
             <a:extLst xmlns:a="http://schemas.openxmlformats.org/drawingml/2006/main">
               <a:ext uri="{FF2B5EF4-FFF2-40B4-BE49-F238E27FC236}">
-                <a16:creationId xmlns:a16="http://schemas.microsoft.com/office/drawing/2014/main" id="{F78784F6-FDA7-4896-BA65-844455B0DD72}"/>
+                <a16:creationId xmlns:a16="http://schemas.microsoft.com/office/drawing/2014/main" id="{CC810E93-561C-4914-BFBF-21B3FE9D7365}"/>
               </a:ext>
             </a:extLst>
           </p:cNvPr>
@@ -14483,7 +14483,7 @@
           <p:cNvPr id="12" name="">
             <a:extLst xmlns:a="http://schemas.openxmlformats.org/drawingml/2006/main">
               <a:ext uri="{FF2B5EF4-FFF2-40B4-BE49-F238E27FC236}">
-                <a16:creationId xmlns:a16="http://schemas.microsoft.com/office/drawing/2014/main" id="{BC9BFBD1-E139-4F57-A9CD-BBA445FD89EE}"/>
+                <a16:creationId xmlns:a16="http://schemas.microsoft.com/office/drawing/2014/main" id="{8054A60B-B1B9-4354-8D13-0DC7860A4790}"/>
               </a:ext>
             </a:extLst>
           </p:cNvPr>
@@ -14549,7 +14549,7 @@
           <p:cNvPr id="13" name="">
             <a:extLst xmlns:a="http://schemas.openxmlformats.org/drawingml/2006/main">
               <a:ext uri="{FF2B5EF4-FFF2-40B4-BE49-F238E27FC236}">
-                <a16:creationId xmlns:a16="http://schemas.microsoft.com/office/drawing/2014/main" id="{692805F6-9298-4CCA-813A-18C3647FB14C}"/>
+                <a16:creationId xmlns:a16="http://schemas.microsoft.com/office/drawing/2014/main" id="{79963398-B67A-4114-845B-83E87B81B5FC}"/>
               </a:ext>
             </a:extLst>
           </p:cNvPr>
@@ -14583,7 +14583,7 @@
           <p:cNvPr id="14" name="">
             <a:extLst xmlns:a="http://schemas.openxmlformats.org/drawingml/2006/main">
               <a:ext uri="{FF2B5EF4-FFF2-40B4-BE49-F238E27FC236}">
-                <a16:creationId xmlns:a16="http://schemas.microsoft.com/office/drawing/2014/main" id="{45DC9C5F-75B6-41EA-ABC9-DD81CBAE9BF7}"/>
+                <a16:creationId xmlns:a16="http://schemas.microsoft.com/office/drawing/2014/main" id="{47443858-E0DA-4FA4-99A6-44436563037C}"/>
               </a:ext>
             </a:extLst>
           </p:cNvPr>
@@ -14649,7 +14649,7 @@
           <p:cNvPr id="15" name="">
             <a:extLst xmlns:a="http://schemas.openxmlformats.org/drawingml/2006/main">
               <a:ext uri="{FF2B5EF4-FFF2-40B4-BE49-F238E27FC236}">
-                <a16:creationId xmlns:a16="http://schemas.microsoft.com/office/drawing/2014/main" id="{C69D72EF-9457-4EB5-8FE4-127B7DCA8458}"/>
+                <a16:creationId xmlns:a16="http://schemas.microsoft.com/office/drawing/2014/main" id="{94719E3B-5DF5-419D-9E0A-0784475B8A84}"/>
               </a:ext>
             </a:extLst>
           </p:cNvPr>
@@ -14715,7 +14715,7 @@
           <p:cNvPr id="16" name="">
             <a:extLst xmlns:a="http://schemas.openxmlformats.org/drawingml/2006/main">
               <a:ext uri="{FF2B5EF4-FFF2-40B4-BE49-F238E27FC236}">
-                <a16:creationId xmlns:a16="http://schemas.microsoft.com/office/drawing/2014/main" id="{6B26A7C0-2CEF-48F0-9A39-9DA35EEB7416}"/>
+                <a16:creationId xmlns:a16="http://schemas.microsoft.com/office/drawing/2014/main" id="{D6D146BF-076C-4B4C-973D-8E54D791BF4F}"/>
               </a:ext>
             </a:extLst>
           </p:cNvPr>
@@ -14781,7 +14781,7 @@
           <p:cNvPr id="17" name="">
             <a:extLst xmlns:a="http://schemas.openxmlformats.org/drawingml/2006/main">
               <a:ext uri="{FF2B5EF4-FFF2-40B4-BE49-F238E27FC236}">
-                <a16:creationId xmlns:a16="http://schemas.microsoft.com/office/drawing/2014/main" id="{EF7D6F74-596C-4008-8A8F-C220B8666208}"/>
+                <a16:creationId xmlns:a16="http://schemas.microsoft.com/office/drawing/2014/main" id="{9E465170-3B4F-4001-BAAF-DCDAA39F17CE}"/>
               </a:ext>
             </a:extLst>
           </p:cNvPr>
@@ -14847,7 +14847,7 @@
           <p:cNvPr id="18" name="">
             <a:extLst xmlns:a="http://schemas.openxmlformats.org/drawingml/2006/main">
               <a:ext uri="{FF2B5EF4-FFF2-40B4-BE49-F238E27FC236}">
-                <a16:creationId xmlns:a16="http://schemas.microsoft.com/office/drawing/2014/main" id="{2B91C8CD-3E05-4756-94DC-1A1B7B41BE45}"/>
+                <a16:creationId xmlns:a16="http://schemas.microsoft.com/office/drawing/2014/main" id="{538E0D07-4A33-4765-B72E-59DED21F85A3}"/>
               </a:ext>
             </a:extLst>
           </p:cNvPr>
@@ -14913,7 +14913,7 @@
           <p:cNvPr id="19" name="">
             <a:extLst xmlns:a="http://schemas.openxmlformats.org/drawingml/2006/main">
               <a:ext uri="{FF2B5EF4-FFF2-40B4-BE49-F238E27FC236}">
-                <a16:creationId xmlns:a16="http://schemas.microsoft.com/office/drawing/2014/main" id="{C46AB556-C086-4762-9327-44298E038F3B}"/>
+                <a16:creationId xmlns:a16="http://schemas.microsoft.com/office/drawing/2014/main" id="{04F95057-8C73-4C53-8F93-219DB1DD5217}"/>
               </a:ext>
             </a:extLst>
           </p:cNvPr>
@@ -14979,7 +14979,7 @@
           <p:cNvPr id="20" name="">
             <a:extLst xmlns:a="http://schemas.openxmlformats.org/drawingml/2006/main">
               <a:ext uri="{FF2B5EF4-FFF2-40B4-BE49-F238E27FC236}">
-                <a16:creationId xmlns:a16="http://schemas.microsoft.com/office/drawing/2014/main" id="{B833F79B-6784-40E7-852D-DDD1BFC520DF}"/>
+                <a16:creationId xmlns:a16="http://schemas.microsoft.com/office/drawing/2014/main" id="{42939714-C3D3-4E76-AAF0-ABEED98E1B61}"/>
               </a:ext>
             </a:extLst>
           </p:cNvPr>
@@ -15045,7 +15045,7 @@
           <p:cNvPr id="21" name="">
             <a:extLst xmlns:a="http://schemas.openxmlformats.org/drawingml/2006/main">
               <a:ext uri="{FF2B5EF4-FFF2-40B4-BE49-F238E27FC236}">
-                <a16:creationId xmlns:a16="http://schemas.microsoft.com/office/drawing/2014/main" id="{FB2AD2F0-391B-4141-85C8-33B604C97B25}"/>
+                <a16:creationId xmlns:a16="http://schemas.microsoft.com/office/drawing/2014/main" id="{47A3BA50-A99A-4A97-934F-8D8BDA215C66}"/>
               </a:ext>
             </a:extLst>
           </p:cNvPr>
@@ -15111,7 +15111,7 @@
           <p:cNvPr id="22" name="">
             <a:extLst xmlns:a="http://schemas.openxmlformats.org/drawingml/2006/main">
               <a:ext uri="{FF2B5EF4-FFF2-40B4-BE49-F238E27FC236}">
-                <a16:creationId xmlns:a16="http://schemas.microsoft.com/office/drawing/2014/main" id="{6224612A-AC85-4301-87E6-2013A5E5996E}"/>
+                <a16:creationId xmlns:a16="http://schemas.microsoft.com/office/drawing/2014/main" id="{21CFB0CD-A763-47FA-AB02-C5ACB16D1577}"/>
               </a:ext>
             </a:extLst>
           </p:cNvPr>
@@ -15175,7 +15175,7 @@
     </p:spTree>
     <p:extLst>
       <p:ext uri="{BB962C8B-B14F-4D97-AF65-F5344CB8AC3E}">
-        <p14:creationId xmlns:p14="http://schemas.microsoft.com/office/powerpoint/2010/main" val="1421442243"/>
+        <p14:creationId xmlns:p14="http://schemas.microsoft.com/office/powerpoint/2010/main" val="410444318"/>
       </p:ext>
     </p:extLst>
   </p:cSld>
@@ -15206,7 +15206,7 @@
           <p:cNvPr id="27" name="">
             <a:extLst xmlns:a="http://schemas.openxmlformats.org/drawingml/2006/main">
               <a:ext uri="{FF2B5EF4-FFF2-40B4-BE49-F238E27FC236}">
-                <a16:creationId xmlns:a16="http://schemas.microsoft.com/office/drawing/2014/main" id="{C7E80226-825A-4FCF-BAC4-6459E6DB76BB}"/>
+                <a16:creationId xmlns:a16="http://schemas.microsoft.com/office/drawing/2014/main" id="{92DC0AA1-BE7D-4C79-9630-AD5B9C6DE8E3}"/>
               </a:ext>
             </a:extLst>
           </p:cNvPr>
@@ -15272,7 +15272,7 @@
           <p:cNvPr id="2" name="">
             <a:extLst xmlns:a="http://schemas.openxmlformats.org/drawingml/2006/main">
               <a:ext uri="{FF2B5EF4-FFF2-40B4-BE49-F238E27FC236}">
-                <a16:creationId xmlns:a16="http://schemas.microsoft.com/office/drawing/2014/main" id="{69DC51E2-C178-42D5-BC4C-2E7EB62252AC}"/>
+                <a16:creationId xmlns:a16="http://schemas.microsoft.com/office/drawing/2014/main" id="{F9901DF2-5074-49D3-BAA7-CB135CE4E10B}"/>
               </a:ext>
             </a:extLst>
           </p:cNvPr>
@@ -15338,7 +15338,7 @@
           <p:cNvPr id="3" name="">
             <a:extLst xmlns:a="http://schemas.openxmlformats.org/drawingml/2006/main">
               <a:ext uri="{FF2B5EF4-FFF2-40B4-BE49-F238E27FC236}">
-                <a16:creationId xmlns:a16="http://schemas.microsoft.com/office/drawing/2014/main" id="{8D2C232A-EB2C-43F6-B7F6-1E491973E5F7}"/>
+                <a16:creationId xmlns:a16="http://schemas.microsoft.com/office/drawing/2014/main" id="{42967F57-B6A7-4472-BC03-1A0AB63EA5EC}"/>
               </a:ext>
             </a:extLst>
           </p:cNvPr>
@@ -15370,7 +15370,7 @@
           <p:cNvPr id="4" name="">
             <a:extLst xmlns:a="http://schemas.openxmlformats.org/drawingml/2006/main">
               <a:ext uri="{FF2B5EF4-FFF2-40B4-BE49-F238E27FC236}">
-                <a16:creationId xmlns:a16="http://schemas.microsoft.com/office/drawing/2014/main" id="{C6B357E8-08B8-483B-B8AB-CC860EC03B9A}"/>
+                <a16:creationId xmlns:a16="http://schemas.microsoft.com/office/drawing/2014/main" id="{A07EC0FF-6634-436A-8522-10A8687FFEA9}"/>
               </a:ext>
             </a:extLst>
           </p:cNvPr>
@@ -15436,7 +15436,7 @@
           <p:cNvPr id="5" name="">
             <a:extLst xmlns:a="http://schemas.openxmlformats.org/drawingml/2006/main">
               <a:ext uri="{FF2B5EF4-FFF2-40B4-BE49-F238E27FC236}">
-                <a16:creationId xmlns:a16="http://schemas.microsoft.com/office/drawing/2014/main" id="{70493063-4D20-4929-9411-2D653F4731B0}"/>
+                <a16:creationId xmlns:a16="http://schemas.microsoft.com/office/drawing/2014/main" id="{76B6852B-E5B4-403B-A288-EA9EEDF30D6C}"/>
               </a:ext>
             </a:extLst>
           </p:cNvPr>
@@ -15502,7 +15502,7 @@
           <p:cNvPr id="6" name="">
             <a:extLst xmlns:a="http://schemas.openxmlformats.org/drawingml/2006/main">
               <a:ext uri="{FF2B5EF4-FFF2-40B4-BE49-F238E27FC236}">
-                <a16:creationId xmlns:a16="http://schemas.microsoft.com/office/drawing/2014/main" id="{98EE4D1B-60E6-46DA-BE61-A4DA44F49482}"/>
+                <a16:creationId xmlns:a16="http://schemas.microsoft.com/office/drawing/2014/main" id="{160DB11C-B935-4DD1-965D-FDE3A2051B13}"/>
               </a:ext>
             </a:extLst>
           </p:cNvPr>
@@ -15568,7 +15568,7 @@
           <p:cNvPr id="7" name="">
             <a:extLst xmlns:a="http://schemas.openxmlformats.org/drawingml/2006/main">
               <a:ext uri="{FF2B5EF4-FFF2-40B4-BE49-F238E27FC236}">
-                <a16:creationId xmlns:a16="http://schemas.microsoft.com/office/drawing/2014/main" id="{E0B41AF5-A1F3-4FBA-9B42-1971562F563C}"/>
+                <a16:creationId xmlns:a16="http://schemas.microsoft.com/office/drawing/2014/main" id="{172CD6D2-DA1D-4F02-A434-CB4090C98B65}"/>
               </a:ext>
             </a:extLst>
           </p:cNvPr>
@@ -15600,7 +15600,7 @@
           <p:cNvPr id="8" name="">
             <a:extLst xmlns:a="http://schemas.openxmlformats.org/drawingml/2006/main">
               <a:ext uri="{FF2B5EF4-FFF2-40B4-BE49-F238E27FC236}">
-                <a16:creationId xmlns:a16="http://schemas.microsoft.com/office/drawing/2014/main" id="{525464E9-9BCF-41C5-8FEB-4311D9BCCFEF}"/>
+                <a16:creationId xmlns:a16="http://schemas.microsoft.com/office/drawing/2014/main" id="{DA960926-9EC4-429C-A052-E07392B05B92}"/>
               </a:ext>
             </a:extLst>
           </p:cNvPr>
@@ -15666,7 +15666,7 @@
           <p:cNvPr id="9" name="">
             <a:extLst xmlns:a="http://schemas.openxmlformats.org/drawingml/2006/main">
               <a:ext uri="{FF2B5EF4-FFF2-40B4-BE49-F238E27FC236}">
-                <a16:creationId xmlns:a16="http://schemas.microsoft.com/office/drawing/2014/main" id="{7AE8DA3F-1E26-482F-A4A7-259C9BBC25A9}"/>
+                <a16:creationId xmlns:a16="http://schemas.microsoft.com/office/drawing/2014/main" id="{D6C277ED-60DE-4F70-BD3D-BF7E6FCE28E5}"/>
               </a:ext>
             </a:extLst>
           </p:cNvPr>
@@ -15732,7 +15732,7 @@
           <p:cNvPr id="10" name="">
             <a:extLst xmlns:a="http://schemas.openxmlformats.org/drawingml/2006/main">
               <a:ext uri="{FF2B5EF4-FFF2-40B4-BE49-F238E27FC236}">
-                <a16:creationId xmlns:a16="http://schemas.microsoft.com/office/drawing/2014/main" id="{62C8F906-057E-4D7B-84EB-AA9083FA32A5}"/>
+                <a16:creationId xmlns:a16="http://schemas.microsoft.com/office/drawing/2014/main" id="{E1D88DCC-C0D0-4FCC-B3E6-E21CDA28056E}"/>
               </a:ext>
             </a:extLst>
           </p:cNvPr>
@@ -15798,7 +15798,7 @@
           <p:cNvPr id="11" name="">
             <a:extLst xmlns:a="http://schemas.openxmlformats.org/drawingml/2006/main">
               <a:ext uri="{FF2B5EF4-FFF2-40B4-BE49-F238E27FC236}">
-                <a16:creationId xmlns:a16="http://schemas.microsoft.com/office/drawing/2014/main" id="{66E5AC19-5D23-4C57-975B-77950AB875F1}"/>
+                <a16:creationId xmlns:a16="http://schemas.microsoft.com/office/drawing/2014/main" id="{0A26A89F-8523-46E5-ABB4-E715791DB4BF}"/>
               </a:ext>
             </a:extLst>
           </p:cNvPr>
@@ -15830,7 +15830,7 @@
           <p:cNvPr id="12" name="">
             <a:extLst xmlns:a="http://schemas.openxmlformats.org/drawingml/2006/main">
               <a:ext uri="{FF2B5EF4-FFF2-40B4-BE49-F238E27FC236}">
-                <a16:creationId xmlns:a16="http://schemas.microsoft.com/office/drawing/2014/main" id="{01247C79-DCDA-4E90-9EBF-696233BCBF8D}"/>
+                <a16:creationId xmlns:a16="http://schemas.microsoft.com/office/drawing/2014/main" id="{B308E0FB-33B1-4BF9-B5B3-ADE75BD90EF3}"/>
               </a:ext>
             </a:extLst>
           </p:cNvPr>
@@ -15864,7 +15864,7 @@
           <p:cNvPr id="13" name="">
             <a:extLst xmlns:a="http://schemas.openxmlformats.org/drawingml/2006/main">
               <a:ext uri="{FF2B5EF4-FFF2-40B4-BE49-F238E27FC236}">
-                <a16:creationId xmlns:a16="http://schemas.microsoft.com/office/drawing/2014/main" id="{21B9BE38-7726-40A1-9707-0EFF37466CD2}"/>
+                <a16:creationId xmlns:a16="http://schemas.microsoft.com/office/drawing/2014/main" id="{0E55C497-05AD-4AE9-AEAB-CC1426FBD6CF}"/>
               </a:ext>
             </a:extLst>
           </p:cNvPr>
@@ -15930,7 +15930,7 @@
           <p:cNvPr id="14" name="">
             <a:extLst xmlns:a="http://schemas.openxmlformats.org/drawingml/2006/main">
               <a:ext uri="{FF2B5EF4-FFF2-40B4-BE49-F238E27FC236}">
-                <a16:creationId xmlns:a16="http://schemas.microsoft.com/office/drawing/2014/main" id="{F80C26B1-993F-4D7C-BDAC-5ECBFD89AB3B}"/>
+                <a16:creationId xmlns:a16="http://schemas.microsoft.com/office/drawing/2014/main" id="{1E0C86CC-000B-4FDF-BA47-31C1C1016F83}"/>
               </a:ext>
             </a:extLst>
           </p:cNvPr>
@@ -15996,7 +15996,7 @@
           <p:cNvPr id="15" name="">
             <a:extLst xmlns:a="http://schemas.openxmlformats.org/drawingml/2006/main">
               <a:ext uri="{FF2B5EF4-FFF2-40B4-BE49-F238E27FC236}">
-                <a16:creationId xmlns:a16="http://schemas.microsoft.com/office/drawing/2014/main" id="{D010E47E-E3FE-4B59-9918-91B5A59F109A}"/>
+                <a16:creationId xmlns:a16="http://schemas.microsoft.com/office/drawing/2014/main" id="{65BBF29E-7C7D-4C49-8565-91DF3B002D80}"/>
               </a:ext>
             </a:extLst>
           </p:cNvPr>
@@ -16062,7 +16062,7 @@
           <p:cNvPr id="16" name="">
             <a:extLst xmlns:a="http://schemas.openxmlformats.org/drawingml/2006/main">
               <a:ext uri="{FF2B5EF4-FFF2-40B4-BE49-F238E27FC236}">
-                <a16:creationId xmlns:a16="http://schemas.microsoft.com/office/drawing/2014/main" id="{CDD232E7-63B6-49AA-AFE3-D0D0AA9C24CC}"/>
+                <a16:creationId xmlns:a16="http://schemas.microsoft.com/office/drawing/2014/main" id="{36F7C55E-ADD7-4230-9BBF-7B2905B7E4B0}"/>
               </a:ext>
             </a:extLst>
           </p:cNvPr>
@@ -16094,7 +16094,7 @@
           <p:cNvPr id="17" name="">
             <a:extLst xmlns:a="http://schemas.openxmlformats.org/drawingml/2006/main">
               <a:ext uri="{FF2B5EF4-FFF2-40B4-BE49-F238E27FC236}">
-                <a16:creationId xmlns:a16="http://schemas.microsoft.com/office/drawing/2014/main" id="{F38396DF-069C-4D58-99B6-30E901C8C271}"/>
+                <a16:creationId xmlns:a16="http://schemas.microsoft.com/office/drawing/2014/main" id="{E29A250B-1E6D-4E64-9F6E-81C21FD13A97}"/>
               </a:ext>
             </a:extLst>
           </p:cNvPr>
@@ -16160,7 +16160,7 @@
           <p:cNvPr id="18" name="">
             <a:extLst xmlns:a="http://schemas.openxmlformats.org/drawingml/2006/main">
               <a:ext uri="{FF2B5EF4-FFF2-40B4-BE49-F238E27FC236}">
-                <a16:creationId xmlns:a16="http://schemas.microsoft.com/office/drawing/2014/main" id="{2DABC2B2-ADAD-4E08-9623-C684CBE2EA9E}"/>
+                <a16:creationId xmlns:a16="http://schemas.microsoft.com/office/drawing/2014/main" id="{C4E57579-3CB6-4456-BBBA-B99BFABE2E85}"/>
               </a:ext>
             </a:extLst>
           </p:cNvPr>
@@ -16226,7 +16226,7 @@
           <p:cNvPr id="19" name="">
             <a:extLst xmlns:a="http://schemas.openxmlformats.org/drawingml/2006/main">
               <a:ext uri="{FF2B5EF4-FFF2-40B4-BE49-F238E27FC236}">
-                <a16:creationId xmlns:a16="http://schemas.microsoft.com/office/drawing/2014/main" id="{856B6F94-F543-4DE1-85DE-A0A9FBA6725C}"/>
+                <a16:creationId xmlns:a16="http://schemas.microsoft.com/office/drawing/2014/main" id="{4525FB82-2611-4F08-B78D-9FF7BD76DE57}"/>
               </a:ext>
             </a:extLst>
           </p:cNvPr>
@@ -16292,7 +16292,7 @@
           <p:cNvPr id="20" name="">
             <a:extLst xmlns:a="http://schemas.openxmlformats.org/drawingml/2006/main">
               <a:ext uri="{FF2B5EF4-FFF2-40B4-BE49-F238E27FC236}">
-                <a16:creationId xmlns:a16="http://schemas.microsoft.com/office/drawing/2014/main" id="{34A84E7A-F05C-4E37-B2D2-E3A0E1B2D3D7}"/>
+                <a16:creationId xmlns:a16="http://schemas.microsoft.com/office/drawing/2014/main" id="{D51EBA78-BD10-4883-A49B-2F5EBDF7E920}"/>
               </a:ext>
             </a:extLst>
           </p:cNvPr>
@@ -16324,7 +16324,7 @@
           <p:cNvPr id="21" name="">
             <a:extLst xmlns:a="http://schemas.openxmlformats.org/drawingml/2006/main">
               <a:ext uri="{FF2B5EF4-FFF2-40B4-BE49-F238E27FC236}">
-                <a16:creationId xmlns:a16="http://schemas.microsoft.com/office/drawing/2014/main" id="{9E3E2CFE-D756-4EC9-AABF-4FF892D26DA0}"/>
+                <a16:creationId xmlns:a16="http://schemas.microsoft.com/office/drawing/2014/main" id="{6B377665-1470-41D1-8D40-F9E32E574D20}"/>
               </a:ext>
             </a:extLst>
           </p:cNvPr>
@@ -16390,7 +16390,7 @@
           <p:cNvPr id="22" name="">
             <a:extLst xmlns:a="http://schemas.openxmlformats.org/drawingml/2006/main">
               <a:ext uri="{FF2B5EF4-FFF2-40B4-BE49-F238E27FC236}">
-                <a16:creationId xmlns:a16="http://schemas.microsoft.com/office/drawing/2014/main" id="{07556827-49ED-422D-9175-1B9A2E133A9E}"/>
+                <a16:creationId xmlns:a16="http://schemas.microsoft.com/office/drawing/2014/main" id="{8B41F348-9BD7-4093-BCBA-842D8BBD98A3}"/>
               </a:ext>
             </a:extLst>
           </p:cNvPr>
@@ -16456,7 +16456,7 @@
           <p:cNvPr id="23" name="">
             <a:extLst xmlns:a="http://schemas.openxmlformats.org/drawingml/2006/main">
               <a:ext uri="{FF2B5EF4-FFF2-40B4-BE49-F238E27FC236}">
-                <a16:creationId xmlns:a16="http://schemas.microsoft.com/office/drawing/2014/main" id="{F7025352-1513-4648-812B-985C54FE658F}"/>
+                <a16:creationId xmlns:a16="http://schemas.microsoft.com/office/drawing/2014/main" id="{EBF064BF-C3BB-4808-A6FE-4521A04E5EAB}"/>
               </a:ext>
             </a:extLst>
           </p:cNvPr>
@@ -16522,7 +16522,7 @@
           <p:cNvPr id="24" name="">
             <a:extLst xmlns:a="http://schemas.openxmlformats.org/drawingml/2006/main">
               <a:ext uri="{FF2B5EF4-FFF2-40B4-BE49-F238E27FC236}">
-                <a16:creationId xmlns:a16="http://schemas.microsoft.com/office/drawing/2014/main" id="{8F035EE4-3D53-4725-AD53-4BD9B476EE9F}"/>
+                <a16:creationId xmlns:a16="http://schemas.microsoft.com/office/drawing/2014/main" id="{E622605E-9E60-40E3-BCFA-DF0041F42037}"/>
               </a:ext>
             </a:extLst>
           </p:cNvPr>
@@ -16588,7 +16588,7 @@
           <p:cNvPr id="25" name="">
             <a:extLst xmlns:a="http://schemas.openxmlformats.org/drawingml/2006/main">
               <a:ext uri="{FF2B5EF4-FFF2-40B4-BE49-F238E27FC236}">
-                <a16:creationId xmlns:a16="http://schemas.microsoft.com/office/drawing/2014/main" id="{D7C48045-A3ED-4B50-A06B-BEBBFDDF9E8B}"/>
+                <a16:creationId xmlns:a16="http://schemas.microsoft.com/office/drawing/2014/main" id="{E74CAB56-A521-447F-8E5B-BD6B6C4A029C}"/>
               </a:ext>
             </a:extLst>
           </p:cNvPr>
@@ -16654,7 +16654,7 @@
           <p:cNvPr id="26" name="">
             <a:extLst xmlns:a="http://schemas.openxmlformats.org/drawingml/2006/main">
               <a:ext uri="{FF2B5EF4-FFF2-40B4-BE49-F238E27FC236}">
-                <a16:creationId xmlns:a16="http://schemas.microsoft.com/office/drawing/2014/main" id="{4E23D656-7564-4A9F-9CE8-A101AB9049C0}"/>
+                <a16:creationId xmlns:a16="http://schemas.microsoft.com/office/drawing/2014/main" id="{08709761-E4B6-40AE-9C4A-B589FA8060CD}"/>
               </a:ext>
             </a:extLst>
           </p:cNvPr>
@@ -16718,7 +16718,7 @@
     </p:spTree>
     <p:extLst>
       <p:ext uri="{BB962C8B-B14F-4D97-AF65-F5344CB8AC3E}">
-        <p14:creationId xmlns:p14="http://schemas.microsoft.com/office/powerpoint/2010/main" val="1557611315"/>
+        <p14:creationId xmlns:p14="http://schemas.microsoft.com/office/powerpoint/2010/main" val="758726400"/>
       </p:ext>
     </p:extLst>
   </p:cSld>
@@ -16749,7 +16749,7 @@
           <p:cNvPr id="21" name="">
             <a:extLst xmlns:a="http://schemas.openxmlformats.org/drawingml/2006/main">
               <a:ext uri="{FF2B5EF4-FFF2-40B4-BE49-F238E27FC236}">
-                <a16:creationId xmlns:a16="http://schemas.microsoft.com/office/drawing/2014/main" id="{A90A30DA-ED1C-431E-9E50-14A4CB551026}"/>
+                <a16:creationId xmlns:a16="http://schemas.microsoft.com/office/drawing/2014/main" id="{C929F222-8872-42C6-B9E7-1F00338697E6}"/>
               </a:ext>
             </a:extLst>
           </p:cNvPr>
@@ -16815,7 +16815,7 @@
           <p:cNvPr id="2" name="">
             <a:extLst xmlns:a="http://schemas.openxmlformats.org/drawingml/2006/main">
               <a:ext uri="{FF2B5EF4-FFF2-40B4-BE49-F238E27FC236}">
-                <a16:creationId xmlns:a16="http://schemas.microsoft.com/office/drawing/2014/main" id="{F1D2E0BD-0E0E-4604-AE6D-307B240441D2}"/>
+                <a16:creationId xmlns:a16="http://schemas.microsoft.com/office/drawing/2014/main" id="{A6345953-E5A7-410F-8EB1-22E21699E2BA}"/>
               </a:ext>
             </a:extLst>
           </p:cNvPr>
@@ -16881,7 +16881,7 @@
           <p:cNvPr id="3" name="">
             <a:extLst xmlns:a="http://schemas.openxmlformats.org/drawingml/2006/main">
               <a:ext uri="{FF2B5EF4-FFF2-40B4-BE49-F238E27FC236}">
-                <a16:creationId xmlns:a16="http://schemas.microsoft.com/office/drawing/2014/main" id="{12582411-B9F0-49E2-8C09-96DDE2DC1A97}"/>
+                <a16:creationId xmlns:a16="http://schemas.microsoft.com/office/drawing/2014/main" id="{4D11F182-7DA8-4673-A10F-0287DBB6C6DE}"/>
               </a:ext>
             </a:extLst>
           </p:cNvPr>
@@ -16913,7 +16913,7 @@
           <p:cNvPr id="4" name="">
             <a:extLst xmlns:a="http://schemas.openxmlformats.org/drawingml/2006/main">
               <a:ext uri="{FF2B5EF4-FFF2-40B4-BE49-F238E27FC236}">
-                <a16:creationId xmlns:a16="http://schemas.microsoft.com/office/drawing/2014/main" id="{9B57DC31-3ED7-45C2-9AA6-BB12950BCDCE}"/>
+                <a16:creationId xmlns:a16="http://schemas.microsoft.com/office/drawing/2014/main" id="{536F7179-263A-4922-90A1-08E1AB447A1B}"/>
               </a:ext>
             </a:extLst>
           </p:cNvPr>
@@ -16947,7 +16947,7 @@
           <p:cNvPr id="5" name="">
             <a:extLst xmlns:a="http://schemas.openxmlformats.org/drawingml/2006/main">
               <a:ext uri="{FF2B5EF4-FFF2-40B4-BE49-F238E27FC236}">
-                <a16:creationId xmlns:a16="http://schemas.microsoft.com/office/drawing/2014/main" id="{90AAA23B-1166-46D1-AA54-3E6A7553DD62}"/>
+                <a16:creationId xmlns:a16="http://schemas.microsoft.com/office/drawing/2014/main" id="{C2DFF604-5EE4-4FC7-A332-B5B4C1629AC9}"/>
               </a:ext>
             </a:extLst>
           </p:cNvPr>
@@ -17013,7 +17013,7 @@
           <p:cNvPr id="6" name="">
             <a:extLst xmlns:a="http://schemas.openxmlformats.org/drawingml/2006/main">
               <a:ext uri="{FF2B5EF4-FFF2-40B4-BE49-F238E27FC236}">
-                <a16:creationId xmlns:a16="http://schemas.microsoft.com/office/drawing/2014/main" id="{B146C13F-BD5B-44A3-8B8D-66C79AF3DDEC}"/>
+                <a16:creationId xmlns:a16="http://schemas.microsoft.com/office/drawing/2014/main" id="{8831D1FF-7698-4927-8DB1-76957CB3C6AA}"/>
               </a:ext>
             </a:extLst>
           </p:cNvPr>
@@ -17079,7 +17079,7 @@
           <p:cNvPr id="7" name="">
             <a:extLst xmlns:a="http://schemas.openxmlformats.org/drawingml/2006/main">
               <a:ext uri="{FF2B5EF4-FFF2-40B4-BE49-F238E27FC236}">
-                <a16:creationId xmlns:a16="http://schemas.microsoft.com/office/drawing/2014/main" id="{CF6ACAD3-7C64-407C-BB45-06999392E857}"/>
+                <a16:creationId xmlns:a16="http://schemas.microsoft.com/office/drawing/2014/main" id="{1398AD8A-35A8-4A3A-A383-2218F06655FF}"/>
               </a:ext>
             </a:extLst>
           </p:cNvPr>
@@ -17111,7 +17111,7 @@
           <p:cNvPr id="8" name="">
             <a:extLst xmlns:a="http://schemas.openxmlformats.org/drawingml/2006/main">
               <a:ext uri="{FF2B5EF4-FFF2-40B4-BE49-F238E27FC236}">
-                <a16:creationId xmlns:a16="http://schemas.microsoft.com/office/drawing/2014/main" id="{6BB2001C-3322-4B3C-ABA1-B58541BAD3D5}"/>
+                <a16:creationId xmlns:a16="http://schemas.microsoft.com/office/drawing/2014/main" id="{338D3E45-9F71-4A14-A7CF-D55856CD4C67}"/>
               </a:ext>
             </a:extLst>
           </p:cNvPr>
@@ -17145,7 +17145,7 @@
           <p:cNvPr id="9" name="">
             <a:extLst xmlns:a="http://schemas.openxmlformats.org/drawingml/2006/main">
               <a:ext uri="{FF2B5EF4-FFF2-40B4-BE49-F238E27FC236}">
-                <a16:creationId xmlns:a16="http://schemas.microsoft.com/office/drawing/2014/main" id="{12831CAE-081D-4F1A-A493-F52D74183888}"/>
+                <a16:creationId xmlns:a16="http://schemas.microsoft.com/office/drawing/2014/main" id="{F6C5EA68-2DE6-4EF6-A8F5-09D5503CAF34}"/>
               </a:ext>
             </a:extLst>
           </p:cNvPr>
@@ -17211,7 +17211,7 @@
           <p:cNvPr id="10" name="">
             <a:extLst xmlns:a="http://schemas.openxmlformats.org/drawingml/2006/main">
               <a:ext uri="{FF2B5EF4-FFF2-40B4-BE49-F238E27FC236}">
-                <a16:creationId xmlns:a16="http://schemas.microsoft.com/office/drawing/2014/main" id="{C12309A7-9A86-4EA9-8382-5171B91054AB}"/>
+                <a16:creationId xmlns:a16="http://schemas.microsoft.com/office/drawing/2014/main" id="{767E6C64-5521-4761-A3A4-07EF69CA9719}"/>
               </a:ext>
             </a:extLst>
           </p:cNvPr>
@@ -17277,7 +17277,7 @@
           <p:cNvPr id="11" name="">
             <a:extLst xmlns:a="http://schemas.openxmlformats.org/drawingml/2006/main">
               <a:ext uri="{FF2B5EF4-FFF2-40B4-BE49-F238E27FC236}">
-                <a16:creationId xmlns:a16="http://schemas.microsoft.com/office/drawing/2014/main" id="{FE26994C-8EF7-4D01-8EEA-5F5F1F616174}"/>
+                <a16:creationId xmlns:a16="http://schemas.microsoft.com/office/drawing/2014/main" id="{F4DA2985-7266-470D-9765-17EB442DF501}"/>
               </a:ext>
             </a:extLst>
           </p:cNvPr>
@@ -17309,7 +17309,7 @@
           <p:cNvPr id="12" name="">
             <a:extLst xmlns:a="http://schemas.openxmlformats.org/drawingml/2006/main">
               <a:ext uri="{FF2B5EF4-FFF2-40B4-BE49-F238E27FC236}">
-                <a16:creationId xmlns:a16="http://schemas.microsoft.com/office/drawing/2014/main" id="{6F9B21E1-8F2A-4B0F-8D63-8003F397E79E}"/>
+                <a16:creationId xmlns:a16="http://schemas.microsoft.com/office/drawing/2014/main" id="{34AC2130-E5D1-442C-BC8F-6BC8BAE7BA17}"/>
               </a:ext>
             </a:extLst>
           </p:cNvPr>
@@ -17343,7 +17343,7 @@
           <p:cNvPr id="13" name="">
             <a:extLst xmlns:a="http://schemas.openxmlformats.org/drawingml/2006/main">
               <a:ext uri="{FF2B5EF4-FFF2-40B4-BE49-F238E27FC236}">
-                <a16:creationId xmlns:a16="http://schemas.microsoft.com/office/drawing/2014/main" id="{37027F96-548D-471A-9E83-B84B789A1F54}"/>
+                <a16:creationId xmlns:a16="http://schemas.microsoft.com/office/drawing/2014/main" id="{82CFB017-13DE-4792-AF57-EB479924BE90}"/>
               </a:ext>
             </a:extLst>
           </p:cNvPr>
@@ -17409,7 +17409,7 @@
           <p:cNvPr id="14" name="">
             <a:extLst xmlns:a="http://schemas.openxmlformats.org/drawingml/2006/main">
               <a:ext uri="{FF2B5EF4-FFF2-40B4-BE49-F238E27FC236}">
-                <a16:creationId xmlns:a16="http://schemas.microsoft.com/office/drawing/2014/main" id="{09E0152C-B4AD-4F3D-ABD6-B10DCCA21BA8}"/>
+                <a16:creationId xmlns:a16="http://schemas.microsoft.com/office/drawing/2014/main" id="{2739DE69-95D1-4312-96E1-DDB1292A75AA}"/>
               </a:ext>
             </a:extLst>
           </p:cNvPr>
@@ -17475,7 +17475,7 @@
           <p:cNvPr id="15" name="">
             <a:extLst xmlns:a="http://schemas.openxmlformats.org/drawingml/2006/main">
               <a:ext uri="{FF2B5EF4-FFF2-40B4-BE49-F238E27FC236}">
-                <a16:creationId xmlns:a16="http://schemas.microsoft.com/office/drawing/2014/main" id="{01C6020D-EFFB-4B4D-AC6C-45B73174FC19}"/>
+                <a16:creationId xmlns:a16="http://schemas.microsoft.com/office/drawing/2014/main" id="{73A32601-CE09-442C-A8CB-CFE374C75D34}"/>
               </a:ext>
             </a:extLst>
           </p:cNvPr>
@@ -17541,7 +17541,7 @@
           <p:cNvPr id="16" name="">
             <a:extLst xmlns:a="http://schemas.openxmlformats.org/drawingml/2006/main">
               <a:ext uri="{FF2B5EF4-FFF2-40B4-BE49-F238E27FC236}">
-                <a16:creationId xmlns:a16="http://schemas.microsoft.com/office/drawing/2014/main" id="{7A27D17F-FF33-4BAD-BBAC-F54F2EF74884}"/>
+                <a16:creationId xmlns:a16="http://schemas.microsoft.com/office/drawing/2014/main" id="{2C2D545D-988A-43BE-A788-B8F7B7401DEE}"/>
               </a:ext>
             </a:extLst>
           </p:cNvPr>
@@ -17607,7 +17607,7 @@
           <p:cNvPr id="17" name="">
             <a:extLst xmlns:a="http://schemas.openxmlformats.org/drawingml/2006/main">
               <a:ext uri="{FF2B5EF4-FFF2-40B4-BE49-F238E27FC236}">
-                <a16:creationId xmlns:a16="http://schemas.microsoft.com/office/drawing/2014/main" id="{DA4D6000-D447-4DA9-ACBB-E44F78B92759}"/>
+                <a16:creationId xmlns:a16="http://schemas.microsoft.com/office/drawing/2014/main" id="{C6A812D2-9C30-4CD9-9E74-37301EE4762B}"/>
               </a:ext>
             </a:extLst>
           </p:cNvPr>
@@ -17673,7 +17673,7 @@
           <p:cNvPr id="18" name="">
             <a:extLst xmlns:a="http://schemas.openxmlformats.org/drawingml/2006/main">
               <a:ext uri="{FF2B5EF4-FFF2-40B4-BE49-F238E27FC236}">
-                <a16:creationId xmlns:a16="http://schemas.microsoft.com/office/drawing/2014/main" id="{C12423C4-7025-4654-9FD9-46215B58DBDF}"/>
+                <a16:creationId xmlns:a16="http://schemas.microsoft.com/office/drawing/2014/main" id="{FD584A9F-B415-488C-887E-DABAEE886F68}"/>
               </a:ext>
             </a:extLst>
           </p:cNvPr>
@@ -17739,7 +17739,7 @@
           <p:cNvPr id="19" name="">
             <a:extLst xmlns:a="http://schemas.openxmlformats.org/drawingml/2006/main">
               <a:ext uri="{FF2B5EF4-FFF2-40B4-BE49-F238E27FC236}">
-                <a16:creationId xmlns:a16="http://schemas.microsoft.com/office/drawing/2014/main" id="{8BB79DED-B787-4ACD-A847-2743B546E74B}"/>
+                <a16:creationId xmlns:a16="http://schemas.microsoft.com/office/drawing/2014/main" id="{4F788A69-5FC5-4C76-8852-B7BF08089C31}"/>
               </a:ext>
             </a:extLst>
           </p:cNvPr>
@@ -17805,7 +17805,7 @@
           <p:cNvPr id="20" name="">
             <a:extLst xmlns:a="http://schemas.openxmlformats.org/drawingml/2006/main">
               <a:ext uri="{FF2B5EF4-FFF2-40B4-BE49-F238E27FC236}">
-                <a16:creationId xmlns:a16="http://schemas.microsoft.com/office/drawing/2014/main" id="{77F980F0-0CE1-4203-918C-7883E77E9EFA}"/>
+                <a16:creationId xmlns:a16="http://schemas.microsoft.com/office/drawing/2014/main" id="{F15A9A07-6515-4EBC-A950-D4AEE0A50A4A}"/>
               </a:ext>
             </a:extLst>
           </p:cNvPr>
@@ -17869,7 +17869,7 @@
     </p:spTree>
     <p:extLst>
       <p:ext uri="{BB962C8B-B14F-4D97-AF65-F5344CB8AC3E}">
-        <p14:creationId xmlns:p14="http://schemas.microsoft.com/office/powerpoint/2010/main" val="1100871819"/>
+        <p14:creationId xmlns:p14="http://schemas.microsoft.com/office/powerpoint/2010/main" val="1532028708"/>
       </p:ext>
     </p:extLst>
   </p:cSld>
@@ -17900,7 +17900,7 @@
           <p:cNvPr id="22" name="">
             <a:extLst xmlns:a="http://schemas.openxmlformats.org/drawingml/2006/main">
               <a:ext uri="{FF2B5EF4-FFF2-40B4-BE49-F238E27FC236}">
-                <a16:creationId xmlns:a16="http://schemas.microsoft.com/office/drawing/2014/main" id="{C50EF600-C71E-4D97-A526-49C32B436FEC}"/>
+                <a16:creationId xmlns:a16="http://schemas.microsoft.com/office/drawing/2014/main" id="{C5E59A89-B563-4E8B-B84A-7F178F082F1E}"/>
               </a:ext>
             </a:extLst>
           </p:cNvPr>
@@ -17966,7 +17966,7 @@
           <p:cNvPr id="2" name="">
             <a:extLst xmlns:a="http://schemas.openxmlformats.org/drawingml/2006/main">
               <a:ext uri="{FF2B5EF4-FFF2-40B4-BE49-F238E27FC236}">
-                <a16:creationId xmlns:a16="http://schemas.microsoft.com/office/drawing/2014/main" id="{87F09C67-A04E-452D-BD1E-09C3BBA18B4A}"/>
+                <a16:creationId xmlns:a16="http://schemas.microsoft.com/office/drawing/2014/main" id="{C99F8995-09FE-43E5-B56F-83DEE8A5324D}"/>
               </a:ext>
             </a:extLst>
           </p:cNvPr>
@@ -18032,7 +18032,7 @@
           <p:cNvPr id="3" name="">
             <a:extLst xmlns:a="http://schemas.openxmlformats.org/drawingml/2006/main">
               <a:ext uri="{FF2B5EF4-FFF2-40B4-BE49-F238E27FC236}">
-                <a16:creationId xmlns:a16="http://schemas.microsoft.com/office/drawing/2014/main" id="{D8916202-A221-4035-8347-41DC889DA6B9}"/>
+                <a16:creationId xmlns:a16="http://schemas.microsoft.com/office/drawing/2014/main" id="{97A10C4E-6462-4F2F-A969-349E17050C7B}"/>
               </a:ext>
             </a:extLst>
           </p:cNvPr>
@@ -18064,7 +18064,7 @@
           <p:cNvPr id="4" name="">
             <a:extLst xmlns:a="http://schemas.openxmlformats.org/drawingml/2006/main">
               <a:ext uri="{FF2B5EF4-FFF2-40B4-BE49-F238E27FC236}">
-                <a16:creationId xmlns:a16="http://schemas.microsoft.com/office/drawing/2014/main" id="{0F5DA5F5-16E8-4E6B-8150-5FE26B1D8F54}"/>
+                <a16:creationId xmlns:a16="http://schemas.microsoft.com/office/drawing/2014/main" id="{74877E48-03AC-4A0A-A187-9619FB611714}"/>
               </a:ext>
             </a:extLst>
           </p:cNvPr>
@@ -18098,7 +18098,7 @@
           <p:cNvPr id="5" name="">
             <a:extLst xmlns:a="http://schemas.openxmlformats.org/drawingml/2006/main">
               <a:ext uri="{FF2B5EF4-FFF2-40B4-BE49-F238E27FC236}">
-                <a16:creationId xmlns:a16="http://schemas.microsoft.com/office/drawing/2014/main" id="{FF1A7032-B4A4-41AC-8CD3-4ED3FF0491AA}"/>
+                <a16:creationId xmlns:a16="http://schemas.microsoft.com/office/drawing/2014/main" id="{897A73DE-138C-4573-A19F-AE597A7677E1}"/>
               </a:ext>
             </a:extLst>
           </p:cNvPr>
@@ -18164,7 +18164,7 @@
           <p:cNvPr id="6" name="">
             <a:extLst xmlns:a="http://schemas.openxmlformats.org/drawingml/2006/main">
               <a:ext uri="{FF2B5EF4-FFF2-40B4-BE49-F238E27FC236}">
-                <a16:creationId xmlns:a16="http://schemas.microsoft.com/office/drawing/2014/main" id="{F8876DF7-8089-4C5E-A872-BF285AAC3FCA}"/>
+                <a16:creationId xmlns:a16="http://schemas.microsoft.com/office/drawing/2014/main" id="{A48FF419-7BF8-4904-AAA4-C1FC6C2A3A5D}"/>
               </a:ext>
             </a:extLst>
           </p:cNvPr>
@@ -18230,7 +18230,7 @@
           <p:cNvPr id="7" name="">
             <a:extLst xmlns:a="http://schemas.openxmlformats.org/drawingml/2006/main">
               <a:ext uri="{FF2B5EF4-FFF2-40B4-BE49-F238E27FC236}">
-                <a16:creationId xmlns:a16="http://schemas.microsoft.com/office/drawing/2014/main" id="{697DE332-D503-4F78-8E28-E0E1A4CE6E7D}"/>
+                <a16:creationId xmlns:a16="http://schemas.microsoft.com/office/drawing/2014/main" id="{BC42E43F-2F81-4425-9701-FD4A9EA1ACFB}"/>
               </a:ext>
             </a:extLst>
           </p:cNvPr>
@@ -18296,7 +18296,7 @@
           <p:cNvPr id="8" name="">
             <a:extLst xmlns:a="http://schemas.openxmlformats.org/drawingml/2006/main">
               <a:ext uri="{FF2B5EF4-FFF2-40B4-BE49-F238E27FC236}">
-                <a16:creationId xmlns:a16="http://schemas.microsoft.com/office/drawing/2014/main" id="{A64BB7AD-A960-4FB8-B038-BF6397F693EB}"/>
+                <a16:creationId xmlns:a16="http://schemas.microsoft.com/office/drawing/2014/main" id="{A7C237F9-3D2B-4465-A53D-9BB80EFB7960}"/>
               </a:ext>
             </a:extLst>
           </p:cNvPr>
@@ -18330,7 +18330,7 @@
           <p:cNvPr id="9" name="">
             <a:extLst xmlns:a="http://schemas.openxmlformats.org/drawingml/2006/main">
               <a:ext uri="{FF2B5EF4-FFF2-40B4-BE49-F238E27FC236}">
-                <a16:creationId xmlns:a16="http://schemas.microsoft.com/office/drawing/2014/main" id="{AA358644-7A9A-44B4-917A-6A49950B69C7}"/>
+                <a16:creationId xmlns:a16="http://schemas.microsoft.com/office/drawing/2014/main" id="{104F1427-669D-42FE-A871-8CABF3818C24}"/>
               </a:ext>
             </a:extLst>
           </p:cNvPr>
@@ -18396,7 +18396,7 @@
           <p:cNvPr id="10" name="">
             <a:extLst xmlns:a="http://schemas.openxmlformats.org/drawingml/2006/main">
               <a:ext uri="{FF2B5EF4-FFF2-40B4-BE49-F238E27FC236}">
-                <a16:creationId xmlns:a16="http://schemas.microsoft.com/office/drawing/2014/main" id="{D8C5F8D9-EFAA-4A5F-80C5-B326ED3FBE01}"/>
+                <a16:creationId xmlns:a16="http://schemas.microsoft.com/office/drawing/2014/main" id="{8BB83BB5-46D6-45F9-8A62-865D3F474541}"/>
               </a:ext>
             </a:extLst>
           </p:cNvPr>
@@ -18462,7 +18462,7 @@
           <p:cNvPr id="11" name="">
             <a:extLst xmlns:a="http://schemas.openxmlformats.org/drawingml/2006/main">
               <a:ext uri="{FF2B5EF4-FFF2-40B4-BE49-F238E27FC236}">
-                <a16:creationId xmlns:a16="http://schemas.microsoft.com/office/drawing/2014/main" id="{1E99296E-0E7D-4E08-89BE-6C3825EC91A7}"/>
+                <a16:creationId xmlns:a16="http://schemas.microsoft.com/office/drawing/2014/main" id="{490C4919-2CAB-491B-9209-015BAE2D4D3A}"/>
               </a:ext>
             </a:extLst>
           </p:cNvPr>
@@ -18528,7 +18528,7 @@
           <p:cNvPr id="12" name="">
             <a:extLst xmlns:a="http://schemas.openxmlformats.org/drawingml/2006/main">
               <a:ext uri="{FF2B5EF4-FFF2-40B4-BE49-F238E27FC236}">
-                <a16:creationId xmlns:a16="http://schemas.microsoft.com/office/drawing/2014/main" id="{749334B6-776D-4236-A38C-9361524D18B0}"/>
+                <a16:creationId xmlns:a16="http://schemas.microsoft.com/office/drawing/2014/main" id="{D1E0A5AA-8EB6-48CA-AF4F-4C14CC8237D6}"/>
               </a:ext>
             </a:extLst>
           </p:cNvPr>
@@ -18562,7 +18562,7 @@
           <p:cNvPr id="13" name="">
             <a:extLst xmlns:a="http://schemas.openxmlformats.org/drawingml/2006/main">
               <a:ext uri="{FF2B5EF4-FFF2-40B4-BE49-F238E27FC236}">
-                <a16:creationId xmlns:a16="http://schemas.microsoft.com/office/drawing/2014/main" id="{BBC37072-1B8C-4B31-BA23-F154BAEE3B0C}"/>
+                <a16:creationId xmlns:a16="http://schemas.microsoft.com/office/drawing/2014/main" id="{808634B5-0F80-493F-A500-CC4F5EE258EE}"/>
               </a:ext>
             </a:extLst>
           </p:cNvPr>
@@ -18628,7 +18628,7 @@
           <p:cNvPr id="14" name="">
             <a:extLst xmlns:a="http://schemas.openxmlformats.org/drawingml/2006/main">
               <a:ext uri="{FF2B5EF4-FFF2-40B4-BE49-F238E27FC236}">
-                <a16:creationId xmlns:a16="http://schemas.microsoft.com/office/drawing/2014/main" id="{040BC11E-3C78-4939-8767-CFB72A20D737}"/>
+                <a16:creationId xmlns:a16="http://schemas.microsoft.com/office/drawing/2014/main" id="{411FD0FC-D39B-4A7D-A9D5-7143F740A4A5}"/>
               </a:ext>
             </a:extLst>
           </p:cNvPr>
@@ -18694,7 +18694,7 @@
           <p:cNvPr id="15" name="">
             <a:extLst xmlns:a="http://schemas.openxmlformats.org/drawingml/2006/main">
               <a:ext uri="{FF2B5EF4-FFF2-40B4-BE49-F238E27FC236}">
-                <a16:creationId xmlns:a16="http://schemas.microsoft.com/office/drawing/2014/main" id="{1030CFC5-FE8E-487B-AD00-23E71A0B046F}"/>
+                <a16:creationId xmlns:a16="http://schemas.microsoft.com/office/drawing/2014/main" id="{521E4EEA-D788-4187-B701-293D791FEEA0}"/>
               </a:ext>
             </a:extLst>
           </p:cNvPr>
@@ -18760,7 +18760,7 @@
           <p:cNvPr id="16" name="">
             <a:extLst xmlns:a="http://schemas.openxmlformats.org/drawingml/2006/main">
               <a:ext uri="{FF2B5EF4-FFF2-40B4-BE49-F238E27FC236}">
-                <a16:creationId xmlns:a16="http://schemas.microsoft.com/office/drawing/2014/main" id="{8630CBAD-C5B3-4325-A137-C463B52E7552}"/>
+                <a16:creationId xmlns:a16="http://schemas.microsoft.com/office/drawing/2014/main" id="{3D026362-3C8A-478B-99E2-A80717ACEAC9}"/>
               </a:ext>
             </a:extLst>
           </p:cNvPr>
@@ -18826,7 +18826,7 @@
           <p:cNvPr id="17" name="">
             <a:extLst xmlns:a="http://schemas.openxmlformats.org/drawingml/2006/main">
               <a:ext uri="{FF2B5EF4-FFF2-40B4-BE49-F238E27FC236}">
-                <a16:creationId xmlns:a16="http://schemas.microsoft.com/office/drawing/2014/main" id="{489F4EEE-3BA3-482D-9934-0A9DB89206CF}"/>
+                <a16:creationId xmlns:a16="http://schemas.microsoft.com/office/drawing/2014/main" id="{EBDF252E-B03B-4314-BD2A-0F8E71891EFD}"/>
               </a:ext>
             </a:extLst>
           </p:cNvPr>
@@ -18892,7 +18892,7 @@
           <p:cNvPr id="18" name="">
             <a:extLst xmlns:a="http://schemas.openxmlformats.org/drawingml/2006/main">
               <a:ext uri="{FF2B5EF4-FFF2-40B4-BE49-F238E27FC236}">
-                <a16:creationId xmlns:a16="http://schemas.microsoft.com/office/drawing/2014/main" id="{476DCA70-3B7B-44B1-99DA-C7C59536591E}"/>
+                <a16:creationId xmlns:a16="http://schemas.microsoft.com/office/drawing/2014/main" id="{AECE2EA5-D69B-428B-B837-B9916051C38C}"/>
               </a:ext>
             </a:extLst>
           </p:cNvPr>
@@ -18958,7 +18958,7 @@
           <p:cNvPr id="19" name="">
             <a:extLst xmlns:a="http://schemas.openxmlformats.org/drawingml/2006/main">
               <a:ext uri="{FF2B5EF4-FFF2-40B4-BE49-F238E27FC236}">
-                <a16:creationId xmlns:a16="http://schemas.microsoft.com/office/drawing/2014/main" id="{973C8CF9-7079-4980-B0A0-6331AF38D2A9}"/>
+                <a16:creationId xmlns:a16="http://schemas.microsoft.com/office/drawing/2014/main" id="{906E9B69-C9DB-4772-A769-60095DD7AC48}"/>
               </a:ext>
             </a:extLst>
           </p:cNvPr>
@@ -19024,7 +19024,7 @@
           <p:cNvPr id="20" name="">
             <a:extLst xmlns:a="http://schemas.openxmlformats.org/drawingml/2006/main">
               <a:ext uri="{FF2B5EF4-FFF2-40B4-BE49-F238E27FC236}">
-                <a16:creationId xmlns:a16="http://schemas.microsoft.com/office/drawing/2014/main" id="{4C3F58BF-51E0-4BCC-8EC2-B95CAEA31D76}"/>
+                <a16:creationId xmlns:a16="http://schemas.microsoft.com/office/drawing/2014/main" id="{8A8D2125-25B1-4C8A-A051-83CDF512837B}"/>
               </a:ext>
             </a:extLst>
           </p:cNvPr>
@@ -19090,7 +19090,7 @@
           <p:cNvPr id="21" name="">
             <a:extLst xmlns:a="http://schemas.openxmlformats.org/drawingml/2006/main">
               <a:ext uri="{FF2B5EF4-FFF2-40B4-BE49-F238E27FC236}">
-                <a16:creationId xmlns:a16="http://schemas.microsoft.com/office/drawing/2014/main" id="{8AC08DA7-8F93-4B11-B89C-F31441E0AAE6}"/>
+                <a16:creationId xmlns:a16="http://schemas.microsoft.com/office/drawing/2014/main" id="{A3047F3A-5C34-42B5-8D43-32A6C53785C8}"/>
               </a:ext>
             </a:extLst>
           </p:cNvPr>
@@ -19154,7 +19154,7 @@
     </p:spTree>
     <p:extLst>
       <p:ext uri="{BB962C8B-B14F-4D97-AF65-F5344CB8AC3E}">
-        <p14:creationId xmlns:p14="http://schemas.microsoft.com/office/powerpoint/2010/main" val="1439891088"/>
+        <p14:creationId xmlns:p14="http://schemas.microsoft.com/office/powerpoint/2010/main" val="1943523594"/>
       </p:ext>
     </p:extLst>
   </p:cSld>
@@ -19185,7 +19185,7 @@
           <p:cNvPr id="10" name="">
             <a:extLst xmlns:a="http://schemas.openxmlformats.org/drawingml/2006/main">
               <a:ext uri="{FF2B5EF4-FFF2-40B4-BE49-F238E27FC236}">
-                <a16:creationId xmlns:a16="http://schemas.microsoft.com/office/drawing/2014/main" id="{CE8A05FC-0C03-44EE-A1C3-865766E9865E}"/>
+                <a16:creationId xmlns:a16="http://schemas.microsoft.com/office/drawing/2014/main" id="{095D9FB9-D724-4D6F-8435-940E360F317F}"/>
               </a:ext>
             </a:extLst>
           </p:cNvPr>
@@ -19251,7 +19251,7 @@
           <p:cNvPr id="2" name="">
             <a:extLst xmlns:a="http://schemas.openxmlformats.org/drawingml/2006/main">
               <a:ext uri="{FF2B5EF4-FFF2-40B4-BE49-F238E27FC236}">
-                <a16:creationId xmlns:a16="http://schemas.microsoft.com/office/drawing/2014/main" id="{13B8F5A0-720F-4B5E-8917-685443360E0A}"/>
+                <a16:creationId xmlns:a16="http://schemas.microsoft.com/office/drawing/2014/main" id="{CE242FD5-FE47-413A-A6F4-650182E2F774}"/>
               </a:ext>
             </a:extLst>
           </p:cNvPr>
@@ -19317,7 +19317,7 @@
           <p:cNvPr id="3" name="">
             <a:extLst xmlns:a="http://schemas.openxmlformats.org/drawingml/2006/main">
               <a:ext uri="{FF2B5EF4-FFF2-40B4-BE49-F238E27FC236}">
-                <a16:creationId xmlns:a16="http://schemas.microsoft.com/office/drawing/2014/main" id="{4E75902C-FFD1-4E6A-B271-BFAD0FBFFA88}"/>
+                <a16:creationId xmlns:a16="http://schemas.microsoft.com/office/drawing/2014/main" id="{75E47CAC-6E90-4E94-A310-63FBBA046566}"/>
               </a:ext>
             </a:extLst>
           </p:cNvPr>
@@ -19349,7 +19349,7 @@
           <p:cNvPr id="4" name="">
             <a:extLst xmlns:a="http://schemas.openxmlformats.org/drawingml/2006/main">
               <a:ext uri="{FF2B5EF4-FFF2-40B4-BE49-F238E27FC236}">
-                <a16:creationId xmlns:a16="http://schemas.microsoft.com/office/drawing/2014/main" id="{81C7CE41-128E-4A51-9321-DBB29BC30A67}"/>
+                <a16:creationId xmlns:a16="http://schemas.microsoft.com/office/drawing/2014/main" id="{E0782FD4-FC2F-434E-9C7B-85CFA6879FE8}"/>
               </a:ext>
             </a:extLst>
           </p:cNvPr>
@@ -20675,7 +20675,7 @@
           <p:cNvPr id="5" name="">
             <a:extLst xmlns:a="http://schemas.openxmlformats.org/drawingml/2006/main">
               <a:ext uri="{FF2B5EF4-FFF2-40B4-BE49-F238E27FC236}">
-                <a16:creationId xmlns:a16="http://schemas.microsoft.com/office/drawing/2014/main" id="{D80481A7-47DF-4B2A-A3EB-C11727E4C535}"/>
+                <a16:creationId xmlns:a16="http://schemas.microsoft.com/office/drawing/2014/main" id="{DDDF7A2A-9845-4FF1-9F03-CE1D4950A7E0}"/>
               </a:ext>
             </a:extLst>
           </p:cNvPr>
@@ -20741,7 +20741,7 @@
           <p:cNvPr id="6" name="">
             <a:extLst xmlns:a="http://schemas.openxmlformats.org/drawingml/2006/main">
               <a:ext uri="{FF2B5EF4-FFF2-40B4-BE49-F238E27FC236}">
-                <a16:creationId xmlns:a16="http://schemas.microsoft.com/office/drawing/2014/main" id="{54024FB3-539B-4990-8355-368274C19EA4}"/>
+                <a16:creationId xmlns:a16="http://schemas.microsoft.com/office/drawing/2014/main" id="{54D068A5-2B6E-430C-8C31-B87EFD2A0C17}"/>
               </a:ext>
             </a:extLst>
           </p:cNvPr>
@@ -20807,7 +20807,7 @@
           <p:cNvPr id="7" name="">
             <a:extLst xmlns:a="http://schemas.openxmlformats.org/drawingml/2006/main">
               <a:ext uri="{FF2B5EF4-FFF2-40B4-BE49-F238E27FC236}">
-                <a16:creationId xmlns:a16="http://schemas.microsoft.com/office/drawing/2014/main" id="{CBBECE22-89B4-4C80-AB9F-E01039395CEC}"/>
+                <a16:creationId xmlns:a16="http://schemas.microsoft.com/office/drawing/2014/main" id="{A52AF1EB-06AA-49E3-B4B3-4E5D54B5EDD5}"/>
               </a:ext>
             </a:extLst>
           </p:cNvPr>
@@ -20873,7 +20873,7 @@
           <p:cNvPr id="8" name="">
             <a:extLst xmlns:a="http://schemas.openxmlformats.org/drawingml/2006/main">
               <a:ext uri="{FF2B5EF4-FFF2-40B4-BE49-F238E27FC236}">
-                <a16:creationId xmlns:a16="http://schemas.microsoft.com/office/drawing/2014/main" id="{0B3D94F5-5584-4633-A5DA-8EA431776382}"/>
+                <a16:creationId xmlns:a16="http://schemas.microsoft.com/office/drawing/2014/main" id="{DEF532CC-753A-47B7-B36F-BAAD853BD262}"/>
               </a:ext>
             </a:extLst>
           </p:cNvPr>
@@ -20939,7 +20939,7 @@
           <p:cNvPr id="9" name="">
             <a:extLst xmlns:a="http://schemas.openxmlformats.org/drawingml/2006/main">
               <a:ext uri="{FF2B5EF4-FFF2-40B4-BE49-F238E27FC236}">
-                <a16:creationId xmlns:a16="http://schemas.microsoft.com/office/drawing/2014/main" id="{4916495B-AAD3-4D7C-BED1-DC5F3D320499}"/>
+                <a16:creationId xmlns:a16="http://schemas.microsoft.com/office/drawing/2014/main" id="{CAB045A5-07FB-4ECA-939A-0D6BACF4D05A}"/>
               </a:ext>
             </a:extLst>
           </p:cNvPr>
@@ -21003,7 +21003,7 @@
     </p:spTree>
     <p:extLst>
       <p:ext uri="{BB962C8B-B14F-4D97-AF65-F5344CB8AC3E}">
-        <p14:creationId xmlns:p14="http://schemas.microsoft.com/office/powerpoint/2010/main" val="1575455890"/>
+        <p14:creationId xmlns:p14="http://schemas.microsoft.com/office/powerpoint/2010/main" val="1725220251"/>
       </p:ext>
     </p:extLst>
   </p:cSld>
@@ -21034,7 +21034,7 @@
           <p:cNvPr id="12" name="">
             <a:extLst xmlns:a="http://schemas.openxmlformats.org/drawingml/2006/main">
               <a:ext uri="{FF2B5EF4-FFF2-40B4-BE49-F238E27FC236}">
-                <a16:creationId xmlns:a16="http://schemas.microsoft.com/office/drawing/2014/main" id="{6F8E8322-F698-458D-95AF-561A3FBC44AC}"/>
+                <a16:creationId xmlns:a16="http://schemas.microsoft.com/office/drawing/2014/main" id="{80733E5F-516B-4769-A9F5-1D68756FEC5E}"/>
               </a:ext>
             </a:extLst>
           </p:cNvPr>
@@ -21100,7 +21100,7 @@
           <p:cNvPr id="2" name="">
             <a:extLst xmlns:a="http://schemas.openxmlformats.org/drawingml/2006/main">
               <a:ext uri="{FF2B5EF4-FFF2-40B4-BE49-F238E27FC236}">
-                <a16:creationId xmlns:a16="http://schemas.microsoft.com/office/drawing/2014/main" id="{DE2060E0-4D3A-4FC2-B158-6BF9755AE712}"/>
+                <a16:creationId xmlns:a16="http://schemas.microsoft.com/office/drawing/2014/main" id="{88457D8B-084D-4DB1-B4FC-DADD981B92AF}"/>
               </a:ext>
             </a:extLst>
           </p:cNvPr>
@@ -21166,7 +21166,7 @@
           <p:cNvPr id="3" name="">
             <a:extLst xmlns:a="http://schemas.openxmlformats.org/drawingml/2006/main">
               <a:ext uri="{FF2B5EF4-FFF2-40B4-BE49-F238E27FC236}">
-                <a16:creationId xmlns:a16="http://schemas.microsoft.com/office/drawing/2014/main" id="{000A513E-67E2-450B-ABA6-A0415E328894}"/>
+                <a16:creationId xmlns:a16="http://schemas.microsoft.com/office/drawing/2014/main" id="{1B0F0B38-5ED0-44BC-A5D8-D20AD564AE11}"/>
               </a:ext>
             </a:extLst>
           </p:cNvPr>
@@ -21198,7 +21198,7 @@
           <p:cNvPr id="4" name="">
             <a:extLst xmlns:a="http://schemas.openxmlformats.org/drawingml/2006/main">
               <a:ext uri="{FF2B5EF4-FFF2-40B4-BE49-F238E27FC236}">
-                <a16:creationId xmlns:a16="http://schemas.microsoft.com/office/drawing/2014/main" id="{875E113D-8BA3-4A5E-BAE8-637AD63CB878}"/>
+                <a16:creationId xmlns:a16="http://schemas.microsoft.com/office/drawing/2014/main" id="{F666B3DE-6F00-4942-BEF6-72E2C49ACB57}"/>
               </a:ext>
             </a:extLst>
           </p:cNvPr>
@@ -21966,7 +21966,7 @@
           <p:cNvPr id="5" name="">
             <a:extLst xmlns:a="http://schemas.openxmlformats.org/drawingml/2006/main">
               <a:ext uri="{FF2B5EF4-FFF2-40B4-BE49-F238E27FC236}">
-                <a16:creationId xmlns:a16="http://schemas.microsoft.com/office/drawing/2014/main" id="{44564CD6-0944-4972-AAE1-C891C5E3A012}"/>
+                <a16:creationId xmlns:a16="http://schemas.microsoft.com/office/drawing/2014/main" id="{AF1DE485-F285-4BCA-9EB8-BDD006C4DA21}"/>
               </a:ext>
             </a:extLst>
           </p:cNvPr>
@@ -22032,7 +22032,7 @@
           <p:cNvPr id="6" name="">
             <a:extLst xmlns:a="http://schemas.openxmlformats.org/drawingml/2006/main">
               <a:ext uri="{FF2B5EF4-FFF2-40B4-BE49-F238E27FC236}">
-                <a16:creationId xmlns:a16="http://schemas.microsoft.com/office/drawing/2014/main" id="{34302E7F-F30C-4482-86F7-F28F1CCDE0BD}"/>
+                <a16:creationId xmlns:a16="http://schemas.microsoft.com/office/drawing/2014/main" id="{798B5E4A-E7FB-4E55-BA6A-6DEF35B49D08}"/>
               </a:ext>
             </a:extLst>
           </p:cNvPr>
@@ -22098,7 +22098,7 @@
           <p:cNvPr id="7" name="">
             <a:extLst xmlns:a="http://schemas.openxmlformats.org/drawingml/2006/main">
               <a:ext uri="{FF2B5EF4-FFF2-40B4-BE49-F238E27FC236}">
-                <a16:creationId xmlns:a16="http://schemas.microsoft.com/office/drawing/2014/main" id="{B92B912A-947C-42A4-B74E-7A4CA7235AD2}"/>
+                <a16:creationId xmlns:a16="http://schemas.microsoft.com/office/drawing/2014/main" id="{964BDA0C-F257-4CA4-8125-43FFB9AC560E}"/>
               </a:ext>
             </a:extLst>
           </p:cNvPr>
@@ -22164,7 +22164,7 @@
           <p:cNvPr id="8" name="">
             <a:extLst xmlns:a="http://schemas.openxmlformats.org/drawingml/2006/main">
               <a:ext uri="{FF2B5EF4-FFF2-40B4-BE49-F238E27FC236}">
-                <a16:creationId xmlns:a16="http://schemas.microsoft.com/office/drawing/2014/main" id="{5F5CB90F-F27E-4F70-A557-E5C33B03C412}"/>
+                <a16:creationId xmlns:a16="http://schemas.microsoft.com/office/drawing/2014/main" id="{C4364635-42F2-4D09-95BC-EDBC8252E1E4}"/>
               </a:ext>
             </a:extLst>
           </p:cNvPr>
@@ -22230,7 +22230,7 @@
           <p:cNvPr id="9" name="">
             <a:extLst xmlns:a="http://schemas.openxmlformats.org/drawingml/2006/main">
               <a:ext uri="{FF2B5EF4-FFF2-40B4-BE49-F238E27FC236}">
-                <a16:creationId xmlns:a16="http://schemas.microsoft.com/office/drawing/2014/main" id="{4C53A7C5-70D3-48F3-AE1B-0A03AE490893}"/>
+                <a16:creationId xmlns:a16="http://schemas.microsoft.com/office/drawing/2014/main" id="{6AD4F512-CE70-47BE-BEB8-E843003162A2}"/>
               </a:ext>
             </a:extLst>
           </p:cNvPr>
@@ -22296,7 +22296,7 @@
           <p:cNvPr id="10" name="">
             <a:extLst xmlns:a="http://schemas.openxmlformats.org/drawingml/2006/main">
               <a:ext uri="{FF2B5EF4-FFF2-40B4-BE49-F238E27FC236}">
-                <a16:creationId xmlns:a16="http://schemas.microsoft.com/office/drawing/2014/main" id="{AFCA496F-8C0D-4DE9-A2D0-C9162221E457}"/>
+                <a16:creationId xmlns:a16="http://schemas.microsoft.com/office/drawing/2014/main" id="{A96212BD-B96C-4D39-B917-1F612783CD26}"/>
               </a:ext>
             </a:extLst>
           </p:cNvPr>
@@ -22362,7 +22362,7 @@
           <p:cNvPr id="11" name="">
             <a:extLst xmlns:a="http://schemas.openxmlformats.org/drawingml/2006/main">
               <a:ext uri="{FF2B5EF4-FFF2-40B4-BE49-F238E27FC236}">
-                <a16:creationId xmlns:a16="http://schemas.microsoft.com/office/drawing/2014/main" id="{F6986411-04F6-4CA2-AAAD-7A6BDA6E22F2}"/>
+                <a16:creationId xmlns:a16="http://schemas.microsoft.com/office/drawing/2014/main" id="{1828B98A-D4F6-4BAF-AF22-400FF40699CA}"/>
               </a:ext>
             </a:extLst>
           </p:cNvPr>
@@ -22426,7 +22426,7 @@
     </p:spTree>
     <p:extLst>
       <p:ext uri="{BB962C8B-B14F-4D97-AF65-F5344CB8AC3E}">
-        <p14:creationId xmlns:p14="http://schemas.microsoft.com/office/powerpoint/2010/main" val="920867468"/>
+        <p14:creationId xmlns:p14="http://schemas.microsoft.com/office/powerpoint/2010/main" val="200559190"/>
       </p:ext>
     </p:extLst>
   </p:cSld>
@@ -22457,7 +22457,7 @@
           <p:cNvPr id="10" name="">
             <a:extLst xmlns:a="http://schemas.openxmlformats.org/drawingml/2006/main">
               <a:ext uri="{FF2B5EF4-FFF2-40B4-BE49-F238E27FC236}">
-                <a16:creationId xmlns:a16="http://schemas.microsoft.com/office/drawing/2014/main" id="{4C17EFD3-D708-4F73-BE14-C58BA0233F77}"/>
+                <a16:creationId xmlns:a16="http://schemas.microsoft.com/office/drawing/2014/main" id="{AA91C9C9-2176-4DC0-B2EA-41C4988F726B}"/>
               </a:ext>
             </a:extLst>
           </p:cNvPr>
@@ -22523,7 +22523,7 @@
           <p:cNvPr id="2" name="">
             <a:extLst xmlns:a="http://schemas.openxmlformats.org/drawingml/2006/main">
               <a:ext uri="{FF2B5EF4-FFF2-40B4-BE49-F238E27FC236}">
-                <a16:creationId xmlns:a16="http://schemas.microsoft.com/office/drawing/2014/main" id="{C43743A3-F8A1-409D-90EE-8871FF843D5B}"/>
+                <a16:creationId xmlns:a16="http://schemas.microsoft.com/office/drawing/2014/main" id="{212CAE57-CB9E-43F0-8795-F042A2A2E479}"/>
               </a:ext>
             </a:extLst>
           </p:cNvPr>
@@ -22589,7 +22589,7 @@
           <p:cNvPr id="3" name="">
             <a:extLst xmlns:a="http://schemas.openxmlformats.org/drawingml/2006/main">
               <a:ext uri="{FF2B5EF4-FFF2-40B4-BE49-F238E27FC236}">
-                <a16:creationId xmlns:a16="http://schemas.microsoft.com/office/drawing/2014/main" id="{5DF8F982-6680-4506-B5DB-ACA9280B60B8}"/>
+                <a16:creationId xmlns:a16="http://schemas.microsoft.com/office/drawing/2014/main" id="{22DB3983-8270-4B32-A56C-23BAD483C8EF}"/>
               </a:ext>
             </a:extLst>
           </p:cNvPr>
@@ -22621,7 +22621,7 @@
           <p:cNvPr id="4" name="">
             <a:extLst xmlns:a="http://schemas.openxmlformats.org/drawingml/2006/main">
               <a:ext uri="{FF2B5EF4-FFF2-40B4-BE49-F238E27FC236}">
-                <a16:creationId xmlns:a16="http://schemas.microsoft.com/office/drawing/2014/main" id="{07C76783-10EA-4832-886F-75854F119881}"/>
+                <a16:creationId xmlns:a16="http://schemas.microsoft.com/office/drawing/2014/main" id="{83C19624-600A-4AF6-B7D1-7DF32D34C1FA}"/>
               </a:ext>
             </a:extLst>
           </p:cNvPr>
@@ -23605,7 +23605,7 @@
                           <a:ea typeface="Helvetica"/>
                           <a:cs typeface="Helvetica"/>
                         </a:rPr>
-                        <a:t>Paul's existing LOA coral bottle hero and convenience-store film are reused as internal creative illustrations.</a:t>
+                        <a:t>Claude's existing LOA coral bottle hero and convenience-store film are reused as internal creative illustrations.</a:t>
                       </a:r>
                     </a:p>
                   </a:txBody>
@@ -23638,7 +23638,7 @@
                           <a:ea typeface="Helvetica"/>
                           <a:cs typeface="Helvetica"/>
                         </a:rPr>
-                        <a:t>Paul and Matt must confirm provenance, usage rights, product accuracy and client-facing suitability.</a:t>
+                        <a:t>Matt must confirm source provenance, usage rights, product accuracy and client-facing suitability.</a:t>
                       </a:r>
                     </a:p>
                   </a:txBody>
@@ -23667,7 +23667,7 @@
           <p:cNvPr id="5" name="">
             <a:extLst xmlns:a="http://schemas.openxmlformats.org/drawingml/2006/main">
               <a:ext uri="{FF2B5EF4-FFF2-40B4-BE49-F238E27FC236}">
-                <a16:creationId xmlns:a16="http://schemas.microsoft.com/office/drawing/2014/main" id="{5087A1A0-A1FA-40EB-A95C-8DFB81F64A8D}"/>
+                <a16:creationId xmlns:a16="http://schemas.microsoft.com/office/drawing/2014/main" id="{02EE5B11-607D-4D88-8728-31C6FA36E586}"/>
               </a:ext>
             </a:extLst>
           </p:cNvPr>
@@ -23733,7 +23733,7 @@
           <p:cNvPr id="6" name="">
             <a:extLst xmlns:a="http://schemas.openxmlformats.org/drawingml/2006/main">
               <a:ext uri="{FF2B5EF4-FFF2-40B4-BE49-F238E27FC236}">
-                <a16:creationId xmlns:a16="http://schemas.microsoft.com/office/drawing/2014/main" id="{F22B4CE0-7BF8-413E-B94A-BC53669CF916}"/>
+                <a16:creationId xmlns:a16="http://schemas.microsoft.com/office/drawing/2014/main" id="{EBA3DE7B-A9E5-44D0-8237-7F0C4C513293}"/>
               </a:ext>
             </a:extLst>
           </p:cNvPr>
@@ -23799,7 +23799,7 @@
           <p:cNvPr id="7" name="">
             <a:extLst xmlns:a="http://schemas.openxmlformats.org/drawingml/2006/main">
               <a:ext uri="{FF2B5EF4-FFF2-40B4-BE49-F238E27FC236}">
-                <a16:creationId xmlns:a16="http://schemas.microsoft.com/office/drawing/2014/main" id="{F142A908-AC9C-488F-8ADB-4226AE2A6589}"/>
+                <a16:creationId xmlns:a16="http://schemas.microsoft.com/office/drawing/2014/main" id="{A8CC5DDD-A90A-452F-AF34-52DC38C0966D}"/>
               </a:ext>
             </a:extLst>
           </p:cNvPr>
@@ -23865,7 +23865,7 @@
           <p:cNvPr id="8" name="">
             <a:extLst xmlns:a="http://schemas.openxmlformats.org/drawingml/2006/main">
               <a:ext uri="{FF2B5EF4-FFF2-40B4-BE49-F238E27FC236}">
-                <a16:creationId xmlns:a16="http://schemas.microsoft.com/office/drawing/2014/main" id="{3A3EE67B-B55C-4076-A9A0-12784F37AC6D}"/>
+                <a16:creationId xmlns:a16="http://schemas.microsoft.com/office/drawing/2014/main" id="{FBCD8D20-BE80-4237-AF8C-36BD0DAED4B7}"/>
               </a:ext>
             </a:extLst>
           </p:cNvPr>
@@ -23931,7 +23931,7 @@
           <p:cNvPr id="9" name="">
             <a:extLst xmlns:a="http://schemas.openxmlformats.org/drawingml/2006/main">
               <a:ext uri="{FF2B5EF4-FFF2-40B4-BE49-F238E27FC236}">
-                <a16:creationId xmlns:a16="http://schemas.microsoft.com/office/drawing/2014/main" id="{0D426BB3-A67D-4D05-AC4E-06763DB66EE6}"/>
+                <a16:creationId xmlns:a16="http://schemas.microsoft.com/office/drawing/2014/main" id="{6BF3BCF8-F9C0-474F-A8D2-8C6AB1CDA3FF}"/>
               </a:ext>
             </a:extLst>
           </p:cNvPr>
@@ -23995,7 +23995,7 @@
     </p:spTree>
     <p:extLst>
       <p:ext uri="{BB962C8B-B14F-4D97-AF65-F5344CB8AC3E}">
-        <p14:creationId xmlns:p14="http://schemas.microsoft.com/office/powerpoint/2010/main" val="584478549"/>
+        <p14:creationId xmlns:p14="http://schemas.microsoft.com/office/powerpoint/2010/main" val="1197691044"/>
       </p:ext>
     </p:extLst>
   </p:cSld>
@@ -24026,7 +24026,7 @@
           <p:cNvPr id="13" name="">
             <a:extLst xmlns:a="http://schemas.openxmlformats.org/drawingml/2006/main">
               <a:ext uri="{FF2B5EF4-FFF2-40B4-BE49-F238E27FC236}">
-                <a16:creationId xmlns:a16="http://schemas.microsoft.com/office/drawing/2014/main" id="{9804507D-2902-4149-AA0B-ED6F2084916A}"/>
+                <a16:creationId xmlns:a16="http://schemas.microsoft.com/office/drawing/2014/main" id="{DC197F67-98B9-4E6A-9447-828821CF3BCD}"/>
               </a:ext>
             </a:extLst>
           </p:cNvPr>
@@ -24092,7 +24092,7 @@
           <p:cNvPr id="2" name="">
             <a:extLst xmlns:a="http://schemas.openxmlformats.org/drawingml/2006/main">
               <a:ext uri="{FF2B5EF4-FFF2-40B4-BE49-F238E27FC236}">
-                <a16:creationId xmlns:a16="http://schemas.microsoft.com/office/drawing/2014/main" id="{43AC898E-9D90-4229-9AE9-D7126C78ADDC}"/>
+                <a16:creationId xmlns:a16="http://schemas.microsoft.com/office/drawing/2014/main" id="{979DAF34-5FB8-4CA1-850E-4C6D9BA1864D}"/>
               </a:ext>
             </a:extLst>
           </p:cNvPr>
@@ -24158,7 +24158,7 @@
           <p:cNvPr id="3" name="">
             <a:extLst xmlns:a="http://schemas.openxmlformats.org/drawingml/2006/main">
               <a:ext uri="{FF2B5EF4-FFF2-40B4-BE49-F238E27FC236}">
-                <a16:creationId xmlns:a16="http://schemas.microsoft.com/office/drawing/2014/main" id="{C184BC37-6FD9-4381-9E16-8C1DC9CEC128}"/>
+                <a16:creationId xmlns:a16="http://schemas.microsoft.com/office/drawing/2014/main" id="{7B582829-3FD0-4AE5-A264-4829F2B08D4F}"/>
               </a:ext>
             </a:extLst>
           </p:cNvPr>
@@ -24190,7 +24190,7 @@
           <p:cNvPr id="4" name="">
             <a:extLst xmlns:a="http://schemas.openxmlformats.org/drawingml/2006/main">
               <a:ext uri="{FF2B5EF4-FFF2-40B4-BE49-F238E27FC236}">
-                <a16:creationId xmlns:a16="http://schemas.microsoft.com/office/drawing/2014/main" id="{538985FB-7628-48F8-9613-83F6B5F648DB}"/>
+                <a16:creationId xmlns:a16="http://schemas.microsoft.com/office/drawing/2014/main" id="{0E364A15-A589-46D9-A520-F32F806FE646}"/>
               </a:ext>
             </a:extLst>
           </p:cNvPr>
@@ -24256,7 +24256,7 @@
           <p:cNvPr id="5" name="">
             <a:extLst xmlns:a="http://schemas.openxmlformats.org/drawingml/2006/main">
               <a:ext uri="{FF2B5EF4-FFF2-40B4-BE49-F238E27FC236}">
-                <a16:creationId xmlns:a16="http://schemas.microsoft.com/office/drawing/2014/main" id="{17EACB03-55DD-4E75-A295-12DB26E83A57}"/>
+                <a16:creationId xmlns:a16="http://schemas.microsoft.com/office/drawing/2014/main" id="{695D82E5-50EA-4C0E-81D6-1A69DA59B7B5}"/>
               </a:ext>
             </a:extLst>
           </p:cNvPr>
@@ -24322,7 +24322,7 @@
           <p:cNvPr id="6" name="">
             <a:extLst xmlns:a="http://schemas.openxmlformats.org/drawingml/2006/main">
               <a:ext uri="{FF2B5EF4-FFF2-40B4-BE49-F238E27FC236}">
-                <a16:creationId xmlns:a16="http://schemas.microsoft.com/office/drawing/2014/main" id="{EF37D078-95B0-4E3A-9E9B-5DF34A2061FD}"/>
+                <a16:creationId xmlns:a16="http://schemas.microsoft.com/office/drawing/2014/main" id="{F4033FE6-B3B4-4E5A-AD01-11C94E767627}"/>
               </a:ext>
             </a:extLst>
           </p:cNvPr>
@@ -24388,7 +24388,7 @@
           <p:cNvPr id="7" name="">
             <a:extLst xmlns:a="http://schemas.openxmlformats.org/drawingml/2006/main">
               <a:ext uri="{FF2B5EF4-FFF2-40B4-BE49-F238E27FC236}">
-                <a16:creationId xmlns:a16="http://schemas.microsoft.com/office/drawing/2014/main" id="{A4962E5A-F535-4FB3-81EA-B86F3885B0A9}"/>
+                <a16:creationId xmlns:a16="http://schemas.microsoft.com/office/drawing/2014/main" id="{EB9198BC-667A-4907-AD9A-111468859C98}"/>
               </a:ext>
             </a:extLst>
           </p:cNvPr>
@@ -24454,7 +24454,7 @@
           <p:cNvPr id="8" name="">
             <a:extLst xmlns:a="http://schemas.openxmlformats.org/drawingml/2006/main">
               <a:ext uri="{FF2B5EF4-FFF2-40B4-BE49-F238E27FC236}">
-                <a16:creationId xmlns:a16="http://schemas.microsoft.com/office/drawing/2014/main" id="{0F6B0EA8-8268-4BF1-9FBD-C89C8E6FDF27}"/>
+                <a16:creationId xmlns:a16="http://schemas.microsoft.com/office/drawing/2014/main" id="{C53BA623-8AD9-49D1-8A08-A0D079AF11A6}"/>
               </a:ext>
             </a:extLst>
           </p:cNvPr>
@@ -24520,7 +24520,7 @@
           <p:cNvPr id="9" name="">
             <a:extLst xmlns:a="http://schemas.openxmlformats.org/drawingml/2006/main">
               <a:ext uri="{FF2B5EF4-FFF2-40B4-BE49-F238E27FC236}">
-                <a16:creationId xmlns:a16="http://schemas.microsoft.com/office/drawing/2014/main" id="{52C01C77-4E54-4A50-B912-4A7EC1090EEA}"/>
+                <a16:creationId xmlns:a16="http://schemas.microsoft.com/office/drawing/2014/main" id="{E16C0D06-EB85-4C9C-8260-7C9CD932EBB6}"/>
               </a:ext>
             </a:extLst>
           </p:cNvPr>
@@ -24586,7 +24586,7 @@
           <p:cNvPr id="10" name="">
             <a:extLst xmlns:a="http://schemas.openxmlformats.org/drawingml/2006/main">
               <a:ext uri="{FF2B5EF4-FFF2-40B4-BE49-F238E27FC236}">
-                <a16:creationId xmlns:a16="http://schemas.microsoft.com/office/drawing/2014/main" id="{AC2E2BE0-1FB5-42D4-B48B-DB3F2B47D119}"/>
+                <a16:creationId xmlns:a16="http://schemas.microsoft.com/office/drawing/2014/main" id="{E046E038-69B5-4991-9252-7F5B21A34091}"/>
               </a:ext>
             </a:extLst>
           </p:cNvPr>
@@ -24652,7 +24652,7 @@
           <p:cNvPr id="11" name="">
             <a:extLst xmlns:a="http://schemas.openxmlformats.org/drawingml/2006/main">
               <a:ext uri="{FF2B5EF4-FFF2-40B4-BE49-F238E27FC236}">
-                <a16:creationId xmlns:a16="http://schemas.microsoft.com/office/drawing/2014/main" id="{0230771A-7313-47EA-B01E-F89D1E619513}"/>
+                <a16:creationId xmlns:a16="http://schemas.microsoft.com/office/drawing/2014/main" id="{38F74A69-5193-492E-B17F-CCEBD85E2F26}"/>
               </a:ext>
             </a:extLst>
           </p:cNvPr>
@@ -24718,7 +24718,7 @@
           <p:cNvPr id="12" name="">
             <a:extLst xmlns:a="http://schemas.openxmlformats.org/drawingml/2006/main">
               <a:ext uri="{FF2B5EF4-FFF2-40B4-BE49-F238E27FC236}">
-                <a16:creationId xmlns:a16="http://schemas.microsoft.com/office/drawing/2014/main" id="{C14CF131-3735-43F2-9581-065FE547A0A2}"/>
+                <a16:creationId xmlns:a16="http://schemas.microsoft.com/office/drawing/2014/main" id="{D27D8B6F-2DCE-4E96-9D35-BB23250319D6}"/>
               </a:ext>
             </a:extLst>
           </p:cNvPr>
@@ -24782,7 +24782,7 @@
     </p:spTree>
     <p:extLst>
       <p:ext uri="{BB962C8B-B14F-4D97-AF65-F5344CB8AC3E}">
-        <p14:creationId xmlns:p14="http://schemas.microsoft.com/office/powerpoint/2010/main" val="200195561"/>
+        <p14:creationId xmlns:p14="http://schemas.microsoft.com/office/powerpoint/2010/main" val="1040702014"/>
       </p:ext>
     </p:extLst>
   </p:cSld>
@@ -24813,7 +24813,7 @@
           <p:cNvPr id="18" name="">
             <a:extLst xmlns:a="http://schemas.openxmlformats.org/drawingml/2006/main">
               <a:ext uri="{FF2B5EF4-FFF2-40B4-BE49-F238E27FC236}">
-                <a16:creationId xmlns:a16="http://schemas.microsoft.com/office/drawing/2014/main" id="{5C97AAB8-E6CC-4986-A0E4-3F344345741C}"/>
+                <a16:creationId xmlns:a16="http://schemas.microsoft.com/office/drawing/2014/main" id="{20252F7D-1E17-45B7-BC67-2D004105E7CE}"/>
               </a:ext>
             </a:extLst>
           </p:cNvPr>
@@ -24879,7 +24879,7 @@
           <p:cNvPr id="2" name="">
             <a:extLst xmlns:a="http://schemas.openxmlformats.org/drawingml/2006/main">
               <a:ext uri="{FF2B5EF4-FFF2-40B4-BE49-F238E27FC236}">
-                <a16:creationId xmlns:a16="http://schemas.microsoft.com/office/drawing/2014/main" id="{E51157C0-8C91-4A0B-B5AD-F11B5056612E}"/>
+                <a16:creationId xmlns:a16="http://schemas.microsoft.com/office/drawing/2014/main" id="{6E16EF66-9FDE-476C-8C41-CFCDAEC95814}"/>
               </a:ext>
             </a:extLst>
           </p:cNvPr>
@@ -24945,7 +24945,7 @@
           <p:cNvPr id="3" name="">
             <a:extLst xmlns:a="http://schemas.openxmlformats.org/drawingml/2006/main">
               <a:ext uri="{FF2B5EF4-FFF2-40B4-BE49-F238E27FC236}">
-                <a16:creationId xmlns:a16="http://schemas.microsoft.com/office/drawing/2014/main" id="{C50E6BB9-84D9-4D47-84DA-77CBAA0760B4}"/>
+                <a16:creationId xmlns:a16="http://schemas.microsoft.com/office/drawing/2014/main" id="{19565C07-61A9-4034-9371-397433188900}"/>
               </a:ext>
             </a:extLst>
           </p:cNvPr>
@@ -24977,7 +24977,7 @@
           <p:cNvPr id="4" name="">
             <a:extLst xmlns:a="http://schemas.openxmlformats.org/drawingml/2006/main">
               <a:ext uri="{FF2B5EF4-FFF2-40B4-BE49-F238E27FC236}">
-                <a16:creationId xmlns:a16="http://schemas.microsoft.com/office/drawing/2014/main" id="{51201C21-0872-455D-A068-D6BA03D9484C}"/>
+                <a16:creationId xmlns:a16="http://schemas.microsoft.com/office/drawing/2014/main" id="{C436645E-08F7-4660-B960-5AC92C679597}"/>
               </a:ext>
             </a:extLst>
           </p:cNvPr>
@@ -25043,7 +25043,7 @@
           <p:cNvPr id="5" name="">
             <a:extLst xmlns:a="http://schemas.openxmlformats.org/drawingml/2006/main">
               <a:ext uri="{FF2B5EF4-FFF2-40B4-BE49-F238E27FC236}">
-                <a16:creationId xmlns:a16="http://schemas.microsoft.com/office/drawing/2014/main" id="{0C59F775-6351-47CD-891D-40277B309217}"/>
+                <a16:creationId xmlns:a16="http://schemas.microsoft.com/office/drawing/2014/main" id="{A5513F9D-DD6D-4465-87EB-42A93CD3948F}"/>
               </a:ext>
             </a:extLst>
           </p:cNvPr>
@@ -25109,7 +25109,7 @@
           <p:cNvPr id="6" name="">
             <a:extLst xmlns:a="http://schemas.openxmlformats.org/drawingml/2006/main">
               <a:ext uri="{FF2B5EF4-FFF2-40B4-BE49-F238E27FC236}">
-                <a16:creationId xmlns:a16="http://schemas.microsoft.com/office/drawing/2014/main" id="{039D9665-2B42-4645-98A6-49AEECAC961A}"/>
+                <a16:creationId xmlns:a16="http://schemas.microsoft.com/office/drawing/2014/main" id="{577F6AF0-9D94-4481-824D-23AE1DD63EF6}"/>
               </a:ext>
             </a:extLst>
           </p:cNvPr>
@@ -25175,7 +25175,7 @@
           <p:cNvPr id="7" name="">
             <a:extLst xmlns:a="http://schemas.openxmlformats.org/drawingml/2006/main">
               <a:ext uri="{FF2B5EF4-FFF2-40B4-BE49-F238E27FC236}">
-                <a16:creationId xmlns:a16="http://schemas.microsoft.com/office/drawing/2014/main" id="{E9CB2E6A-7C02-4131-94FA-243D21530714}"/>
+                <a16:creationId xmlns:a16="http://schemas.microsoft.com/office/drawing/2014/main" id="{1935E8A3-EF82-4C22-B57C-9B996853C44F}"/>
               </a:ext>
             </a:extLst>
           </p:cNvPr>
@@ -25207,7 +25207,7 @@
           <p:cNvPr id="8" name="">
             <a:extLst xmlns:a="http://schemas.openxmlformats.org/drawingml/2006/main">
               <a:ext uri="{FF2B5EF4-FFF2-40B4-BE49-F238E27FC236}">
-                <a16:creationId xmlns:a16="http://schemas.microsoft.com/office/drawing/2014/main" id="{ED790E19-C671-446B-8D38-2C43BBCFCACB}"/>
+                <a16:creationId xmlns:a16="http://schemas.microsoft.com/office/drawing/2014/main" id="{9EA1CA73-C118-42F1-8632-10DAEA83708F}"/>
               </a:ext>
             </a:extLst>
           </p:cNvPr>
@@ -25273,7 +25273,7 @@
           <p:cNvPr id="9" name="">
             <a:extLst xmlns:a="http://schemas.openxmlformats.org/drawingml/2006/main">
               <a:ext uri="{FF2B5EF4-FFF2-40B4-BE49-F238E27FC236}">
-                <a16:creationId xmlns:a16="http://schemas.microsoft.com/office/drawing/2014/main" id="{E17CCDFA-58F8-4BFB-BB31-9B531992108F}"/>
+                <a16:creationId xmlns:a16="http://schemas.microsoft.com/office/drawing/2014/main" id="{57DCF6C1-CF2D-4921-97C5-F989DCEE3CF5}"/>
               </a:ext>
             </a:extLst>
           </p:cNvPr>
@@ -25339,7 +25339,7 @@
           <p:cNvPr id="10" name="">
             <a:extLst xmlns:a="http://schemas.openxmlformats.org/drawingml/2006/main">
               <a:ext uri="{FF2B5EF4-FFF2-40B4-BE49-F238E27FC236}">
-                <a16:creationId xmlns:a16="http://schemas.microsoft.com/office/drawing/2014/main" id="{CF3D1702-FB5D-482B-B211-EB5130B268FF}"/>
+                <a16:creationId xmlns:a16="http://schemas.microsoft.com/office/drawing/2014/main" id="{22A3B907-194B-4832-B3E0-68F8DB50B646}"/>
               </a:ext>
             </a:extLst>
           </p:cNvPr>
@@ -25405,7 +25405,7 @@
           <p:cNvPr id="11" name="">
             <a:extLst xmlns:a="http://schemas.openxmlformats.org/drawingml/2006/main">
               <a:ext uri="{FF2B5EF4-FFF2-40B4-BE49-F238E27FC236}">
-                <a16:creationId xmlns:a16="http://schemas.microsoft.com/office/drawing/2014/main" id="{5816E1CB-DB8D-4032-9855-7770C7F373B7}"/>
+                <a16:creationId xmlns:a16="http://schemas.microsoft.com/office/drawing/2014/main" id="{A685C9B5-6AFA-46C3-AB83-83CE0D144895}"/>
               </a:ext>
             </a:extLst>
           </p:cNvPr>
@@ -25471,7 +25471,7 @@
           <p:cNvPr id="12" name="">
             <a:extLst xmlns:a="http://schemas.openxmlformats.org/drawingml/2006/main">
               <a:ext uri="{FF2B5EF4-FFF2-40B4-BE49-F238E27FC236}">
-                <a16:creationId xmlns:a16="http://schemas.microsoft.com/office/drawing/2014/main" id="{5B380BEF-E219-42A0-B8EE-46605F9E724E}"/>
+                <a16:creationId xmlns:a16="http://schemas.microsoft.com/office/drawing/2014/main" id="{DD084D6A-A72D-4C14-BA3E-9A309D5C0630}"/>
               </a:ext>
             </a:extLst>
           </p:cNvPr>
@@ -25537,7 +25537,7 @@
           <p:cNvPr id="13" name="">
             <a:extLst xmlns:a="http://schemas.openxmlformats.org/drawingml/2006/main">
               <a:ext uri="{FF2B5EF4-FFF2-40B4-BE49-F238E27FC236}">
-                <a16:creationId xmlns:a16="http://schemas.microsoft.com/office/drawing/2014/main" id="{7F5324AC-D7E6-4FF7-AE56-DCF61E8D4EB1}"/>
+                <a16:creationId xmlns:a16="http://schemas.microsoft.com/office/drawing/2014/main" id="{EBCFB87E-F678-4B4D-BE04-AD6B4EBF34BA}"/>
               </a:ext>
             </a:extLst>
           </p:cNvPr>
@@ -25603,7 +25603,7 @@
           <p:cNvPr id="14" name="">
             <a:extLst xmlns:a="http://schemas.openxmlformats.org/drawingml/2006/main">
               <a:ext uri="{FF2B5EF4-FFF2-40B4-BE49-F238E27FC236}">
-                <a16:creationId xmlns:a16="http://schemas.microsoft.com/office/drawing/2014/main" id="{93646D1B-8A31-41BA-993F-06E1B3FC58A7}"/>
+                <a16:creationId xmlns:a16="http://schemas.microsoft.com/office/drawing/2014/main" id="{051F916F-8DE3-441B-8BDE-4D1AA8ED6377}"/>
               </a:ext>
             </a:extLst>
           </p:cNvPr>
@@ -25669,7 +25669,7 @@
           <p:cNvPr id="15" name="">
             <a:extLst xmlns:a="http://schemas.openxmlformats.org/drawingml/2006/main">
               <a:ext uri="{FF2B5EF4-FFF2-40B4-BE49-F238E27FC236}">
-                <a16:creationId xmlns:a16="http://schemas.microsoft.com/office/drawing/2014/main" id="{BDBEAC9E-7132-4759-BFBE-D09125F422AD}"/>
+                <a16:creationId xmlns:a16="http://schemas.microsoft.com/office/drawing/2014/main" id="{BE9EECD8-D3E3-4474-8E02-19C9866C1DC9}"/>
               </a:ext>
             </a:extLst>
           </p:cNvPr>
@@ -25735,7 +25735,7 @@
           <p:cNvPr id="16" name="">
             <a:extLst xmlns:a="http://schemas.openxmlformats.org/drawingml/2006/main">
               <a:ext uri="{FF2B5EF4-FFF2-40B4-BE49-F238E27FC236}">
-                <a16:creationId xmlns:a16="http://schemas.microsoft.com/office/drawing/2014/main" id="{61750EF7-3215-46D7-B4DE-D0937EF2A8FA}"/>
+                <a16:creationId xmlns:a16="http://schemas.microsoft.com/office/drawing/2014/main" id="{23D33B55-989A-4DCD-B309-3EFA2AB09895}"/>
               </a:ext>
             </a:extLst>
           </p:cNvPr>
@@ -25801,7 +25801,7 @@
           <p:cNvPr id="17" name="">
             <a:extLst xmlns:a="http://schemas.openxmlformats.org/drawingml/2006/main">
               <a:ext uri="{FF2B5EF4-FFF2-40B4-BE49-F238E27FC236}">
-                <a16:creationId xmlns:a16="http://schemas.microsoft.com/office/drawing/2014/main" id="{655F4BF6-399A-4EC5-AC6B-D2DC13B90D70}"/>
+                <a16:creationId xmlns:a16="http://schemas.microsoft.com/office/drawing/2014/main" id="{2D9DD53D-3895-4B9A-8334-DFE67931E5D7}"/>
               </a:ext>
             </a:extLst>
           </p:cNvPr>
@@ -25865,7 +25865,7 @@
     </p:spTree>
     <p:extLst>
       <p:ext uri="{BB962C8B-B14F-4D97-AF65-F5344CB8AC3E}">
-        <p14:creationId xmlns:p14="http://schemas.microsoft.com/office/powerpoint/2010/main" val="1624510941"/>
+        <p14:creationId xmlns:p14="http://schemas.microsoft.com/office/powerpoint/2010/main" val="999231060"/>
       </p:ext>
     </p:extLst>
   </p:cSld>
@@ -25896,7 +25896,7 @@
           <p:cNvPr id="22" name="">
             <a:extLst xmlns:a="http://schemas.openxmlformats.org/drawingml/2006/main">
               <a:ext uri="{FF2B5EF4-FFF2-40B4-BE49-F238E27FC236}">
-                <a16:creationId xmlns:a16="http://schemas.microsoft.com/office/drawing/2014/main" id="{31EDDBED-D421-4FA3-903A-294550E98DB8}"/>
+                <a16:creationId xmlns:a16="http://schemas.microsoft.com/office/drawing/2014/main" id="{B1C32EA1-37C7-4E25-AC6A-D8CFA13B47A5}"/>
               </a:ext>
             </a:extLst>
           </p:cNvPr>
@@ -25962,7 +25962,7 @@
           <p:cNvPr id="2" name="">
             <a:extLst xmlns:a="http://schemas.openxmlformats.org/drawingml/2006/main">
               <a:ext uri="{FF2B5EF4-FFF2-40B4-BE49-F238E27FC236}">
-                <a16:creationId xmlns:a16="http://schemas.microsoft.com/office/drawing/2014/main" id="{72EE0868-AD44-44E5-ADDF-EFD4CD10F61B}"/>
+                <a16:creationId xmlns:a16="http://schemas.microsoft.com/office/drawing/2014/main" id="{085A2A60-6AFB-497B-8078-B8F2DF445197}"/>
               </a:ext>
             </a:extLst>
           </p:cNvPr>
@@ -26028,7 +26028,7 @@
           <p:cNvPr id="3" name="">
             <a:extLst xmlns:a="http://schemas.openxmlformats.org/drawingml/2006/main">
               <a:ext uri="{FF2B5EF4-FFF2-40B4-BE49-F238E27FC236}">
-                <a16:creationId xmlns:a16="http://schemas.microsoft.com/office/drawing/2014/main" id="{174BD1BF-61DD-4C96-97D7-F88D26C48348}"/>
+                <a16:creationId xmlns:a16="http://schemas.microsoft.com/office/drawing/2014/main" id="{CE41E5E7-E667-4EB6-8A35-870328517507}"/>
               </a:ext>
             </a:extLst>
           </p:cNvPr>
@@ -26060,7 +26060,7 @@
           <p:cNvPr id="4" name="">
             <a:extLst xmlns:a="http://schemas.openxmlformats.org/drawingml/2006/main">
               <a:ext uri="{FF2B5EF4-FFF2-40B4-BE49-F238E27FC236}">
-                <a16:creationId xmlns:a16="http://schemas.microsoft.com/office/drawing/2014/main" id="{C02C4535-89F1-4134-86FE-6A9951EE8820}"/>
+                <a16:creationId xmlns:a16="http://schemas.microsoft.com/office/drawing/2014/main" id="{3720CF2D-EB3D-4484-BAA6-E2768F57C4DD}"/>
               </a:ext>
             </a:extLst>
           </p:cNvPr>
@@ -26094,7 +26094,7 @@
           <p:cNvPr id="5" name="">
             <a:extLst xmlns:a="http://schemas.openxmlformats.org/drawingml/2006/main">
               <a:ext uri="{FF2B5EF4-FFF2-40B4-BE49-F238E27FC236}">
-                <a16:creationId xmlns:a16="http://schemas.microsoft.com/office/drawing/2014/main" id="{E7435107-1E96-4EC4-B498-51B06B7A71F8}"/>
+                <a16:creationId xmlns:a16="http://schemas.microsoft.com/office/drawing/2014/main" id="{7C60426A-F567-478D-A2F3-18232314DF76}"/>
               </a:ext>
             </a:extLst>
           </p:cNvPr>
@@ -26160,7 +26160,7 @@
           <p:cNvPr id="6" name="">
             <a:extLst xmlns:a="http://schemas.openxmlformats.org/drawingml/2006/main">
               <a:ext uri="{FF2B5EF4-FFF2-40B4-BE49-F238E27FC236}">
-                <a16:creationId xmlns:a16="http://schemas.microsoft.com/office/drawing/2014/main" id="{16DFB3FE-085C-4C4A-8DCF-8468CCECA1CA}"/>
+                <a16:creationId xmlns:a16="http://schemas.microsoft.com/office/drawing/2014/main" id="{EA44737B-40C6-495A-8094-2AF91682D00C}"/>
               </a:ext>
             </a:extLst>
           </p:cNvPr>
@@ -26226,7 +26226,7 @@
           <p:cNvPr id="7" name="">
             <a:extLst xmlns:a="http://schemas.openxmlformats.org/drawingml/2006/main">
               <a:ext uri="{FF2B5EF4-FFF2-40B4-BE49-F238E27FC236}">
-                <a16:creationId xmlns:a16="http://schemas.microsoft.com/office/drawing/2014/main" id="{43681D57-7104-440B-AE55-2CFD6F26EC46}"/>
+                <a16:creationId xmlns:a16="http://schemas.microsoft.com/office/drawing/2014/main" id="{D95267A2-ACE3-41BE-B830-CF11DEB65595}"/>
               </a:ext>
             </a:extLst>
           </p:cNvPr>
@@ -26292,7 +26292,7 @@
           <p:cNvPr id="8" name="">
             <a:extLst xmlns:a="http://schemas.openxmlformats.org/drawingml/2006/main">
               <a:ext uri="{FF2B5EF4-FFF2-40B4-BE49-F238E27FC236}">
-                <a16:creationId xmlns:a16="http://schemas.microsoft.com/office/drawing/2014/main" id="{DDD4C452-5D21-4B1A-A736-F5928641F051}"/>
+                <a16:creationId xmlns:a16="http://schemas.microsoft.com/office/drawing/2014/main" id="{4FDFDC23-3A0E-4F8C-B677-96988910D11A}"/>
               </a:ext>
             </a:extLst>
           </p:cNvPr>
@@ -26326,7 +26326,7 @@
           <p:cNvPr id="9" name="">
             <a:extLst xmlns:a="http://schemas.openxmlformats.org/drawingml/2006/main">
               <a:ext uri="{FF2B5EF4-FFF2-40B4-BE49-F238E27FC236}">
-                <a16:creationId xmlns:a16="http://schemas.microsoft.com/office/drawing/2014/main" id="{DC1EC593-AFBD-4F90-92E5-7982869F95FC}"/>
+                <a16:creationId xmlns:a16="http://schemas.microsoft.com/office/drawing/2014/main" id="{F93DA28E-AD14-460B-B4CF-6993145A0CAC}"/>
               </a:ext>
             </a:extLst>
           </p:cNvPr>
@@ -26392,7 +26392,7 @@
           <p:cNvPr id="10" name="">
             <a:extLst xmlns:a="http://schemas.openxmlformats.org/drawingml/2006/main">
               <a:ext uri="{FF2B5EF4-FFF2-40B4-BE49-F238E27FC236}">
-                <a16:creationId xmlns:a16="http://schemas.microsoft.com/office/drawing/2014/main" id="{78925059-D9B5-4C82-849A-267805E04AD3}"/>
+                <a16:creationId xmlns:a16="http://schemas.microsoft.com/office/drawing/2014/main" id="{13C0B54F-FD84-40B1-9D5E-AA8B78D6FF55}"/>
               </a:ext>
             </a:extLst>
           </p:cNvPr>
@@ -26458,7 +26458,7 @@
           <p:cNvPr id="11" name="">
             <a:extLst xmlns:a="http://schemas.openxmlformats.org/drawingml/2006/main">
               <a:ext uri="{FF2B5EF4-FFF2-40B4-BE49-F238E27FC236}">
-                <a16:creationId xmlns:a16="http://schemas.microsoft.com/office/drawing/2014/main" id="{67DAA0D7-F695-43BE-9B9F-DB496CCD43B8}"/>
+                <a16:creationId xmlns:a16="http://schemas.microsoft.com/office/drawing/2014/main" id="{371382D3-4F93-46B9-AC88-EF07D5DFD0BE}"/>
               </a:ext>
             </a:extLst>
           </p:cNvPr>
@@ -26524,7 +26524,7 @@
           <p:cNvPr id="12" name="">
             <a:extLst xmlns:a="http://schemas.openxmlformats.org/drawingml/2006/main">
               <a:ext uri="{FF2B5EF4-FFF2-40B4-BE49-F238E27FC236}">
-                <a16:creationId xmlns:a16="http://schemas.microsoft.com/office/drawing/2014/main" id="{81678689-E9F2-4340-86D9-7A3D84561E48}"/>
+                <a16:creationId xmlns:a16="http://schemas.microsoft.com/office/drawing/2014/main" id="{1235928C-7656-4076-A587-AE730E98CAE6}"/>
               </a:ext>
             </a:extLst>
           </p:cNvPr>
@@ -26558,7 +26558,7 @@
           <p:cNvPr id="13" name="">
             <a:extLst xmlns:a="http://schemas.openxmlformats.org/drawingml/2006/main">
               <a:ext uri="{FF2B5EF4-FFF2-40B4-BE49-F238E27FC236}">
-                <a16:creationId xmlns:a16="http://schemas.microsoft.com/office/drawing/2014/main" id="{B1F92699-16D4-498B-A800-00511C18E9C4}"/>
+                <a16:creationId xmlns:a16="http://schemas.microsoft.com/office/drawing/2014/main" id="{1FC91BBF-7BD0-444A-B508-1B8456968C8B}"/>
               </a:ext>
             </a:extLst>
           </p:cNvPr>
@@ -26624,7 +26624,7 @@
           <p:cNvPr id="14" name="">
             <a:extLst xmlns:a="http://schemas.openxmlformats.org/drawingml/2006/main">
               <a:ext uri="{FF2B5EF4-FFF2-40B4-BE49-F238E27FC236}">
-                <a16:creationId xmlns:a16="http://schemas.microsoft.com/office/drawing/2014/main" id="{AA5FBDE8-84FC-440D-9CB8-B288982C9321}"/>
+                <a16:creationId xmlns:a16="http://schemas.microsoft.com/office/drawing/2014/main" id="{CED443AB-76B0-43CB-B2E5-1D48C568CE57}"/>
               </a:ext>
             </a:extLst>
           </p:cNvPr>
@@ -26690,7 +26690,7 @@
           <p:cNvPr id="15" name="">
             <a:extLst xmlns:a="http://schemas.openxmlformats.org/drawingml/2006/main">
               <a:ext uri="{FF2B5EF4-FFF2-40B4-BE49-F238E27FC236}">
-                <a16:creationId xmlns:a16="http://schemas.microsoft.com/office/drawing/2014/main" id="{DFB87AB9-B37B-4E13-A01F-6A77E2B18185}"/>
+                <a16:creationId xmlns:a16="http://schemas.microsoft.com/office/drawing/2014/main" id="{7AF37151-C18B-4F79-A81D-B7464078AC40}"/>
               </a:ext>
             </a:extLst>
           </p:cNvPr>
@@ -26756,7 +26756,7 @@
           <p:cNvPr id="16" name="">
             <a:extLst xmlns:a="http://schemas.openxmlformats.org/drawingml/2006/main">
               <a:ext uri="{FF2B5EF4-FFF2-40B4-BE49-F238E27FC236}">
-                <a16:creationId xmlns:a16="http://schemas.microsoft.com/office/drawing/2014/main" id="{5B7BD496-D12B-4BBA-A393-2CE091FF8924}"/>
+                <a16:creationId xmlns:a16="http://schemas.microsoft.com/office/drawing/2014/main" id="{BA1558CC-7D23-4321-B00E-F534E536DFEA}"/>
               </a:ext>
             </a:extLst>
           </p:cNvPr>
@@ -26822,7 +26822,7 @@
           <p:cNvPr id="17" name="">
             <a:extLst xmlns:a="http://schemas.openxmlformats.org/drawingml/2006/main">
               <a:ext uri="{FF2B5EF4-FFF2-40B4-BE49-F238E27FC236}">
-                <a16:creationId xmlns:a16="http://schemas.microsoft.com/office/drawing/2014/main" id="{44F08D3A-01D0-4202-BE2B-9C628EABD520}"/>
+                <a16:creationId xmlns:a16="http://schemas.microsoft.com/office/drawing/2014/main" id="{ABD110F8-BDD2-47A6-BAE0-72BCD9E06EAB}"/>
               </a:ext>
             </a:extLst>
           </p:cNvPr>
@@ -26888,7 +26888,7 @@
           <p:cNvPr id="18" name="">
             <a:extLst xmlns:a="http://schemas.openxmlformats.org/drawingml/2006/main">
               <a:ext uri="{FF2B5EF4-FFF2-40B4-BE49-F238E27FC236}">
-                <a16:creationId xmlns:a16="http://schemas.microsoft.com/office/drawing/2014/main" id="{9A918F12-07B0-4B57-BEF6-653A53F96844}"/>
+                <a16:creationId xmlns:a16="http://schemas.microsoft.com/office/drawing/2014/main" id="{158C5FC4-E849-4EC1-816A-883C8D7345A0}"/>
               </a:ext>
             </a:extLst>
           </p:cNvPr>
@@ -26954,7 +26954,7 @@
           <p:cNvPr id="19" name="">
             <a:extLst xmlns:a="http://schemas.openxmlformats.org/drawingml/2006/main">
               <a:ext uri="{FF2B5EF4-FFF2-40B4-BE49-F238E27FC236}">
-                <a16:creationId xmlns:a16="http://schemas.microsoft.com/office/drawing/2014/main" id="{4E5B3A46-E2C2-4112-9E2E-E59CA2F052A9}"/>
+                <a16:creationId xmlns:a16="http://schemas.microsoft.com/office/drawing/2014/main" id="{D19FB535-B721-4D90-9824-FF53BC0091B7}"/>
               </a:ext>
             </a:extLst>
           </p:cNvPr>
@@ -27020,7 +27020,7 @@
           <p:cNvPr id="20" name="">
             <a:extLst xmlns:a="http://schemas.openxmlformats.org/drawingml/2006/main">
               <a:ext uri="{FF2B5EF4-FFF2-40B4-BE49-F238E27FC236}">
-                <a16:creationId xmlns:a16="http://schemas.microsoft.com/office/drawing/2014/main" id="{E5B88759-30D9-4792-BD25-E9F5B43372E1}"/>
+                <a16:creationId xmlns:a16="http://schemas.microsoft.com/office/drawing/2014/main" id="{10688E43-B19D-42D6-BFAF-9B67AF0B42D6}"/>
               </a:ext>
             </a:extLst>
           </p:cNvPr>
@@ -27086,7 +27086,7 @@
           <p:cNvPr id="21" name="">
             <a:extLst xmlns:a="http://schemas.openxmlformats.org/drawingml/2006/main">
               <a:ext uri="{FF2B5EF4-FFF2-40B4-BE49-F238E27FC236}">
-                <a16:creationId xmlns:a16="http://schemas.microsoft.com/office/drawing/2014/main" id="{CCC8B6C7-7E5B-4E6C-AA62-698BBA825BD7}"/>
+                <a16:creationId xmlns:a16="http://schemas.microsoft.com/office/drawing/2014/main" id="{20FFB57A-C06D-4FB1-A696-B6C53149FCB4}"/>
               </a:ext>
             </a:extLst>
           </p:cNvPr>
@@ -27150,7 +27150,7 @@
     </p:spTree>
     <p:extLst>
       <p:ext uri="{BB962C8B-B14F-4D97-AF65-F5344CB8AC3E}">
-        <p14:creationId xmlns:p14="http://schemas.microsoft.com/office/powerpoint/2010/main" val="238755247"/>
+        <p14:creationId xmlns:p14="http://schemas.microsoft.com/office/powerpoint/2010/main" val="1485401297"/>
       </p:ext>
     </p:extLst>
   </p:cSld>
@@ -27181,7 +27181,7 @@
           <p:cNvPr id="13" name="">
             <a:extLst xmlns:a="http://schemas.openxmlformats.org/drawingml/2006/main">
               <a:ext uri="{FF2B5EF4-FFF2-40B4-BE49-F238E27FC236}">
-                <a16:creationId xmlns:a16="http://schemas.microsoft.com/office/drawing/2014/main" id="{73064818-B7AC-479D-B348-C2405C4B6E68}"/>
+                <a16:creationId xmlns:a16="http://schemas.microsoft.com/office/drawing/2014/main" id="{8778822F-2731-48DB-AA81-FEF842F6BC04}"/>
               </a:ext>
             </a:extLst>
           </p:cNvPr>
@@ -27191,7 +27191,7 @@
           <p:nvPr/>
         </p:nvPicPr>
         <p:blipFill>
-          <a:blip xmlns:r="http://schemas.openxmlformats.org/officeDocument/2006/relationships" xmlns:a="http://schemas.openxmlformats.org/drawingml/2006/main" r:embed="Rc27bf25c9e1c4a0c"/>
+          <a:blip xmlns:r="http://schemas.openxmlformats.org/officeDocument/2006/relationships" xmlns:a="http://schemas.openxmlformats.org/drawingml/2006/main" r:embed="R9ae23a8437574f65"/>
           <a:srcRect xmlns:a="http://schemas.openxmlformats.org/drawingml/2006/main" l="0" t="21875" r="0" b="21875"/>
           <a:stretch xmlns:a="http://schemas.openxmlformats.org/drawingml/2006/main">
             <a:fillRect l="0" t="0" r="0" b="0"/>
@@ -27212,7 +27212,7 @@
           <p:cNvPr id="2" name="">
             <a:extLst xmlns:a="http://schemas.openxmlformats.org/drawingml/2006/main">
               <a:ext uri="{FF2B5EF4-FFF2-40B4-BE49-F238E27FC236}">
-                <a16:creationId xmlns:a16="http://schemas.microsoft.com/office/drawing/2014/main" id="{6A74005F-3179-45B8-93F5-AAF2A1A1C199}"/>
+                <a16:creationId xmlns:a16="http://schemas.microsoft.com/office/drawing/2014/main" id="{4749F5BB-8E55-4E06-BEC3-EB8E1D6EB4A6}"/>
               </a:ext>
             </a:extLst>
           </p:cNvPr>
@@ -27248,7 +27248,7 @@
           <p:cNvPr id="3" name="">
             <a:extLst xmlns:a="http://schemas.openxmlformats.org/drawingml/2006/main">
               <a:ext uri="{FF2B5EF4-FFF2-40B4-BE49-F238E27FC236}">
-                <a16:creationId xmlns:a16="http://schemas.microsoft.com/office/drawing/2014/main" id="{DE4B7A33-594E-4C95-88B8-4B11C4155303}"/>
+                <a16:creationId xmlns:a16="http://schemas.microsoft.com/office/drawing/2014/main" id="{E6579680-7F4B-435A-9193-9EAF4C3E88B6}"/>
               </a:ext>
             </a:extLst>
           </p:cNvPr>
@@ -27314,7 +27314,7 @@
           <p:cNvPr id="4" name="">
             <a:extLst xmlns:a="http://schemas.openxmlformats.org/drawingml/2006/main">
               <a:ext uri="{FF2B5EF4-FFF2-40B4-BE49-F238E27FC236}">
-                <a16:creationId xmlns:a16="http://schemas.microsoft.com/office/drawing/2014/main" id="{6A374F42-0BEF-45D9-AC16-1000BACE3499}"/>
+                <a16:creationId xmlns:a16="http://schemas.microsoft.com/office/drawing/2014/main" id="{8F38EABC-B71A-48DE-BC3A-957EB480AE1A}"/>
               </a:ext>
             </a:extLst>
           </p:cNvPr>
@@ -27380,7 +27380,7 @@
           <p:cNvPr id="5" name="">
             <a:extLst xmlns:a="http://schemas.openxmlformats.org/drawingml/2006/main">
               <a:ext uri="{FF2B5EF4-FFF2-40B4-BE49-F238E27FC236}">
-                <a16:creationId xmlns:a16="http://schemas.microsoft.com/office/drawing/2014/main" id="{D9507541-13B7-4EEB-B14D-4D937EB73A6D}"/>
+                <a16:creationId xmlns:a16="http://schemas.microsoft.com/office/drawing/2014/main" id="{FD50B7CF-C96D-4FD3-93CC-F7B0E1D9B738}"/>
               </a:ext>
             </a:extLst>
           </p:cNvPr>
@@ -27446,7 +27446,7 @@
           <p:cNvPr id="6" name="">
             <a:extLst xmlns:a="http://schemas.openxmlformats.org/drawingml/2006/main">
               <a:ext uri="{FF2B5EF4-FFF2-40B4-BE49-F238E27FC236}">
-                <a16:creationId xmlns:a16="http://schemas.microsoft.com/office/drawing/2014/main" id="{24A12381-0E0C-4267-85FF-E060C2DCC6A9}"/>
+                <a16:creationId xmlns:a16="http://schemas.microsoft.com/office/drawing/2014/main" id="{DFFFBB51-698E-4043-A342-C6CCAD91E07D}"/>
               </a:ext>
             </a:extLst>
           </p:cNvPr>
@@ -27512,7 +27512,7 @@
           <p:cNvPr id="7" name="">
             <a:extLst xmlns:a="http://schemas.openxmlformats.org/drawingml/2006/main">
               <a:ext uri="{FF2B5EF4-FFF2-40B4-BE49-F238E27FC236}">
-                <a16:creationId xmlns:a16="http://schemas.microsoft.com/office/drawing/2014/main" id="{E30A6C54-494D-4136-B51E-1DFE79662239}"/>
+                <a16:creationId xmlns:a16="http://schemas.microsoft.com/office/drawing/2014/main" id="{170AF29E-D886-4152-9998-B99B9BBC1F29}"/>
               </a:ext>
             </a:extLst>
           </p:cNvPr>
@@ -27578,7 +27578,7 @@
           <p:cNvPr id="8" name="">
             <a:extLst xmlns:a="http://schemas.openxmlformats.org/drawingml/2006/main">
               <a:ext uri="{FF2B5EF4-FFF2-40B4-BE49-F238E27FC236}">
-                <a16:creationId xmlns:a16="http://schemas.microsoft.com/office/drawing/2014/main" id="{9BAAB377-FBD5-4144-8ECE-316D5BD4D232}"/>
+                <a16:creationId xmlns:a16="http://schemas.microsoft.com/office/drawing/2014/main" id="{775FC484-B7DA-447A-94AE-A4BA4800A548}"/>
               </a:ext>
             </a:extLst>
           </p:cNvPr>
@@ -27644,7 +27644,7 @@
           <p:cNvPr id="9" name="">
             <a:extLst xmlns:a="http://schemas.openxmlformats.org/drawingml/2006/main">
               <a:ext uri="{FF2B5EF4-FFF2-40B4-BE49-F238E27FC236}">
-                <a16:creationId xmlns:a16="http://schemas.microsoft.com/office/drawing/2014/main" id="{71FBA7F7-AA35-4A0E-B668-A887EAD0F424}"/>
+                <a16:creationId xmlns:a16="http://schemas.microsoft.com/office/drawing/2014/main" id="{A364CC66-9740-400D-AE67-042986AAAA7D}"/>
               </a:ext>
             </a:extLst>
           </p:cNvPr>
@@ -27710,7 +27710,7 @@
           <p:cNvPr id="10" name="">
             <a:extLst xmlns:a="http://schemas.openxmlformats.org/drawingml/2006/main">
               <a:ext uri="{FF2B5EF4-FFF2-40B4-BE49-F238E27FC236}">
-                <a16:creationId xmlns:a16="http://schemas.microsoft.com/office/drawing/2014/main" id="{F6868E84-9A8F-4010-9051-A0B4F5D927B5}"/>
+                <a16:creationId xmlns:a16="http://schemas.microsoft.com/office/drawing/2014/main" id="{4A5E30A0-2F4B-4762-9CD7-E3E533D98B74}"/>
               </a:ext>
             </a:extLst>
           </p:cNvPr>
@@ -27776,7 +27776,7 @@
           <p:cNvPr id="11" name="">
             <a:extLst xmlns:a="http://schemas.openxmlformats.org/drawingml/2006/main">
               <a:ext uri="{FF2B5EF4-FFF2-40B4-BE49-F238E27FC236}">
-                <a16:creationId xmlns:a16="http://schemas.microsoft.com/office/drawing/2014/main" id="{2A31F5DB-628D-4DFC-95E6-12E522ACAA6F}"/>
+                <a16:creationId xmlns:a16="http://schemas.microsoft.com/office/drawing/2014/main" id="{018336E7-D5B2-4877-BE6F-2C40BEA91C5E}"/>
               </a:ext>
             </a:extLst>
           </p:cNvPr>
@@ -27842,7 +27842,7 @@
           <p:cNvPr id="12" name="">
             <a:extLst xmlns:a="http://schemas.openxmlformats.org/drawingml/2006/main">
               <a:ext uri="{FF2B5EF4-FFF2-40B4-BE49-F238E27FC236}">
-                <a16:creationId xmlns:a16="http://schemas.microsoft.com/office/drawing/2014/main" id="{72FEE9F6-BC82-453D-B4BA-B461696F2D39}"/>
+                <a16:creationId xmlns:a16="http://schemas.microsoft.com/office/drawing/2014/main" id="{CC4D2865-35F2-4F34-851E-2B47B5B30202}"/>
               </a:ext>
             </a:extLst>
           </p:cNvPr>
@@ -27906,7 +27906,7 @@
     </p:spTree>
     <p:extLst>
       <p:ext uri="{BB962C8B-B14F-4D97-AF65-F5344CB8AC3E}">
-        <p14:creationId xmlns:p14="http://schemas.microsoft.com/office/powerpoint/2010/main" val="137430221"/>
+        <p14:creationId xmlns:p14="http://schemas.microsoft.com/office/powerpoint/2010/main" val="211738335"/>
       </p:ext>
     </p:extLst>
   </p:cSld>
@@ -27937,7 +27937,7 @@
           <p:cNvPr id="15" name="">
             <a:extLst xmlns:a="http://schemas.openxmlformats.org/drawingml/2006/main">
               <a:ext uri="{FF2B5EF4-FFF2-40B4-BE49-F238E27FC236}">
-                <a16:creationId xmlns:a16="http://schemas.microsoft.com/office/drawing/2014/main" id="{D4E5B444-E17D-417D-B597-97DFABFAF6E1}"/>
+                <a16:creationId xmlns:a16="http://schemas.microsoft.com/office/drawing/2014/main" id="{097D9CAF-054E-4BA0-BC59-5B0491B4762F}"/>
               </a:ext>
             </a:extLst>
           </p:cNvPr>
@@ -28003,7 +28003,7 @@
           <p:cNvPr id="2" name="">
             <a:extLst xmlns:a="http://schemas.openxmlformats.org/drawingml/2006/main">
               <a:ext uri="{FF2B5EF4-FFF2-40B4-BE49-F238E27FC236}">
-                <a16:creationId xmlns:a16="http://schemas.microsoft.com/office/drawing/2014/main" id="{4F9F719F-6C85-4EC5-85CF-7D1D89C046B4}"/>
+                <a16:creationId xmlns:a16="http://schemas.microsoft.com/office/drawing/2014/main" id="{DE9CC1D6-BB80-48C9-BA36-27A6E9B7DA37}"/>
               </a:ext>
             </a:extLst>
           </p:cNvPr>
@@ -28069,7 +28069,7 @@
           <p:cNvPr id="3" name="">
             <a:extLst xmlns:a="http://schemas.openxmlformats.org/drawingml/2006/main">
               <a:ext uri="{FF2B5EF4-FFF2-40B4-BE49-F238E27FC236}">
-                <a16:creationId xmlns:a16="http://schemas.microsoft.com/office/drawing/2014/main" id="{23318AE7-9FDF-4D19-9BCC-C2348B21B14B}"/>
+                <a16:creationId xmlns:a16="http://schemas.microsoft.com/office/drawing/2014/main" id="{67B16E84-7BCA-4A04-A686-A60A5A040109}"/>
               </a:ext>
             </a:extLst>
           </p:cNvPr>
@@ -28101,7 +28101,7 @@
           <p:cNvPr id="4" name="">
             <a:extLst xmlns:a="http://schemas.openxmlformats.org/drawingml/2006/main">
               <a:ext uri="{FF2B5EF4-FFF2-40B4-BE49-F238E27FC236}">
-                <a16:creationId xmlns:a16="http://schemas.microsoft.com/office/drawing/2014/main" id="{165EC676-D924-4C61-8044-0A7D2115BFAE}"/>
+                <a16:creationId xmlns:a16="http://schemas.microsoft.com/office/drawing/2014/main" id="{4F388B70-BC2D-4958-8D74-F036FAE6DB58}"/>
               </a:ext>
             </a:extLst>
           </p:cNvPr>
@@ -28167,7 +28167,7 @@
           <p:cNvPr id="5" name="">
             <a:extLst xmlns:a="http://schemas.openxmlformats.org/drawingml/2006/main">
               <a:ext uri="{FF2B5EF4-FFF2-40B4-BE49-F238E27FC236}">
-                <a16:creationId xmlns:a16="http://schemas.microsoft.com/office/drawing/2014/main" id="{1F8C35B3-192D-4F19-B7AA-DB1E7AB2FD2D}"/>
+                <a16:creationId xmlns:a16="http://schemas.microsoft.com/office/drawing/2014/main" id="{E4013292-73AB-4C96-B532-4F8C55280A72}"/>
               </a:ext>
             </a:extLst>
           </p:cNvPr>
@@ -28199,7 +28199,7 @@
           <p:cNvPr id="6" name="">
             <a:extLst xmlns:a="http://schemas.openxmlformats.org/drawingml/2006/main">
               <a:ext uri="{FF2B5EF4-FFF2-40B4-BE49-F238E27FC236}">
-                <a16:creationId xmlns:a16="http://schemas.microsoft.com/office/drawing/2014/main" id="{B4EA34B2-C96C-4F7F-A28B-A0C86EDDA31F}"/>
+                <a16:creationId xmlns:a16="http://schemas.microsoft.com/office/drawing/2014/main" id="{5403F12F-DE32-4200-BA3C-FDF7874AC4B4}"/>
               </a:ext>
             </a:extLst>
           </p:cNvPr>
@@ -28265,7 +28265,7 @@
           <p:cNvPr id="7" name="">
             <a:extLst xmlns:a="http://schemas.openxmlformats.org/drawingml/2006/main">
               <a:ext uri="{FF2B5EF4-FFF2-40B4-BE49-F238E27FC236}">
-                <a16:creationId xmlns:a16="http://schemas.microsoft.com/office/drawing/2014/main" id="{39EC235D-4174-4907-8066-0F42BB55908C}"/>
+                <a16:creationId xmlns:a16="http://schemas.microsoft.com/office/drawing/2014/main" id="{DEA7941F-D6BB-41E0-8065-B424AAE7B011}"/>
               </a:ext>
             </a:extLst>
           </p:cNvPr>
@@ -28297,7 +28297,7 @@
           <p:cNvPr id="8" name="">
             <a:extLst xmlns:a="http://schemas.openxmlformats.org/drawingml/2006/main">
               <a:ext uri="{FF2B5EF4-FFF2-40B4-BE49-F238E27FC236}">
-                <a16:creationId xmlns:a16="http://schemas.microsoft.com/office/drawing/2014/main" id="{0571503D-9280-495F-894C-F1A1AF42459F}"/>
+                <a16:creationId xmlns:a16="http://schemas.microsoft.com/office/drawing/2014/main" id="{B5F6CC62-5D5A-4FA4-9BDD-8879344CF407}"/>
               </a:ext>
             </a:extLst>
           </p:cNvPr>
@@ -28363,7 +28363,7 @@
           <p:cNvPr id="9" name="">
             <a:extLst xmlns:a="http://schemas.openxmlformats.org/drawingml/2006/main">
               <a:ext uri="{FF2B5EF4-FFF2-40B4-BE49-F238E27FC236}">
-                <a16:creationId xmlns:a16="http://schemas.microsoft.com/office/drawing/2014/main" id="{E25F814E-DC09-4639-A529-E63ED6A78DB8}"/>
+                <a16:creationId xmlns:a16="http://schemas.microsoft.com/office/drawing/2014/main" id="{30BC8D2D-D3A8-48CF-A91C-CC9E07CAE41B}"/>
               </a:ext>
             </a:extLst>
           </p:cNvPr>
@@ -28429,7 +28429,7 @@
           <p:cNvPr id="10" name="">
             <a:extLst xmlns:a="http://schemas.openxmlformats.org/drawingml/2006/main">
               <a:ext uri="{FF2B5EF4-FFF2-40B4-BE49-F238E27FC236}">
-                <a16:creationId xmlns:a16="http://schemas.microsoft.com/office/drawing/2014/main" id="{F0615AE8-0042-44D5-AF15-B2D7CD318838}"/>
+                <a16:creationId xmlns:a16="http://schemas.microsoft.com/office/drawing/2014/main" id="{BB9BEBFA-F363-4B5A-B103-09FC4213E595}"/>
               </a:ext>
             </a:extLst>
           </p:cNvPr>
@@ -28495,7 +28495,7 @@
           <p:cNvPr id="11" name="">
             <a:extLst xmlns:a="http://schemas.openxmlformats.org/drawingml/2006/main">
               <a:ext uri="{FF2B5EF4-FFF2-40B4-BE49-F238E27FC236}">
-                <a16:creationId xmlns:a16="http://schemas.microsoft.com/office/drawing/2014/main" id="{7EDD4BBE-DFC0-4F0A-AF8C-0C222F4F83E0}"/>
+                <a16:creationId xmlns:a16="http://schemas.microsoft.com/office/drawing/2014/main" id="{4983E29B-FD79-4E72-AF10-007E2E80D159}"/>
               </a:ext>
             </a:extLst>
           </p:cNvPr>
@@ -28561,7 +28561,7 @@
           <p:cNvPr id="12" name="">
             <a:extLst xmlns:a="http://schemas.openxmlformats.org/drawingml/2006/main">
               <a:ext uri="{FF2B5EF4-FFF2-40B4-BE49-F238E27FC236}">
-                <a16:creationId xmlns:a16="http://schemas.microsoft.com/office/drawing/2014/main" id="{016EC043-2CA8-43B6-A062-AEE75A0AF1E2}"/>
+                <a16:creationId xmlns:a16="http://schemas.microsoft.com/office/drawing/2014/main" id="{FE2F5ED2-0839-49CD-B824-2DE4578B2421}"/>
               </a:ext>
             </a:extLst>
           </p:cNvPr>
@@ -28627,7 +28627,7 @@
           <p:cNvPr id="13" name="">
             <a:extLst xmlns:a="http://schemas.openxmlformats.org/drawingml/2006/main">
               <a:ext uri="{FF2B5EF4-FFF2-40B4-BE49-F238E27FC236}">
-                <a16:creationId xmlns:a16="http://schemas.microsoft.com/office/drawing/2014/main" id="{9CB5734E-8158-42AE-BE72-43AAE077506F}"/>
+                <a16:creationId xmlns:a16="http://schemas.microsoft.com/office/drawing/2014/main" id="{24129F51-C353-4636-8E6D-BC9C99FF6FE5}"/>
               </a:ext>
             </a:extLst>
           </p:cNvPr>
@@ -28693,7 +28693,7 @@
           <p:cNvPr id="14" name="">
             <a:extLst xmlns:a="http://schemas.openxmlformats.org/drawingml/2006/main">
               <a:ext uri="{FF2B5EF4-FFF2-40B4-BE49-F238E27FC236}">
-                <a16:creationId xmlns:a16="http://schemas.microsoft.com/office/drawing/2014/main" id="{9DC2FDE0-C5EA-4ADC-BBE2-AB324C7A8EF3}"/>
+                <a16:creationId xmlns:a16="http://schemas.microsoft.com/office/drawing/2014/main" id="{6BD537DB-CA0A-4DA0-A24F-CC7BCA3E92E1}"/>
               </a:ext>
             </a:extLst>
           </p:cNvPr>
@@ -28757,7 +28757,7 @@
     </p:spTree>
     <p:extLst>
       <p:ext uri="{BB962C8B-B14F-4D97-AF65-F5344CB8AC3E}">
-        <p14:creationId xmlns:p14="http://schemas.microsoft.com/office/powerpoint/2010/main" val="949726844"/>
+        <p14:creationId xmlns:p14="http://schemas.microsoft.com/office/powerpoint/2010/main" val="1779679099"/>
       </p:ext>
     </p:extLst>
   </p:cSld>
@@ -28788,7 +28788,7 @@
           <p:cNvPr id="17" name="">
             <a:extLst xmlns:a="http://schemas.openxmlformats.org/drawingml/2006/main">
               <a:ext uri="{FF2B5EF4-FFF2-40B4-BE49-F238E27FC236}">
-                <a16:creationId xmlns:a16="http://schemas.microsoft.com/office/drawing/2014/main" id="{2A94B443-BA14-4569-BC6C-5316C8E067B0}"/>
+                <a16:creationId xmlns:a16="http://schemas.microsoft.com/office/drawing/2014/main" id="{D3ECF509-85CE-49D3-AA1B-5C8AF78F6B19}"/>
               </a:ext>
             </a:extLst>
           </p:cNvPr>
@@ -28854,7 +28854,7 @@
           <p:cNvPr id="2" name="">
             <a:extLst xmlns:a="http://schemas.openxmlformats.org/drawingml/2006/main">
               <a:ext uri="{FF2B5EF4-FFF2-40B4-BE49-F238E27FC236}">
-                <a16:creationId xmlns:a16="http://schemas.microsoft.com/office/drawing/2014/main" id="{522B511F-91A8-479F-BDFB-1818103E12C2}"/>
+                <a16:creationId xmlns:a16="http://schemas.microsoft.com/office/drawing/2014/main" id="{F30937E3-F27C-4BA2-837A-031E7C1C3018}"/>
               </a:ext>
             </a:extLst>
           </p:cNvPr>
@@ -28920,7 +28920,7 @@
           <p:cNvPr id="3" name="">
             <a:extLst xmlns:a="http://schemas.openxmlformats.org/drawingml/2006/main">
               <a:ext uri="{FF2B5EF4-FFF2-40B4-BE49-F238E27FC236}">
-                <a16:creationId xmlns:a16="http://schemas.microsoft.com/office/drawing/2014/main" id="{BBCF59BD-3467-4E3C-B296-63858668CBF3}"/>
+                <a16:creationId xmlns:a16="http://schemas.microsoft.com/office/drawing/2014/main" id="{B64B8B93-C18D-483F-8F2D-9C10BA21285F}"/>
               </a:ext>
             </a:extLst>
           </p:cNvPr>
@@ -28952,7 +28952,7 @@
           <p:cNvPr id="4" name="">
             <a:extLst xmlns:a="http://schemas.openxmlformats.org/drawingml/2006/main">
               <a:ext uri="{FF2B5EF4-FFF2-40B4-BE49-F238E27FC236}">
-                <a16:creationId xmlns:a16="http://schemas.microsoft.com/office/drawing/2014/main" id="{CFE951DF-6EDF-4253-95E8-9928A285170E}"/>
+                <a16:creationId xmlns:a16="http://schemas.microsoft.com/office/drawing/2014/main" id="{4874BD8B-78C1-4BDD-8E19-5D17C43DF239}"/>
               </a:ext>
             </a:extLst>
           </p:cNvPr>
@@ -28986,7 +28986,7 @@
           <p:cNvPr id="5" name="">
             <a:extLst xmlns:a="http://schemas.openxmlformats.org/drawingml/2006/main">
               <a:ext uri="{FF2B5EF4-FFF2-40B4-BE49-F238E27FC236}">
-                <a16:creationId xmlns:a16="http://schemas.microsoft.com/office/drawing/2014/main" id="{085F7464-5210-475E-A574-8C65A9EDC339}"/>
+                <a16:creationId xmlns:a16="http://schemas.microsoft.com/office/drawing/2014/main" id="{BE382A58-8783-4100-AE86-4235041828DC}"/>
               </a:ext>
             </a:extLst>
           </p:cNvPr>
@@ -29052,7 +29052,7 @@
           <p:cNvPr id="6" name="">
             <a:extLst xmlns:a="http://schemas.openxmlformats.org/drawingml/2006/main">
               <a:ext uri="{FF2B5EF4-FFF2-40B4-BE49-F238E27FC236}">
-                <a16:creationId xmlns:a16="http://schemas.microsoft.com/office/drawing/2014/main" id="{8AC84B55-2471-4C8A-9A25-CC91BA8DEDFB}"/>
+                <a16:creationId xmlns:a16="http://schemas.microsoft.com/office/drawing/2014/main" id="{EDF186A2-CA11-4248-97E1-3A80FA979C30}"/>
               </a:ext>
             </a:extLst>
           </p:cNvPr>
@@ -29086,7 +29086,7 @@
           <p:cNvPr id="7" name="">
             <a:extLst xmlns:a="http://schemas.openxmlformats.org/drawingml/2006/main">
               <a:ext uri="{FF2B5EF4-FFF2-40B4-BE49-F238E27FC236}">
-                <a16:creationId xmlns:a16="http://schemas.microsoft.com/office/drawing/2014/main" id="{BA4BFA30-5FBD-41C9-A89C-F395D5F5C73F}"/>
+                <a16:creationId xmlns:a16="http://schemas.microsoft.com/office/drawing/2014/main" id="{36BEEE37-EA59-4E65-ABD4-69946184563F}"/>
               </a:ext>
             </a:extLst>
           </p:cNvPr>
@@ -29152,7 +29152,7 @@
           <p:cNvPr id="8" name="">
             <a:extLst xmlns:a="http://schemas.openxmlformats.org/drawingml/2006/main">
               <a:ext uri="{FF2B5EF4-FFF2-40B4-BE49-F238E27FC236}">
-                <a16:creationId xmlns:a16="http://schemas.microsoft.com/office/drawing/2014/main" id="{2FDEAD87-B856-4599-BC68-F2B6FB6B8A95}"/>
+                <a16:creationId xmlns:a16="http://schemas.microsoft.com/office/drawing/2014/main" id="{0628CE53-947B-46BF-8D27-9EFA0BC82D7E}"/>
               </a:ext>
             </a:extLst>
           </p:cNvPr>
@@ -29186,7 +29186,7 @@
           <p:cNvPr id="9" name="">
             <a:extLst xmlns:a="http://schemas.openxmlformats.org/drawingml/2006/main">
               <a:ext uri="{FF2B5EF4-FFF2-40B4-BE49-F238E27FC236}">
-                <a16:creationId xmlns:a16="http://schemas.microsoft.com/office/drawing/2014/main" id="{409CB5C6-4CDB-4B07-A909-605287F374C2}"/>
+                <a16:creationId xmlns:a16="http://schemas.microsoft.com/office/drawing/2014/main" id="{8599B323-B231-49E4-8D76-FC16A952ABCB}"/>
               </a:ext>
             </a:extLst>
           </p:cNvPr>
@@ -29252,7 +29252,7 @@
           <p:cNvPr id="10" name="">
             <a:extLst xmlns:a="http://schemas.openxmlformats.org/drawingml/2006/main">
               <a:ext uri="{FF2B5EF4-FFF2-40B4-BE49-F238E27FC236}">
-                <a16:creationId xmlns:a16="http://schemas.microsoft.com/office/drawing/2014/main" id="{D6B52EC6-FFFB-4E87-A85D-E7F78F391D2C}"/>
+                <a16:creationId xmlns:a16="http://schemas.microsoft.com/office/drawing/2014/main" id="{96E31F57-5C27-4AB8-9991-6B3F995DDD94}"/>
               </a:ext>
             </a:extLst>
           </p:cNvPr>
@@ -29318,7 +29318,7 @@
           <p:cNvPr id="11" name="">
             <a:extLst xmlns:a="http://schemas.openxmlformats.org/drawingml/2006/main">
               <a:ext uri="{FF2B5EF4-FFF2-40B4-BE49-F238E27FC236}">
-                <a16:creationId xmlns:a16="http://schemas.microsoft.com/office/drawing/2014/main" id="{A6DDC1FA-3302-4E7B-AAD8-1C855575CA1F}"/>
+                <a16:creationId xmlns:a16="http://schemas.microsoft.com/office/drawing/2014/main" id="{F063020E-4D6E-4DAF-BA51-100D645CF490}"/>
               </a:ext>
             </a:extLst>
           </p:cNvPr>
@@ -29384,7 +29384,7 @@
           <p:cNvPr id="12" name="">
             <a:extLst xmlns:a="http://schemas.openxmlformats.org/drawingml/2006/main">
               <a:ext uri="{FF2B5EF4-FFF2-40B4-BE49-F238E27FC236}">
-                <a16:creationId xmlns:a16="http://schemas.microsoft.com/office/drawing/2014/main" id="{15019218-51F5-4309-98D9-595254023937}"/>
+                <a16:creationId xmlns:a16="http://schemas.microsoft.com/office/drawing/2014/main" id="{0F36140C-678C-4D45-8F62-C1F88635B4BC}"/>
               </a:ext>
             </a:extLst>
           </p:cNvPr>
@@ -29450,7 +29450,7 @@
           <p:cNvPr id="13" name="">
             <a:extLst xmlns:a="http://schemas.openxmlformats.org/drawingml/2006/main">
               <a:ext uri="{FF2B5EF4-FFF2-40B4-BE49-F238E27FC236}">
-                <a16:creationId xmlns:a16="http://schemas.microsoft.com/office/drawing/2014/main" id="{92A6058E-BE06-4CDE-BD12-C2A171128474}"/>
+                <a16:creationId xmlns:a16="http://schemas.microsoft.com/office/drawing/2014/main" id="{E5D2C133-834F-4DE7-A887-C68A9BFD28E9}"/>
               </a:ext>
             </a:extLst>
           </p:cNvPr>
@@ -29516,7 +29516,7 @@
           <p:cNvPr id="14" name="">
             <a:extLst xmlns:a="http://schemas.openxmlformats.org/drawingml/2006/main">
               <a:ext uri="{FF2B5EF4-FFF2-40B4-BE49-F238E27FC236}">
-                <a16:creationId xmlns:a16="http://schemas.microsoft.com/office/drawing/2014/main" id="{0734CD38-EE0D-4B2C-978A-D52C513C899C}"/>
+                <a16:creationId xmlns:a16="http://schemas.microsoft.com/office/drawing/2014/main" id="{1B33D2A4-BC16-46A1-8AA1-9ED2E785BE79}"/>
               </a:ext>
             </a:extLst>
           </p:cNvPr>
@@ -29582,7 +29582,7 @@
           <p:cNvPr id="15" name="">
             <a:extLst xmlns:a="http://schemas.openxmlformats.org/drawingml/2006/main">
               <a:ext uri="{FF2B5EF4-FFF2-40B4-BE49-F238E27FC236}">
-                <a16:creationId xmlns:a16="http://schemas.microsoft.com/office/drawing/2014/main" id="{8057D59A-81EF-463F-8987-8E835ADC32DA}"/>
+                <a16:creationId xmlns:a16="http://schemas.microsoft.com/office/drawing/2014/main" id="{6B25E713-F51E-4F96-976B-A9F16EEB2ECD}"/>
               </a:ext>
             </a:extLst>
           </p:cNvPr>
@@ -29648,7 +29648,7 @@
           <p:cNvPr id="16" name="">
             <a:extLst xmlns:a="http://schemas.openxmlformats.org/drawingml/2006/main">
               <a:ext uri="{FF2B5EF4-FFF2-40B4-BE49-F238E27FC236}">
-                <a16:creationId xmlns:a16="http://schemas.microsoft.com/office/drawing/2014/main" id="{66BB8EA5-511F-4584-9996-AA3E726200BD}"/>
+                <a16:creationId xmlns:a16="http://schemas.microsoft.com/office/drawing/2014/main" id="{B5E59A1A-F600-42F5-A421-AFDAF936CE52}"/>
               </a:ext>
             </a:extLst>
           </p:cNvPr>
@@ -29712,7 +29712,7 @@
     </p:spTree>
     <p:extLst>
       <p:ext uri="{BB962C8B-B14F-4D97-AF65-F5344CB8AC3E}">
-        <p14:creationId xmlns:p14="http://schemas.microsoft.com/office/powerpoint/2010/main" val="919557644"/>
+        <p14:creationId xmlns:p14="http://schemas.microsoft.com/office/powerpoint/2010/main" val="1444909152"/>
       </p:ext>
     </p:extLst>
   </p:cSld>
@@ -29743,7 +29743,7 @@
           <p:cNvPr id="17" name="">
             <a:extLst xmlns:a="http://schemas.openxmlformats.org/drawingml/2006/main">
               <a:ext uri="{FF2B5EF4-FFF2-40B4-BE49-F238E27FC236}">
-                <a16:creationId xmlns:a16="http://schemas.microsoft.com/office/drawing/2014/main" id="{574303A6-2425-4C20-9001-1F9D7B77C327}"/>
+                <a16:creationId xmlns:a16="http://schemas.microsoft.com/office/drawing/2014/main" id="{3B45BFEE-3B70-4A81-B4E9-C2C921ED8285}"/>
               </a:ext>
             </a:extLst>
           </p:cNvPr>
@@ -29809,7 +29809,7 @@
           <p:cNvPr id="2" name="">
             <a:extLst xmlns:a="http://schemas.openxmlformats.org/drawingml/2006/main">
               <a:ext uri="{FF2B5EF4-FFF2-40B4-BE49-F238E27FC236}">
-                <a16:creationId xmlns:a16="http://schemas.microsoft.com/office/drawing/2014/main" id="{3B298243-B7CC-4033-AA83-9D7F114DD20B}"/>
+                <a16:creationId xmlns:a16="http://schemas.microsoft.com/office/drawing/2014/main" id="{D9F47A1A-52A7-4185-84B8-8E4A614465AD}"/>
               </a:ext>
             </a:extLst>
           </p:cNvPr>
@@ -29875,7 +29875,7 @@
           <p:cNvPr id="3" name="">
             <a:extLst xmlns:a="http://schemas.openxmlformats.org/drawingml/2006/main">
               <a:ext uri="{FF2B5EF4-FFF2-40B4-BE49-F238E27FC236}">
-                <a16:creationId xmlns:a16="http://schemas.microsoft.com/office/drawing/2014/main" id="{18951779-74A2-49CA-B2A9-AAEFDE38CD08}"/>
+                <a16:creationId xmlns:a16="http://schemas.microsoft.com/office/drawing/2014/main" id="{7E5A944D-B7C7-46DB-A20E-661B300632FC}"/>
               </a:ext>
             </a:extLst>
           </p:cNvPr>
@@ -29907,7 +29907,7 @@
           <p:cNvPr id="4" name="">
             <a:extLst xmlns:a="http://schemas.openxmlformats.org/drawingml/2006/main">
               <a:ext uri="{FF2B5EF4-FFF2-40B4-BE49-F238E27FC236}">
-                <a16:creationId xmlns:a16="http://schemas.microsoft.com/office/drawing/2014/main" id="{2428F707-F0FC-4E99-82EE-84293A6B814E}"/>
+                <a16:creationId xmlns:a16="http://schemas.microsoft.com/office/drawing/2014/main" id="{B940B46D-508D-4E54-9EE9-CF3D37B3C4D9}"/>
               </a:ext>
             </a:extLst>
           </p:cNvPr>
@@ -29941,7 +29941,7 @@
           <p:cNvPr id="5" name="">
             <a:extLst xmlns:a="http://schemas.openxmlformats.org/drawingml/2006/main">
               <a:ext uri="{FF2B5EF4-FFF2-40B4-BE49-F238E27FC236}">
-                <a16:creationId xmlns:a16="http://schemas.microsoft.com/office/drawing/2014/main" id="{2AED5B46-4404-4EA8-A299-7EE15DC3814E}"/>
+                <a16:creationId xmlns:a16="http://schemas.microsoft.com/office/drawing/2014/main" id="{CCE949F8-DB9B-42FD-9684-F5CC6BB18254}"/>
               </a:ext>
             </a:extLst>
           </p:cNvPr>
@@ -30007,7 +30007,7 @@
           <p:cNvPr id="6" name="">
             <a:extLst xmlns:a="http://schemas.openxmlformats.org/drawingml/2006/main">
               <a:ext uri="{FF2B5EF4-FFF2-40B4-BE49-F238E27FC236}">
-                <a16:creationId xmlns:a16="http://schemas.microsoft.com/office/drawing/2014/main" id="{1ADF991A-55EA-44E3-8383-E039A01B7BF3}"/>
+                <a16:creationId xmlns:a16="http://schemas.microsoft.com/office/drawing/2014/main" id="{92CD9B7E-3755-4E8D-99FA-5D6B365AF1B5}"/>
               </a:ext>
             </a:extLst>
           </p:cNvPr>
@@ -30041,7 +30041,7 @@
           <p:cNvPr id="7" name="">
             <a:extLst xmlns:a="http://schemas.openxmlformats.org/drawingml/2006/main">
               <a:ext uri="{FF2B5EF4-FFF2-40B4-BE49-F238E27FC236}">
-                <a16:creationId xmlns:a16="http://schemas.microsoft.com/office/drawing/2014/main" id="{FEA244B2-951C-4F70-9839-D29A4F961091}"/>
+                <a16:creationId xmlns:a16="http://schemas.microsoft.com/office/drawing/2014/main" id="{8D667AC6-2AD3-42DB-851D-76A9372D295E}"/>
               </a:ext>
             </a:extLst>
           </p:cNvPr>
@@ -30107,7 +30107,7 @@
           <p:cNvPr id="8" name="">
             <a:extLst xmlns:a="http://schemas.openxmlformats.org/drawingml/2006/main">
               <a:ext uri="{FF2B5EF4-FFF2-40B4-BE49-F238E27FC236}">
-                <a16:creationId xmlns:a16="http://schemas.microsoft.com/office/drawing/2014/main" id="{4B8B405A-4510-4032-BCBD-1C3846723EB5}"/>
+                <a16:creationId xmlns:a16="http://schemas.microsoft.com/office/drawing/2014/main" id="{3E1DF113-39A7-494B-8AD2-878F73F24D34}"/>
               </a:ext>
             </a:extLst>
           </p:cNvPr>
@@ -30141,7 +30141,7 @@
           <p:cNvPr id="9" name="">
             <a:extLst xmlns:a="http://schemas.openxmlformats.org/drawingml/2006/main">
               <a:ext uri="{FF2B5EF4-FFF2-40B4-BE49-F238E27FC236}">
-                <a16:creationId xmlns:a16="http://schemas.microsoft.com/office/drawing/2014/main" id="{5714A938-4B11-41E4-8357-53FE38EB7C3F}"/>
+                <a16:creationId xmlns:a16="http://schemas.microsoft.com/office/drawing/2014/main" id="{FC32FCE9-D3AD-4C44-8157-C75185C6D2C2}"/>
               </a:ext>
             </a:extLst>
           </p:cNvPr>
@@ -30207,7 +30207,7 @@
           <p:cNvPr id="10" name="">
             <a:extLst xmlns:a="http://schemas.openxmlformats.org/drawingml/2006/main">
               <a:ext uri="{FF2B5EF4-FFF2-40B4-BE49-F238E27FC236}">
-                <a16:creationId xmlns:a16="http://schemas.microsoft.com/office/drawing/2014/main" id="{FD7F8F5A-8A41-49BB-96B4-B51BD538B363}"/>
+                <a16:creationId xmlns:a16="http://schemas.microsoft.com/office/drawing/2014/main" id="{4903DD99-67D8-4A8A-B0D8-71C9537DC452}"/>
               </a:ext>
             </a:extLst>
           </p:cNvPr>
@@ -30273,7 +30273,7 @@
           <p:cNvPr id="11" name="">
             <a:extLst xmlns:a="http://schemas.openxmlformats.org/drawingml/2006/main">
               <a:ext uri="{FF2B5EF4-FFF2-40B4-BE49-F238E27FC236}">
-                <a16:creationId xmlns:a16="http://schemas.microsoft.com/office/drawing/2014/main" id="{EE9C8E64-9EE1-4513-BB25-DF2F87215C3C}"/>
+                <a16:creationId xmlns:a16="http://schemas.microsoft.com/office/drawing/2014/main" id="{FA34EC94-5129-48B6-B6C5-3B4921CA7F6C}"/>
               </a:ext>
             </a:extLst>
           </p:cNvPr>
@@ -30339,7 +30339,7 @@
           <p:cNvPr id="12" name="">
             <a:extLst xmlns:a="http://schemas.openxmlformats.org/drawingml/2006/main">
               <a:ext uri="{FF2B5EF4-FFF2-40B4-BE49-F238E27FC236}">
-                <a16:creationId xmlns:a16="http://schemas.microsoft.com/office/drawing/2014/main" id="{9E94AAC4-A326-459F-8931-03E2263B1F30}"/>
+                <a16:creationId xmlns:a16="http://schemas.microsoft.com/office/drawing/2014/main" id="{0F989D63-03B0-4B23-905C-1E6E5BF1B017}"/>
               </a:ext>
             </a:extLst>
           </p:cNvPr>
@@ -30405,7 +30405,7 @@
           <p:cNvPr id="13" name="">
             <a:extLst xmlns:a="http://schemas.openxmlformats.org/drawingml/2006/main">
               <a:ext uri="{FF2B5EF4-FFF2-40B4-BE49-F238E27FC236}">
-                <a16:creationId xmlns:a16="http://schemas.microsoft.com/office/drawing/2014/main" id="{55855024-D8B5-4E61-832C-63AE3618053F}"/>
+                <a16:creationId xmlns:a16="http://schemas.microsoft.com/office/drawing/2014/main" id="{90134526-9876-4DDA-AEC1-B1C12585C98B}"/>
               </a:ext>
             </a:extLst>
           </p:cNvPr>
@@ -30471,7 +30471,7 @@
           <p:cNvPr id="14" name="">
             <a:extLst xmlns:a="http://schemas.openxmlformats.org/drawingml/2006/main">
               <a:ext uri="{FF2B5EF4-FFF2-40B4-BE49-F238E27FC236}">
-                <a16:creationId xmlns:a16="http://schemas.microsoft.com/office/drawing/2014/main" id="{3C7A4C81-76E3-414A-9467-8882F3A131D2}"/>
+                <a16:creationId xmlns:a16="http://schemas.microsoft.com/office/drawing/2014/main" id="{69DB8183-4AFC-400D-9CE3-8F9C15CD2012}"/>
               </a:ext>
             </a:extLst>
           </p:cNvPr>
@@ -30537,7 +30537,7 @@
           <p:cNvPr id="15" name="">
             <a:extLst xmlns:a="http://schemas.openxmlformats.org/drawingml/2006/main">
               <a:ext uri="{FF2B5EF4-FFF2-40B4-BE49-F238E27FC236}">
-                <a16:creationId xmlns:a16="http://schemas.microsoft.com/office/drawing/2014/main" id="{C55BA9A0-6ED6-481B-BDC2-D519AB7A35F1}"/>
+                <a16:creationId xmlns:a16="http://schemas.microsoft.com/office/drawing/2014/main" id="{5FE81F16-EC4C-41A6-8FD4-DB779C3D7117}"/>
               </a:ext>
             </a:extLst>
           </p:cNvPr>
@@ -30603,7 +30603,7 @@
           <p:cNvPr id="16" name="">
             <a:extLst xmlns:a="http://schemas.openxmlformats.org/drawingml/2006/main">
               <a:ext uri="{FF2B5EF4-FFF2-40B4-BE49-F238E27FC236}">
-                <a16:creationId xmlns:a16="http://schemas.microsoft.com/office/drawing/2014/main" id="{97990596-AF57-4A17-A337-5636DEB10C90}"/>
+                <a16:creationId xmlns:a16="http://schemas.microsoft.com/office/drawing/2014/main" id="{BF1D3F88-1999-441A-86BB-F1A4CE0BBC35}"/>
               </a:ext>
             </a:extLst>
           </p:cNvPr>
@@ -30667,7 +30667,7 @@
     </p:spTree>
     <p:extLst>
       <p:ext uri="{BB962C8B-B14F-4D97-AF65-F5344CB8AC3E}">
-        <p14:creationId xmlns:p14="http://schemas.microsoft.com/office/powerpoint/2010/main" val="1900491005"/>
+        <p14:creationId xmlns:p14="http://schemas.microsoft.com/office/powerpoint/2010/main" val="420595018"/>
       </p:ext>
     </p:extLst>
   </p:cSld>
@@ -30698,7 +30698,7 @@
           <p:cNvPr id="21" name="">
             <a:extLst xmlns:a="http://schemas.openxmlformats.org/drawingml/2006/main">
               <a:ext uri="{FF2B5EF4-FFF2-40B4-BE49-F238E27FC236}">
-                <a16:creationId xmlns:a16="http://schemas.microsoft.com/office/drawing/2014/main" id="{E52943DC-85E9-4AC1-A8C8-6AC479E2CB7B}"/>
+                <a16:creationId xmlns:a16="http://schemas.microsoft.com/office/drawing/2014/main" id="{4051AF54-A394-4240-9528-5BD02BD1D159}"/>
               </a:ext>
             </a:extLst>
           </p:cNvPr>
@@ -30764,7 +30764,7 @@
           <p:cNvPr id="2" name="">
             <a:extLst xmlns:a="http://schemas.openxmlformats.org/drawingml/2006/main">
               <a:ext uri="{FF2B5EF4-FFF2-40B4-BE49-F238E27FC236}">
-                <a16:creationId xmlns:a16="http://schemas.microsoft.com/office/drawing/2014/main" id="{36A84123-98EC-4467-A642-39AFFD496408}"/>
+                <a16:creationId xmlns:a16="http://schemas.microsoft.com/office/drawing/2014/main" id="{25E51520-6541-443E-9C30-B5C6B410AB5A}"/>
               </a:ext>
             </a:extLst>
           </p:cNvPr>
@@ -30830,7 +30830,7 @@
           <p:cNvPr id="3" name="">
             <a:extLst xmlns:a="http://schemas.openxmlformats.org/drawingml/2006/main">
               <a:ext uri="{FF2B5EF4-FFF2-40B4-BE49-F238E27FC236}">
-                <a16:creationId xmlns:a16="http://schemas.microsoft.com/office/drawing/2014/main" id="{5B3ED93C-88E9-44C5-AC9F-F8FC7B40106A}"/>
+                <a16:creationId xmlns:a16="http://schemas.microsoft.com/office/drawing/2014/main" id="{0CAEE80B-393B-49FF-978C-D9BF4B92E8F0}"/>
               </a:ext>
             </a:extLst>
           </p:cNvPr>
@@ -30862,7 +30862,7 @@
           <p:cNvPr id="4" name="">
             <a:extLst xmlns:a="http://schemas.openxmlformats.org/drawingml/2006/main">
               <a:ext uri="{FF2B5EF4-FFF2-40B4-BE49-F238E27FC236}">
-                <a16:creationId xmlns:a16="http://schemas.microsoft.com/office/drawing/2014/main" id="{94C674E0-C05D-43D2-90E6-77E418E9B701}"/>
+                <a16:creationId xmlns:a16="http://schemas.microsoft.com/office/drawing/2014/main" id="{984A6244-C0A6-4B6D-8086-4B7869964A68}"/>
               </a:ext>
             </a:extLst>
           </p:cNvPr>
@@ -30894,7 +30894,7 @@
           <p:cNvPr id="5" name="">
             <a:extLst xmlns:a="http://schemas.openxmlformats.org/drawingml/2006/main">
               <a:ext uri="{FF2B5EF4-FFF2-40B4-BE49-F238E27FC236}">
-                <a16:creationId xmlns:a16="http://schemas.microsoft.com/office/drawing/2014/main" id="{B97AA2F0-E895-4EF7-A6B3-25D416E4A281}"/>
+                <a16:creationId xmlns:a16="http://schemas.microsoft.com/office/drawing/2014/main" id="{A567042E-22BD-44C8-B544-14AAC100EBDB}"/>
               </a:ext>
             </a:extLst>
           </p:cNvPr>
@@ -30926,7 +30926,7 @@
           <p:cNvPr id="6" name="">
             <a:extLst xmlns:a="http://schemas.openxmlformats.org/drawingml/2006/main">
               <a:ext uri="{FF2B5EF4-FFF2-40B4-BE49-F238E27FC236}">
-                <a16:creationId xmlns:a16="http://schemas.microsoft.com/office/drawing/2014/main" id="{BB67DE55-8FC7-4EA9-BFBD-586B113D127D}"/>
+                <a16:creationId xmlns:a16="http://schemas.microsoft.com/office/drawing/2014/main" id="{55CABBDE-AD19-4D61-AB3E-94044C2C6C64}"/>
               </a:ext>
             </a:extLst>
           </p:cNvPr>
@@ -30992,7 +30992,7 @@
           <p:cNvPr id="7" name="">
             <a:extLst xmlns:a="http://schemas.openxmlformats.org/drawingml/2006/main">
               <a:ext uri="{FF2B5EF4-FFF2-40B4-BE49-F238E27FC236}">
-                <a16:creationId xmlns:a16="http://schemas.microsoft.com/office/drawing/2014/main" id="{A0F65A6A-3C01-4BA6-8447-1125C9257478}"/>
+                <a16:creationId xmlns:a16="http://schemas.microsoft.com/office/drawing/2014/main" id="{BE4AA7B2-F541-45C2-A954-3EF4033826B4}"/>
               </a:ext>
             </a:extLst>
           </p:cNvPr>
@@ -31058,7 +31058,7 @@
           <p:cNvPr id="8" name="">
             <a:extLst xmlns:a="http://schemas.openxmlformats.org/drawingml/2006/main">
               <a:ext uri="{FF2B5EF4-FFF2-40B4-BE49-F238E27FC236}">
-                <a16:creationId xmlns:a16="http://schemas.microsoft.com/office/drawing/2014/main" id="{0659D6DC-C649-4D03-802B-7595E0475EE6}"/>
+                <a16:creationId xmlns:a16="http://schemas.microsoft.com/office/drawing/2014/main" id="{0C25EE4F-90ED-4802-AB10-8D8770828B8D}"/>
               </a:ext>
             </a:extLst>
           </p:cNvPr>
@@ -31090,7 +31090,7 @@
           <p:cNvPr id="9" name="">
             <a:extLst xmlns:a="http://schemas.openxmlformats.org/drawingml/2006/main">
               <a:ext uri="{FF2B5EF4-FFF2-40B4-BE49-F238E27FC236}">
-                <a16:creationId xmlns:a16="http://schemas.microsoft.com/office/drawing/2014/main" id="{B9C6CB3A-2385-43DD-9483-ABDBF01A7FC5}"/>
+                <a16:creationId xmlns:a16="http://schemas.microsoft.com/office/drawing/2014/main" id="{5C626A72-EC10-4113-B379-8CF681A44DAC}"/>
               </a:ext>
             </a:extLst>
           </p:cNvPr>
@@ -31156,7 +31156,7 @@
           <p:cNvPr id="10" name="">
             <a:extLst xmlns:a="http://schemas.openxmlformats.org/drawingml/2006/main">
               <a:ext uri="{FF2B5EF4-FFF2-40B4-BE49-F238E27FC236}">
-                <a16:creationId xmlns:a16="http://schemas.microsoft.com/office/drawing/2014/main" id="{C88A6D0C-068D-4F3F-AEDB-00290CDDB64D}"/>
+                <a16:creationId xmlns:a16="http://schemas.microsoft.com/office/drawing/2014/main" id="{95747040-F0AB-43AA-8FB9-B254AA551EC9}"/>
               </a:ext>
             </a:extLst>
           </p:cNvPr>
@@ -31222,7 +31222,7 @@
           <p:cNvPr id="11" name="">
             <a:extLst xmlns:a="http://schemas.openxmlformats.org/drawingml/2006/main">
               <a:ext uri="{FF2B5EF4-FFF2-40B4-BE49-F238E27FC236}">
-                <a16:creationId xmlns:a16="http://schemas.microsoft.com/office/drawing/2014/main" id="{AA8B732A-38D1-4037-A2DD-A84685BDAA83}"/>
+                <a16:creationId xmlns:a16="http://schemas.microsoft.com/office/drawing/2014/main" id="{C52E17F5-89A4-4EB7-BF2D-08BD67A6FB84}"/>
               </a:ext>
             </a:extLst>
           </p:cNvPr>
@@ -31254,7 +31254,7 @@
           <p:cNvPr id="12" name="">
             <a:extLst xmlns:a="http://schemas.openxmlformats.org/drawingml/2006/main">
               <a:ext uri="{FF2B5EF4-FFF2-40B4-BE49-F238E27FC236}">
-                <a16:creationId xmlns:a16="http://schemas.microsoft.com/office/drawing/2014/main" id="{68A88135-936B-41C3-9C29-235000472E74}"/>
+                <a16:creationId xmlns:a16="http://schemas.microsoft.com/office/drawing/2014/main" id="{74F8EB93-B3FA-40F2-BF2C-267C92BAEE33}"/>
               </a:ext>
             </a:extLst>
           </p:cNvPr>
@@ -31320,7 +31320,7 @@
           <p:cNvPr id="13" name="">
             <a:extLst xmlns:a="http://schemas.openxmlformats.org/drawingml/2006/main">
               <a:ext uri="{FF2B5EF4-FFF2-40B4-BE49-F238E27FC236}">
-                <a16:creationId xmlns:a16="http://schemas.microsoft.com/office/drawing/2014/main" id="{2526B712-7AFC-474B-A2F5-42BCF5BB7759}"/>
+                <a16:creationId xmlns:a16="http://schemas.microsoft.com/office/drawing/2014/main" id="{7D8B6809-20FB-43B0-A622-1CA192C69B6E}"/>
               </a:ext>
             </a:extLst>
           </p:cNvPr>
@@ -31386,7 +31386,7 @@
           <p:cNvPr id="14" name="">
             <a:extLst xmlns:a="http://schemas.openxmlformats.org/drawingml/2006/main">
               <a:ext uri="{FF2B5EF4-FFF2-40B4-BE49-F238E27FC236}">
-                <a16:creationId xmlns:a16="http://schemas.microsoft.com/office/drawing/2014/main" id="{B1C59D39-E418-4F39-AB7C-BD51C66B22F5}"/>
+                <a16:creationId xmlns:a16="http://schemas.microsoft.com/office/drawing/2014/main" id="{28C51447-552F-4943-AF50-5320E831EA09}"/>
               </a:ext>
             </a:extLst>
           </p:cNvPr>
@@ -31452,7 +31452,7 @@
           <p:cNvPr id="15" name="">
             <a:extLst xmlns:a="http://schemas.openxmlformats.org/drawingml/2006/main">
               <a:ext uri="{FF2B5EF4-FFF2-40B4-BE49-F238E27FC236}">
-                <a16:creationId xmlns:a16="http://schemas.microsoft.com/office/drawing/2014/main" id="{48E5FEC6-9F57-412C-A492-FDA3A793F7E0}"/>
+                <a16:creationId xmlns:a16="http://schemas.microsoft.com/office/drawing/2014/main" id="{E4E8B241-8B9F-4FDC-B5B6-338FB3452646}"/>
               </a:ext>
             </a:extLst>
           </p:cNvPr>
@@ -31518,7 +31518,7 @@
           <p:cNvPr id="16" name="">
             <a:extLst xmlns:a="http://schemas.openxmlformats.org/drawingml/2006/main">
               <a:ext uri="{FF2B5EF4-FFF2-40B4-BE49-F238E27FC236}">
-                <a16:creationId xmlns:a16="http://schemas.microsoft.com/office/drawing/2014/main" id="{7E121BFC-8043-4B38-A410-4D9862260A6F}"/>
+                <a16:creationId xmlns:a16="http://schemas.microsoft.com/office/drawing/2014/main" id="{36C6B24E-4371-4561-B353-B53047ADF07F}"/>
               </a:ext>
             </a:extLst>
           </p:cNvPr>
@@ -31584,7 +31584,7 @@
           <p:cNvPr id="17" name="">
             <a:extLst xmlns:a="http://schemas.openxmlformats.org/drawingml/2006/main">
               <a:ext uri="{FF2B5EF4-FFF2-40B4-BE49-F238E27FC236}">
-                <a16:creationId xmlns:a16="http://schemas.microsoft.com/office/drawing/2014/main" id="{BBEBAE87-4612-469B-BB02-A67F12191DF4}"/>
+                <a16:creationId xmlns:a16="http://schemas.microsoft.com/office/drawing/2014/main" id="{194AF9BF-CF32-40D7-9511-014DDBAC36D5}"/>
               </a:ext>
             </a:extLst>
           </p:cNvPr>
@@ -31650,7 +31650,7 @@
           <p:cNvPr id="18" name="">
             <a:extLst xmlns:a="http://schemas.openxmlformats.org/drawingml/2006/main">
               <a:ext uri="{FF2B5EF4-FFF2-40B4-BE49-F238E27FC236}">
-                <a16:creationId xmlns:a16="http://schemas.microsoft.com/office/drawing/2014/main" id="{BE80811A-90DB-4BA7-92E1-BCCBA740227B}"/>
+                <a16:creationId xmlns:a16="http://schemas.microsoft.com/office/drawing/2014/main" id="{A0D8BA2A-4953-4407-91BB-F7D923A7ED0F}"/>
               </a:ext>
             </a:extLst>
           </p:cNvPr>
@@ -31716,7 +31716,7 @@
           <p:cNvPr id="19" name="">
             <a:extLst xmlns:a="http://schemas.openxmlformats.org/drawingml/2006/main">
               <a:ext uri="{FF2B5EF4-FFF2-40B4-BE49-F238E27FC236}">
-                <a16:creationId xmlns:a16="http://schemas.microsoft.com/office/drawing/2014/main" id="{879F5DB3-9A0A-44BC-B06F-55660CF8BB65}"/>
+                <a16:creationId xmlns:a16="http://schemas.microsoft.com/office/drawing/2014/main" id="{92A54558-999E-4EF5-BA62-814A718DA1EF}"/>
               </a:ext>
             </a:extLst>
           </p:cNvPr>
@@ -31782,7 +31782,7 @@
           <p:cNvPr id="20" name="">
             <a:extLst xmlns:a="http://schemas.openxmlformats.org/drawingml/2006/main">
               <a:ext uri="{FF2B5EF4-FFF2-40B4-BE49-F238E27FC236}">
-                <a16:creationId xmlns:a16="http://schemas.microsoft.com/office/drawing/2014/main" id="{981B5E33-6DFF-467A-878E-BEC508861C34}"/>
+                <a16:creationId xmlns:a16="http://schemas.microsoft.com/office/drawing/2014/main" id="{69EF2B1D-5CE8-4FF7-9F3B-0D61050962BA}"/>
               </a:ext>
             </a:extLst>
           </p:cNvPr>
@@ -31846,7 +31846,7 @@
     </p:spTree>
     <p:extLst>
       <p:ext uri="{BB962C8B-B14F-4D97-AF65-F5344CB8AC3E}">
-        <p14:creationId xmlns:p14="http://schemas.microsoft.com/office/powerpoint/2010/main" val="693125853"/>
+        <p14:creationId xmlns:p14="http://schemas.microsoft.com/office/powerpoint/2010/main" val="1873368640"/>
       </p:ext>
     </p:extLst>
   </p:cSld>

</xml_diff>